<commit_message>
Optimize PPT builder: fix hardcoded cover, add 7 slide types, custom themes, text auto-fit
</commit_message>
<xml_diff>
--- a/dist/hello-world-codex.pptx
+++ b/dist/hello-world-codex.pptx
@@ -2,114 +2,19 @@
 <file path=ppt/presentation.xml><?xml version="1.0" encoding="utf-8"?>
 <p:presentation xmlns:p="http://schemas.openxmlformats.org/presentationml/2006/main">
   <p:sldMasterIdLst>
-    <p:sldMasterId xmlns:r="http://schemas.openxmlformats.org/officeDocument/2006/relationships" id="2147483648" r:id="Rac0bd7cf32ce4959"/>
+    <p:sldMasterId xmlns:r="http://schemas.openxmlformats.org/officeDocument/2006/relationships" id="2147483648" r:id="R23823b8260a44619"/>
   </p:sldMasterIdLst>
   <p:notesMasterIdLst>
-    <p:notesMasterId xmlns:r="http://schemas.openxmlformats.org/officeDocument/2006/relationships" r:id="R5076088945f54625"/>
+    <p:notesMasterId xmlns:r="http://schemas.openxmlformats.org/officeDocument/2006/relationships" r:id="Rdab26d221cfd49f0"/>
   </p:notesMasterIdLst>
   <p:sldIdLst>
-    <p:sldId xmlns:r="http://schemas.openxmlformats.org/officeDocument/2006/relationships" id="256" r:id="Re405e58d4ab046c5"/>
-    <p:sldId xmlns:r="http://schemas.openxmlformats.org/officeDocument/2006/relationships" id="257" r:id="R73b08b4362af4c8f"/>
-    <p:sldId xmlns:r="http://schemas.openxmlformats.org/officeDocument/2006/relationships" id="258" r:id="R966a9e15e1f04ebe"/>
-    <p:sldId xmlns:r="http://schemas.openxmlformats.org/officeDocument/2006/relationships" id="259" r:id="R3f70c522becc4e8c"/>
+    <p:sldId xmlns:r="http://schemas.openxmlformats.org/officeDocument/2006/relationships" id="256" r:id="Rbaa317cb4d4043cb"/>
+    <p:sldId xmlns:r="http://schemas.openxmlformats.org/officeDocument/2006/relationships" id="257" r:id="R96a1242828474497"/>
+    <p:sldId xmlns:r="http://schemas.openxmlformats.org/officeDocument/2006/relationships" id="258" r:id="R7626ea79af404815"/>
+    <p:sldId xmlns:r="http://schemas.openxmlformats.org/officeDocument/2006/relationships" id="259" r:id="Rad5b628886644fe5"/>
   </p:sldIdLst>
   <p:sldSz cx="12192000" cy="6858000"/>
   <p:notesSz cx="6858000" cy="9144000"/>
-  <p:defaultTextStyle>
-    <a:defPPr xmlns:a="http://schemas.openxmlformats.org/drawingml/2006/main">
-      <a:defRPr lang="en-US"/>
-    </a:defPPr>
-    <a:lvl1pPr xmlns:a="http://schemas.openxmlformats.org/drawingml/2006/main" marL="0" indent="0" algn="l" defTabSz="914400">
-      <a:defRPr sz="1800" kern="1200">
-        <a:solidFill>
-          <a:schemeClr val="tx1"/>
-        </a:solidFill>
-        <a:latin typeface="+mn-lt"/>
-        <a:ea typeface="+mn-ea"/>
-        <a:cs typeface="+mn-cs"/>
-      </a:defRPr>
-    </a:lvl1pPr>
-    <a:lvl2pPr xmlns:a="http://schemas.openxmlformats.org/drawingml/2006/main" marL="457200" indent="0" algn="l" defTabSz="914400">
-      <a:defRPr sz="1800" kern="1200">
-        <a:solidFill>
-          <a:schemeClr val="tx1"/>
-        </a:solidFill>
-        <a:latin typeface="+mn-lt"/>
-        <a:ea typeface="+mn-ea"/>
-        <a:cs typeface="+mn-cs"/>
-      </a:defRPr>
-    </a:lvl2pPr>
-    <a:lvl3pPr xmlns:a="http://schemas.openxmlformats.org/drawingml/2006/main" marL="914400" indent="0" algn="l" defTabSz="914400">
-      <a:defRPr sz="1800" kern="1200">
-        <a:solidFill>
-          <a:schemeClr val="tx1"/>
-        </a:solidFill>
-        <a:latin typeface="+mn-lt"/>
-        <a:ea typeface="+mn-ea"/>
-        <a:cs typeface="+mn-cs"/>
-      </a:defRPr>
-    </a:lvl3pPr>
-    <a:lvl4pPr xmlns:a="http://schemas.openxmlformats.org/drawingml/2006/main" marL="1371600" indent="0" algn="l" defTabSz="914400">
-      <a:defRPr sz="1800" kern="1200">
-        <a:solidFill>
-          <a:schemeClr val="tx1"/>
-        </a:solidFill>
-        <a:latin typeface="+mn-lt"/>
-        <a:ea typeface="+mn-ea"/>
-        <a:cs typeface="+mn-cs"/>
-      </a:defRPr>
-    </a:lvl4pPr>
-    <a:lvl5pPr xmlns:a="http://schemas.openxmlformats.org/drawingml/2006/main" marL="1828800" indent="0" algn="l" defTabSz="914400">
-      <a:defRPr sz="1800" kern="1200">
-        <a:solidFill>
-          <a:schemeClr val="tx1"/>
-        </a:solidFill>
-        <a:latin typeface="+mn-lt"/>
-        <a:ea typeface="+mn-ea"/>
-        <a:cs typeface="+mn-cs"/>
-      </a:defRPr>
-    </a:lvl5pPr>
-    <a:lvl6pPr xmlns:a="http://schemas.openxmlformats.org/drawingml/2006/main" marL="2286000" indent="0" algn="l" defTabSz="914400">
-      <a:defRPr sz="1800" kern="1200">
-        <a:solidFill>
-          <a:schemeClr val="tx1"/>
-        </a:solidFill>
-        <a:latin typeface="+mn-lt"/>
-        <a:ea typeface="+mn-ea"/>
-        <a:cs typeface="+mn-cs"/>
-      </a:defRPr>
-    </a:lvl6pPr>
-    <a:lvl7pPr xmlns:a="http://schemas.openxmlformats.org/drawingml/2006/main" marL="2743200" indent="0" algn="l" defTabSz="914400">
-      <a:defRPr sz="1800" kern="1200">
-        <a:solidFill>
-          <a:schemeClr val="tx1"/>
-        </a:solidFill>
-        <a:latin typeface="+mn-lt"/>
-        <a:ea typeface="+mn-ea"/>
-        <a:cs typeface="+mn-cs"/>
-      </a:defRPr>
-    </a:lvl7pPr>
-    <a:lvl8pPr xmlns:a="http://schemas.openxmlformats.org/drawingml/2006/main" marL="3200400" indent="0" algn="l" defTabSz="914400">
-      <a:defRPr sz="1800" kern="1200">
-        <a:solidFill>
-          <a:schemeClr val="tx1"/>
-        </a:solidFill>
-        <a:latin typeface="+mn-lt"/>
-        <a:ea typeface="+mn-ea"/>
-        <a:cs typeface="+mn-cs"/>
-      </a:defRPr>
-    </a:lvl8pPr>
-    <a:lvl9pPr xmlns:a="http://schemas.openxmlformats.org/drawingml/2006/main" marL="3657600" indent="0" algn="l" defTabSz="914400">
-      <a:defRPr sz="1800" kern="1200">
-        <a:solidFill>
-          <a:schemeClr val="tx1"/>
-        </a:solidFill>
-        <a:latin typeface="+mn-lt"/>
-        <a:ea typeface="+mn-ea"/>
-        <a:cs typeface="+mn-cs"/>
-      </a:defRPr>
-    </a:lvl9pPr>
-  </p:defaultTextStyle>
 </p:presentation>
 </file>
 
@@ -313,12 +218,58 @@
         <a:solidFill>
           <a:schemeClr val="phClr"/>
         </a:solidFill>
-        <a:solidFill>
-          <a:schemeClr val="dk1"/>
-        </a:solidFill>
-        <a:solidFill>
-          <a:schemeClr val="accent1"/>
-        </a:solidFill>
+        <a:gradFill>
+          <a:gsLst>
+            <a:gs pos="0">
+              <a:schemeClr val="phClr">
+                <a:tint val="67000"/>
+                <a:lumMod val="110000"/>
+                <a:satMod val="105000"/>
+              </a:schemeClr>
+            </a:gs>
+            <a:gs pos="50000">
+              <a:schemeClr val="phClr">
+                <a:tint val="73000"/>
+                <a:lumMod val="105000"/>
+                <a:satMod val="103000"/>
+              </a:schemeClr>
+            </a:gs>
+            <a:gs pos="100000">
+              <a:schemeClr val="phClr">
+                <a:tint val="81000"/>
+                <a:lumMod val="105000"/>
+                <a:satMod val="109000"/>
+              </a:schemeClr>
+            </a:gs>
+          </a:gsLst>
+          <a:lin ang="5400000" scaled="0"/>
+        </a:gradFill>
+        <a:gradFill>
+          <a:gsLst>
+            <a:gs pos="0">
+              <a:schemeClr val="phClr">
+                <a:tint val="94000"/>
+                <a:lumMod val="102000"/>
+                <a:satMod val="103000"/>
+              </a:schemeClr>
+            </a:gs>
+            <a:gs pos="50000">
+              <a:schemeClr val="phClr">
+                <a:shade val="100000"/>
+                <a:lumMod val="100000"/>
+                <a:satMod val="110000"/>
+              </a:schemeClr>
+            </a:gs>
+            <a:gs pos="100000">
+              <a:schemeClr val="phClr">
+                <a:shade val="78000"/>
+                <a:lumMod val="99000"/>
+                <a:satMod val="120000"/>
+              </a:schemeClr>
+            </a:gs>
+          </a:gsLst>
+          <a:lin ang="5400000" scaled="0"/>
+        </a:gradFill>
       </a:fillStyleLst>
       <a:lnStyleLst>
         <a:ln w="12700">
@@ -756,7 +707,7 @@
   </p:cSld>
   <p:clrMap bg1="lt1" tx1="dk1" bg2="lt2" tx2="dk2" accent1="accent1" accent2="accent2" accent3="accent3" accent4="accent4" accent5="accent5" accent6="accent6" hlink="hlink" folHlink="folHlink"/>
   <p:sldLayoutIdLst>
-    <p:sldLayoutId xmlns:r="http://schemas.openxmlformats.org/officeDocument/2006/relationships" id="2147483649" r:id="R28465d33dc3f474d"/>
+    <p:sldLayoutId xmlns:r="http://schemas.openxmlformats.org/officeDocument/2006/relationships" id="2147483649" r:id="Rc38bf278c80b47fb"/>
   </p:sldLayoutIdLst>
   <p:txStyles>
     <p:titleStyle>
@@ -1096,12 +1047,58 @@
         <a:solidFill>
           <a:schemeClr val="phClr"/>
         </a:solidFill>
-        <a:solidFill>
-          <a:schemeClr val="dk1"/>
-        </a:solidFill>
-        <a:solidFill>
-          <a:schemeClr val="accent1"/>
-        </a:solidFill>
+        <a:gradFill>
+          <a:gsLst>
+            <a:gs pos="0">
+              <a:schemeClr val="phClr">
+                <a:tint val="67000"/>
+                <a:lumMod val="110000"/>
+                <a:satMod val="105000"/>
+              </a:schemeClr>
+            </a:gs>
+            <a:gs pos="50000">
+              <a:schemeClr val="phClr">
+                <a:tint val="73000"/>
+                <a:lumMod val="105000"/>
+                <a:satMod val="103000"/>
+              </a:schemeClr>
+            </a:gs>
+            <a:gs pos="100000">
+              <a:schemeClr val="phClr">
+                <a:tint val="81000"/>
+                <a:lumMod val="105000"/>
+                <a:satMod val="109000"/>
+              </a:schemeClr>
+            </a:gs>
+          </a:gsLst>
+          <a:lin ang="5400000" scaled="0"/>
+        </a:gradFill>
+        <a:gradFill>
+          <a:gsLst>
+            <a:gs pos="0">
+              <a:schemeClr val="phClr">
+                <a:tint val="94000"/>
+                <a:lumMod val="102000"/>
+                <a:satMod val="103000"/>
+              </a:schemeClr>
+            </a:gs>
+            <a:gs pos="50000">
+              <a:schemeClr val="phClr">
+                <a:shade val="100000"/>
+                <a:lumMod val="100000"/>
+                <a:satMod val="110000"/>
+              </a:schemeClr>
+            </a:gs>
+            <a:gs pos="100000">
+              <a:schemeClr val="phClr">
+                <a:shade val="78000"/>
+                <a:lumMod val="99000"/>
+                <a:satMod val="120000"/>
+              </a:schemeClr>
+            </a:gs>
+          </a:gsLst>
+          <a:lin ang="5400000" scaled="0"/>
+        </a:gradFill>
       </a:fillStyleLst>
       <a:lnStyleLst>
         <a:ln w="12700">
@@ -1251,10 +1248,10 @@
       </p:grpSpPr>
       <p:sp>
         <p:nvSpPr>
-          <p:cNvPr id="1" name="">
-            <a:extLst xmlns:a="http://schemas.openxmlformats.org/drawingml/2006/main">
-              <a:ext uri="{FF2B5EF4-FFF2-40B4-BE49-F238E27FC236}">
-                <a16:creationId xmlns:a16="http://schemas.microsoft.com/office/drawing/2014/main" id="{DD27854B-E161-428E-A7B0-3D172C26004B}"/>
+          <p:cNvPr id="18" name="">
+            <a:extLst xmlns:a="http://schemas.openxmlformats.org/drawingml/2006/main">
+              <a:ext uri="{FF2B5EF4-FFF2-40B4-BE49-F238E27FC236}">
+                <a16:creationId xmlns:a16="http://schemas.microsoft.com/office/drawing/2014/main" id="{730D6C48-3690-4B45-8CD6-7278C3B06E89}"/>
               </a:ext>
             </a:extLst>
           </p:cNvPr>
@@ -1289,19 +1286,194 @@
           <p:cNvPr id="2" name="">
             <a:extLst xmlns:a="http://schemas.openxmlformats.org/drawingml/2006/main">
               <a:ext uri="{FF2B5EF4-FFF2-40B4-BE49-F238E27FC236}">
-                <a16:creationId xmlns:a16="http://schemas.microsoft.com/office/drawing/2014/main" id="{EC2744C0-BEFC-41CD-845B-89DCEE67DFA7}"/>
-              </a:ext>
-            </a:extLst>
-          </p:cNvPr>
-          <p:cNvSpPr>
-            <a:spLocks xmlns:a="http://schemas.openxmlformats.org/drawingml/2006/main" noGrp="1"/>
-          </p:cNvSpPr>
-          <p:nvPr/>
-        </p:nvSpPr>
-        <p:spPr>
-          <a:xfrm xmlns:a="http://schemas.openxmlformats.org/drawingml/2006/main">
-            <a:off x="609600" y="552450"/>
-            <a:ext cx="1619250" cy="285750"/>
+                <a16:creationId xmlns:a16="http://schemas.microsoft.com/office/drawing/2014/main" id="{FA8682AE-434F-4A0C-BCFF-4CCA97B26B56}"/>
+              </a:ext>
+            </a:extLst>
+          </p:cNvPr>
+          <p:cNvSpPr>
+            <a:spLocks xmlns:a="http://schemas.openxmlformats.org/drawingml/2006/main" noGrp="1"/>
+          </p:cNvSpPr>
+          <p:nvPr/>
+        </p:nvSpPr>
+        <p:spPr>
+          <a:xfrm xmlns:a="http://schemas.openxmlformats.org/drawingml/2006/main">
+            <a:off x="0" y="0"/>
+            <a:ext cx="12192000" cy="266700"/>
+          </a:xfrm>
+          <a:prstGeom xmlns:a="http://schemas.openxmlformats.org/drawingml/2006/main" prst="rect">
+            <a:avLst/>
+          </a:prstGeom>
+          <a:solidFill xmlns:a="http://schemas.openxmlformats.org/drawingml/2006/main">
+            <a:srgbClr val="1F2738"/>
+          </a:solidFill>
+          <a:ln xmlns:a="http://schemas.openxmlformats.org/drawingml/2006/main" w="0">
+            <a:solidFill>
+              <a:srgbClr val="000000">
+                <a:alpha val="0"/>
+              </a:srgbClr>
+            </a:solidFill>
+            <a:prstDash val="solid"/>
+          </a:ln>
+        </p:spPr>
+      </p:sp>
+      <p:sp>
+        <p:nvSpPr>
+          <p:cNvPr id="3" name="">
+            <a:extLst xmlns:a="http://schemas.openxmlformats.org/drawingml/2006/main">
+              <a:ext uri="{FF2B5EF4-FFF2-40B4-BE49-F238E27FC236}">
+                <a16:creationId xmlns:a16="http://schemas.microsoft.com/office/drawing/2014/main" id="{FA7EE88D-E9B0-4D21-BBFF-B531E7DBD035}"/>
+              </a:ext>
+            </a:extLst>
+          </p:cNvPr>
+          <p:cNvSpPr>
+            <a:spLocks xmlns:a="http://schemas.openxmlformats.org/drawingml/2006/main" noGrp="1"/>
+          </p:cNvSpPr>
+          <p:nvPr/>
+        </p:nvSpPr>
+        <p:spPr>
+          <a:xfrm xmlns:a="http://schemas.openxmlformats.org/drawingml/2006/main">
+            <a:off x="0" y="0"/>
+            <a:ext cx="12192000" cy="6858000"/>
+          </a:xfrm>
+          <a:prstGeom xmlns:a="http://schemas.openxmlformats.org/drawingml/2006/main" prst="rect">
+            <a:avLst/>
+          </a:prstGeom>
+          <a:solidFill xmlns:a="http://schemas.openxmlformats.org/drawingml/2006/main">
+            <a:srgbClr val="F6F1E8"/>
+          </a:solidFill>
+          <a:ln xmlns:a="http://schemas.openxmlformats.org/drawingml/2006/main" w="0">
+            <a:solidFill>
+              <a:srgbClr val="000000">
+                <a:alpha val="0"/>
+              </a:srgbClr>
+            </a:solidFill>
+            <a:prstDash val="solid"/>
+          </a:ln>
+        </p:spPr>
+      </p:sp>
+      <p:sp>
+        <p:nvSpPr>
+          <p:cNvPr id="4" name="">
+            <a:extLst xmlns:a="http://schemas.openxmlformats.org/drawingml/2006/main">
+              <a:ext uri="{FF2B5EF4-FFF2-40B4-BE49-F238E27FC236}">
+                <a16:creationId xmlns:a16="http://schemas.microsoft.com/office/drawing/2014/main" id="{F3A5E276-D45B-4E59-A616-D624AE421AB9}"/>
+              </a:ext>
+            </a:extLst>
+          </p:cNvPr>
+          <p:cNvSpPr>
+            <a:spLocks xmlns:a="http://schemas.openxmlformats.org/drawingml/2006/main" noGrp="1"/>
+          </p:cNvSpPr>
+          <p:nvPr/>
+        </p:nvSpPr>
+        <p:spPr>
+          <a:xfrm xmlns:a="http://schemas.openxmlformats.org/drawingml/2006/main">
+            <a:off x="7753350" y="0"/>
+            <a:ext cx="4438650" cy="6858000"/>
+          </a:xfrm>
+          <a:prstGeom xmlns:a="http://schemas.openxmlformats.org/drawingml/2006/main" prst="rect">
+            <a:avLst/>
+          </a:prstGeom>
+          <a:solidFill xmlns:a="http://schemas.openxmlformats.org/drawingml/2006/main">
+            <a:srgbClr val="1F2738"/>
+          </a:solidFill>
+          <a:ln xmlns:a="http://schemas.openxmlformats.org/drawingml/2006/main" w="0">
+            <a:solidFill>
+              <a:srgbClr val="000000">
+                <a:alpha val="0"/>
+              </a:srgbClr>
+            </a:solidFill>
+            <a:prstDash val="solid"/>
+          </a:ln>
+        </p:spPr>
+      </p:sp>
+      <p:sp>
+        <p:nvSpPr>
+          <p:cNvPr id="5" name="">
+            <a:extLst xmlns:a="http://schemas.openxmlformats.org/drawingml/2006/main">
+              <a:ext uri="{FF2B5EF4-FFF2-40B4-BE49-F238E27FC236}">
+                <a16:creationId xmlns:a16="http://schemas.microsoft.com/office/drawing/2014/main" id="{4F82F10A-611B-439A-9BF6-E1E449B7762F}"/>
+              </a:ext>
+            </a:extLst>
+          </p:cNvPr>
+          <p:cNvSpPr>
+            <a:spLocks xmlns:a="http://schemas.openxmlformats.org/drawingml/2006/main" noGrp="1"/>
+          </p:cNvSpPr>
+          <p:nvPr/>
+        </p:nvSpPr>
+        <p:spPr>
+          <a:xfrm xmlns:a="http://schemas.openxmlformats.org/drawingml/2006/main">
+            <a:off x="7239000" y="0"/>
+            <a:ext cx="838200" cy="6858000"/>
+          </a:xfrm>
+          <a:prstGeom xmlns:a="http://schemas.openxmlformats.org/drawingml/2006/main" prst="rect">
+            <a:avLst/>
+          </a:prstGeom>
+          <a:solidFill xmlns:a="http://schemas.openxmlformats.org/drawingml/2006/main">
+            <a:srgbClr val="E7B08B"/>
+          </a:solidFill>
+          <a:ln xmlns:a="http://schemas.openxmlformats.org/drawingml/2006/main" w="0">
+            <a:solidFill>
+              <a:srgbClr val="000000">
+                <a:alpha val="0"/>
+              </a:srgbClr>
+            </a:solidFill>
+            <a:prstDash val="solid"/>
+          </a:ln>
+        </p:spPr>
+      </p:sp>
+      <p:sp>
+        <p:nvSpPr>
+          <p:cNvPr id="6" name="">
+            <a:extLst xmlns:a="http://schemas.openxmlformats.org/drawingml/2006/main">
+              <a:ext uri="{FF2B5EF4-FFF2-40B4-BE49-F238E27FC236}">
+                <a16:creationId xmlns:a16="http://schemas.microsoft.com/office/drawing/2014/main" id="{3AFF728F-313D-4E22-8D7F-590418D915AE}"/>
+              </a:ext>
+            </a:extLst>
+          </p:cNvPr>
+          <p:cNvSpPr>
+            <a:spLocks xmlns:a="http://schemas.openxmlformats.org/drawingml/2006/main" noGrp="1"/>
+          </p:cNvSpPr>
+          <p:nvPr/>
+        </p:nvSpPr>
+        <p:spPr>
+          <a:xfrm xmlns:a="http://schemas.openxmlformats.org/drawingml/2006/main">
+            <a:off x="8172450" y="1047750"/>
+            <a:ext cx="3429000" cy="4762500"/>
+          </a:xfrm>
+          <a:prstGeom xmlns:a="http://schemas.openxmlformats.org/drawingml/2006/main" prst="rect">
+            <a:avLst/>
+          </a:prstGeom>
+          <a:solidFill xmlns:a="http://schemas.openxmlformats.org/drawingml/2006/main">
+            <a:srgbClr val="000000">
+              <a:alpha val="0"/>
+            </a:srgbClr>
+          </a:solidFill>
+          <a:ln xmlns:a="http://schemas.openxmlformats.org/drawingml/2006/main" w="19050">
+            <a:solidFill>
+              <a:srgbClr val="E7B08B"/>
+            </a:solidFill>
+            <a:prstDash val="solid"/>
+          </a:ln>
+        </p:spPr>
+      </p:sp>
+      <p:sp>
+        <p:nvSpPr>
+          <p:cNvPr id="7" name="">
+            <a:extLst xmlns:a="http://schemas.openxmlformats.org/drawingml/2006/main">
+              <a:ext uri="{FF2B5EF4-FFF2-40B4-BE49-F238E27FC236}">
+                <a16:creationId xmlns:a16="http://schemas.microsoft.com/office/drawing/2014/main" id="{AC937234-BADD-4460-946A-D275F76C9C0F}"/>
+              </a:ext>
+            </a:extLst>
+          </p:cNvPr>
+          <p:cNvSpPr>
+            <a:spLocks xmlns:a="http://schemas.openxmlformats.org/drawingml/2006/main" noGrp="1"/>
+          </p:cNvSpPr>
+          <p:nvPr/>
+        </p:nvSpPr>
+        <p:spPr>
+          <a:xfrm xmlns:a="http://schemas.openxmlformats.org/drawingml/2006/main">
+            <a:off x="685800" y="819150"/>
+            <a:ext cx="1447800" cy="228600"/>
           </a:xfrm>
           <a:prstGeom xmlns:a="http://schemas.openxmlformats.org/drawingml/2006/main" prst="rect">
             <a:avLst/>
@@ -1311,30 +1483,32 @@
           </a:solidFill>
           <a:ln xmlns:a="http://schemas.openxmlformats.org/drawingml/2006/main" w="0">
             <a:solidFill>
-              <a:srgbClr val="C65D2E"/>
-            </a:solidFill>
-            <a:prstDash val="solid"/>
-          </a:ln>
-        </p:spPr>
-      </p:sp>
-      <p:sp>
-        <p:nvSpPr>
-          <p:cNvPr id="3" name="">
-            <a:extLst xmlns:a="http://schemas.openxmlformats.org/drawingml/2006/main">
-              <a:ext uri="{FF2B5EF4-FFF2-40B4-BE49-F238E27FC236}">
-                <a16:creationId xmlns:a16="http://schemas.microsoft.com/office/drawing/2014/main" id="{FBD5B9F4-8472-42F6-AD81-ACB95C217DDC}"/>
-              </a:ext>
-            </a:extLst>
-          </p:cNvPr>
-          <p:cNvSpPr>
-            <a:spLocks xmlns:a="http://schemas.openxmlformats.org/drawingml/2006/main" noGrp="1"/>
-          </p:cNvSpPr>
-          <p:nvPr/>
-        </p:nvSpPr>
-        <p:spPr>
-          <a:xfrm xmlns:a="http://schemas.openxmlformats.org/drawingml/2006/main">
-            <a:off x="742950" y="619125"/>
-            <a:ext cx="1352550" cy="171450"/>
+              <a:srgbClr val="000000">
+                <a:alpha val="0"/>
+              </a:srgbClr>
+            </a:solidFill>
+            <a:prstDash val="solid"/>
+          </a:ln>
+        </p:spPr>
+      </p:sp>
+      <p:sp>
+        <p:nvSpPr>
+          <p:cNvPr id="8" name="">
+            <a:extLst xmlns:a="http://schemas.openxmlformats.org/drawingml/2006/main">
+              <a:ext uri="{FF2B5EF4-FFF2-40B4-BE49-F238E27FC236}">
+                <a16:creationId xmlns:a16="http://schemas.microsoft.com/office/drawing/2014/main" id="{6BEE2A9D-DA34-4671-B936-3EEB74C0D89E}"/>
+              </a:ext>
+            </a:extLst>
+          </p:cNvPr>
+          <p:cNvSpPr>
+            <a:spLocks xmlns:a="http://schemas.openxmlformats.org/drawingml/2006/main" noGrp="1"/>
+          </p:cNvSpPr>
+          <p:nvPr/>
+        </p:nvSpPr>
+        <p:spPr>
+          <a:xfrm xmlns:a="http://schemas.openxmlformats.org/drawingml/2006/main">
+            <a:off x="781050" y="857250"/>
+            <a:ext cx="1257300" cy="152400"/>
           </a:xfrm>
           <a:prstGeom xmlns:a="http://schemas.openxmlformats.org/drawingml/2006/main" prst="rect">
             <a:avLst/>
@@ -1358,7 +1532,7 @@
           <a:lstStyle xmlns:a="http://schemas.openxmlformats.org/drawingml/2006/main"/>
           <a:p xmlns:a="http://schemas.openxmlformats.org/drawingml/2006/main">
             <a:pPr algn="ctr">
-              <a:defRPr sz="825" b="1">
+              <a:defRPr sz="750" b="1">
                 <a:solidFill>
                   <a:srgbClr val="FFF8F0"/>
                 </a:solidFill>
@@ -1368,7 +1542,7 @@
               </a:defRPr>
             </a:pPr>
             <a:r>
-              <a:rPr sz="825" b="1">
+              <a:rPr sz="750" b="1">
                 <a:solidFill>
                   <a:srgbClr val="FFF8F0"/>
                 </a:solidFill>
@@ -1383,22 +1557,22 @@
       </p:sp>
       <p:sp>
         <p:nvSpPr>
-          <p:cNvPr id="4" name="">
-            <a:extLst xmlns:a="http://schemas.openxmlformats.org/drawingml/2006/main">
-              <a:ext uri="{FF2B5EF4-FFF2-40B4-BE49-F238E27FC236}">
-                <a16:creationId xmlns:a16="http://schemas.microsoft.com/office/drawing/2014/main" id="{ADE36CB3-29EF-4731-A579-0CF5B86F9A1B}"/>
-              </a:ext>
-            </a:extLst>
-          </p:cNvPr>
-          <p:cNvSpPr>
-            <a:spLocks xmlns:a="http://schemas.openxmlformats.org/drawingml/2006/main" noGrp="1"/>
-          </p:cNvSpPr>
-          <p:nvPr/>
-        </p:nvSpPr>
-        <p:spPr>
-          <a:xfrm xmlns:a="http://schemas.openxmlformats.org/drawingml/2006/main">
-            <a:off x="609600" y="1314450"/>
-            <a:ext cx="7429500" cy="1714500"/>
+          <p:cNvPr id="9" name="">
+            <a:extLst xmlns:a="http://schemas.openxmlformats.org/drawingml/2006/main">
+              <a:ext uri="{FF2B5EF4-FFF2-40B4-BE49-F238E27FC236}">
+                <a16:creationId xmlns:a16="http://schemas.microsoft.com/office/drawing/2014/main" id="{255E5A15-D09D-4321-AB3F-1F09756B7D43}"/>
+              </a:ext>
+            </a:extLst>
+          </p:cNvPr>
+          <p:cNvSpPr>
+            <a:spLocks xmlns:a="http://schemas.openxmlformats.org/drawingml/2006/main" noGrp="1"/>
+          </p:cNvSpPr>
+          <p:nvPr/>
+        </p:nvSpPr>
+        <p:spPr>
+          <a:xfrm xmlns:a="http://schemas.openxmlformats.org/drawingml/2006/main">
+            <a:off x="685800" y="1638300"/>
+            <a:ext cx="6000750" cy="1619250"/>
           </a:xfrm>
           <a:prstGeom xmlns:a="http://schemas.openxmlformats.org/drawingml/2006/main" prst="rect">
             <a:avLst/>
@@ -1422,23 +1596,23 @@
           <a:lstStyle xmlns:a="http://schemas.openxmlformats.org/drawingml/2006/main"/>
           <a:p xmlns:a="http://schemas.openxmlformats.org/drawingml/2006/main">
             <a:pPr algn="l">
-              <a:defRPr sz="3000" b="1">
+              <a:defRPr sz="2625" b="1">
                 <a:solidFill>
                   <a:srgbClr val="1E1B18"/>
                 </a:solidFill>
-                <a:latin typeface="Aptos Display"/>
-                <a:ea typeface="Aptos Display"/>
-                <a:cs typeface="Aptos Display"/>
+                <a:latin typeface="Times New Roman"/>
+                <a:ea typeface="Times New Roman"/>
+                <a:cs typeface="Times New Roman"/>
               </a:defRPr>
             </a:pPr>
             <a:r>
-              <a:rPr sz="3000" b="1">
+              <a:rPr sz="2625" b="1">
                 <a:solidFill>
                   <a:srgbClr val="1E1B18"/>
                 </a:solidFill>
-                <a:latin typeface="Aptos Display"/>
-                <a:ea typeface="Aptos Display"/>
-                <a:cs typeface="Aptos Display"/>
+                <a:latin typeface="Times New Roman"/>
+                <a:ea typeface="Times New Roman"/>
+                <a:cs typeface="Times New Roman"/>
               </a:rPr>
               <a:t>Codex can automate editable PPT creation.</a:t>
             </a:r>
@@ -1447,22 +1621,22 @@
       </p:sp>
       <p:sp>
         <p:nvSpPr>
-          <p:cNvPr id="5" name="">
-            <a:extLst xmlns:a="http://schemas.openxmlformats.org/drawingml/2006/main">
-              <a:ext uri="{FF2B5EF4-FFF2-40B4-BE49-F238E27FC236}">
-                <a16:creationId xmlns:a16="http://schemas.microsoft.com/office/drawing/2014/main" id="{1CFAE6BE-A830-4DB9-9D79-1BD84CBB116C}"/>
-              </a:ext>
-            </a:extLst>
-          </p:cNvPr>
-          <p:cNvSpPr>
-            <a:spLocks xmlns:a="http://schemas.openxmlformats.org/drawingml/2006/main" noGrp="1"/>
-          </p:cNvSpPr>
-          <p:nvPr/>
-        </p:nvSpPr>
-        <p:spPr>
-          <a:xfrm xmlns:a="http://schemas.openxmlformats.org/drawingml/2006/main">
-            <a:off x="609600" y="3181350"/>
-            <a:ext cx="6191250" cy="609600"/>
+          <p:cNvPr id="10" name="">
+            <a:extLst xmlns:a="http://schemas.openxmlformats.org/drawingml/2006/main">
+              <a:ext uri="{FF2B5EF4-FFF2-40B4-BE49-F238E27FC236}">
+                <a16:creationId xmlns:a16="http://schemas.microsoft.com/office/drawing/2014/main" id="{A61BDA4B-6D4E-4188-8D92-E1085DF0077B}"/>
+              </a:ext>
+            </a:extLst>
+          </p:cNvPr>
+          <p:cNvSpPr>
+            <a:spLocks xmlns:a="http://schemas.openxmlformats.org/drawingml/2006/main" noGrp="1"/>
+          </p:cNvSpPr>
+          <p:nvPr/>
+        </p:nvSpPr>
+        <p:spPr>
+          <a:xfrm xmlns:a="http://schemas.openxmlformats.org/drawingml/2006/main">
+            <a:off x="685800" y="3562350"/>
+            <a:ext cx="5334000" cy="857250"/>
           </a:xfrm>
           <a:prstGeom xmlns:a="http://schemas.openxmlformats.org/drawingml/2006/main" prst="rect">
             <a:avLst/>
@@ -1486,7 +1660,7 @@
           <a:lstStyle xmlns:a="http://schemas.openxmlformats.org/drawingml/2006/main"/>
           <a:p xmlns:a="http://schemas.openxmlformats.org/drawingml/2006/main">
             <a:pPr algn="l">
-              <a:defRPr sz="1500" b="0">
+              <a:defRPr sz="1425" b="0">
                 <a:solidFill>
                   <a:srgbClr val="6B6258"/>
                 </a:solidFill>
@@ -1496,7 +1670,7 @@
               </a:defRPr>
             </a:pPr>
             <a:r>
-              <a:rPr sz="1500" b="0">
+              <a:rPr sz="1425" b="0">
                 <a:solidFill>
                   <a:srgbClr val="6B6258"/>
                 </a:solidFill>
@@ -1511,90 +1685,22 @@
       </p:sp>
       <p:sp>
         <p:nvSpPr>
-          <p:cNvPr id="6" name="">
-            <a:extLst xmlns:a="http://schemas.openxmlformats.org/drawingml/2006/main">
-              <a:ext uri="{FF2B5EF4-FFF2-40B4-BE49-F238E27FC236}">
-                <a16:creationId xmlns:a16="http://schemas.microsoft.com/office/drawing/2014/main" id="{C172EE4E-6EA0-4118-B386-150BF7755053}"/>
-              </a:ext>
-            </a:extLst>
-          </p:cNvPr>
-          <p:cNvSpPr>
-            <a:spLocks xmlns:a="http://schemas.openxmlformats.org/drawingml/2006/main" noGrp="1"/>
-          </p:cNvSpPr>
-          <p:nvPr/>
-        </p:nvSpPr>
-        <p:spPr>
-          <a:xfrm xmlns:a="http://schemas.openxmlformats.org/drawingml/2006/main">
-            <a:off x="8496300" y="1200150"/>
-            <a:ext cx="3086100" cy="3162300"/>
-          </a:xfrm>
-          <a:prstGeom xmlns:a="http://schemas.openxmlformats.org/drawingml/2006/main" prst="rect">
-            <a:avLst/>
-          </a:prstGeom>
-          <a:solidFill xmlns:a="http://schemas.openxmlformats.org/drawingml/2006/main">
-            <a:srgbClr val="FFF9F2"/>
-          </a:solidFill>
-          <a:ln xmlns:a="http://schemas.openxmlformats.org/drawingml/2006/main" w="9525">
-            <a:solidFill>
-              <a:srgbClr val="D6C8B8"/>
-            </a:solidFill>
-            <a:prstDash val="solid"/>
-          </a:ln>
-        </p:spPr>
-      </p:sp>
-      <p:sp>
-        <p:nvSpPr>
-          <p:cNvPr id="7" name="">
-            <a:extLst xmlns:a="http://schemas.openxmlformats.org/drawingml/2006/main">
-              <a:ext uri="{FF2B5EF4-FFF2-40B4-BE49-F238E27FC236}">
-                <a16:creationId xmlns:a16="http://schemas.microsoft.com/office/drawing/2014/main" id="{6A756E10-99DE-4012-9AD6-4058C946F07F}"/>
-              </a:ext>
-            </a:extLst>
-          </p:cNvPr>
-          <p:cNvSpPr>
-            <a:spLocks xmlns:a="http://schemas.openxmlformats.org/drawingml/2006/main" noGrp="1"/>
-          </p:cNvSpPr>
-          <p:nvPr/>
-        </p:nvSpPr>
-        <p:spPr>
-          <a:xfrm xmlns:a="http://schemas.openxmlformats.org/drawingml/2006/main">
-            <a:off x="8801100" y="1485900"/>
-            <a:ext cx="838200" cy="838200"/>
-          </a:xfrm>
-          <a:prstGeom xmlns:a="http://schemas.openxmlformats.org/drawingml/2006/main" prst="rect">
-            <a:avLst/>
-          </a:prstGeom>
-          <a:solidFill xmlns:a="http://schemas.openxmlformats.org/drawingml/2006/main">
-            <a:srgbClr val="E7B08B"/>
-          </a:solidFill>
-          <a:ln xmlns:a="http://schemas.openxmlformats.org/drawingml/2006/main" w="0">
-            <a:solidFill>
-              <a:srgbClr val="000000">
-                <a:alpha val="0"/>
-              </a:srgbClr>
-            </a:solidFill>
-            <a:prstDash val="solid"/>
-          </a:ln>
-        </p:spPr>
-      </p:sp>
-      <p:sp>
-        <p:nvSpPr>
-          <p:cNvPr id="8" name="">
-            <a:extLst xmlns:a="http://schemas.openxmlformats.org/drawingml/2006/main">
-              <a:ext uri="{FF2B5EF4-FFF2-40B4-BE49-F238E27FC236}">
-                <a16:creationId xmlns:a16="http://schemas.microsoft.com/office/drawing/2014/main" id="{E8040E43-78FF-467E-B5C4-5484F42320FA}"/>
-              </a:ext>
-            </a:extLst>
-          </p:cNvPr>
-          <p:cNvSpPr>
-            <a:spLocks xmlns:a="http://schemas.openxmlformats.org/drawingml/2006/main" noGrp="1"/>
-          </p:cNvSpPr>
-          <p:nvPr/>
-        </p:nvSpPr>
-        <p:spPr>
-          <a:xfrm xmlns:a="http://schemas.openxmlformats.org/drawingml/2006/main">
-            <a:off x="9791700" y="1962150"/>
-            <a:ext cx="1257300" cy="1257300"/>
+          <p:cNvPr id="11" name="">
+            <a:extLst xmlns:a="http://schemas.openxmlformats.org/drawingml/2006/main">
+              <a:ext uri="{FF2B5EF4-FFF2-40B4-BE49-F238E27FC236}">
+                <a16:creationId xmlns:a16="http://schemas.microsoft.com/office/drawing/2014/main" id="{D0F5F4FA-A97F-41CD-AD90-B9AF854F847E}"/>
+              </a:ext>
+            </a:extLst>
+          </p:cNvPr>
+          <p:cNvSpPr>
+            <a:spLocks xmlns:a="http://schemas.openxmlformats.org/drawingml/2006/main" noGrp="1"/>
+          </p:cNvSpPr>
+          <p:nvPr/>
+        </p:nvSpPr>
+        <p:spPr>
+          <a:xfrm xmlns:a="http://schemas.openxmlformats.org/drawingml/2006/main">
+            <a:off x="685800" y="5219700"/>
+            <a:ext cx="2000250" cy="19050"/>
           </a:xfrm>
           <a:prstGeom xmlns:a="http://schemas.openxmlformats.org/drawingml/2006/main" prst="rect">
             <a:avLst/>
@@ -1614,22 +1720,22 @@
       </p:sp>
       <p:sp>
         <p:nvSpPr>
-          <p:cNvPr id="9" name="">
-            <a:extLst xmlns:a="http://schemas.openxmlformats.org/drawingml/2006/main">
-              <a:ext uri="{FF2B5EF4-FFF2-40B4-BE49-F238E27FC236}">
-                <a16:creationId xmlns:a16="http://schemas.microsoft.com/office/drawing/2014/main" id="{4CE242FC-EF67-4915-80A6-25B1C76CD782}"/>
-              </a:ext>
-            </a:extLst>
-          </p:cNvPr>
-          <p:cNvSpPr>
-            <a:spLocks xmlns:a="http://schemas.openxmlformats.org/drawingml/2006/main" noGrp="1"/>
-          </p:cNvSpPr>
-          <p:nvPr/>
-        </p:nvSpPr>
-        <p:spPr>
-          <a:xfrm xmlns:a="http://schemas.openxmlformats.org/drawingml/2006/main">
-            <a:off x="8801100" y="3600450"/>
-            <a:ext cx="1524000" cy="228600"/>
+          <p:cNvPr id="12" name="">
+            <a:extLst xmlns:a="http://schemas.openxmlformats.org/drawingml/2006/main">
+              <a:ext uri="{FF2B5EF4-FFF2-40B4-BE49-F238E27FC236}">
+                <a16:creationId xmlns:a16="http://schemas.microsoft.com/office/drawing/2014/main" id="{F6FF0629-0B54-4496-873E-275C6679F41A}"/>
+              </a:ext>
+            </a:extLst>
+          </p:cNvPr>
+          <p:cNvSpPr>
+            <a:spLocks xmlns:a="http://schemas.openxmlformats.org/drawingml/2006/main" noGrp="1"/>
+          </p:cNvSpPr>
+          <p:nvPr/>
+        </p:nvSpPr>
+        <p:spPr>
+          <a:xfrm xmlns:a="http://schemas.openxmlformats.org/drawingml/2006/main">
+            <a:off x="685800" y="5391150"/>
+            <a:ext cx="4572000" cy="381000"/>
           </a:xfrm>
           <a:prstGeom xmlns:a="http://schemas.openxmlformats.org/drawingml/2006/main" prst="rect">
             <a:avLst/>
@@ -1653,9 +1759,9 @@
           <a:lstStyle xmlns:a="http://schemas.openxmlformats.org/drawingml/2006/main"/>
           <a:p xmlns:a="http://schemas.openxmlformats.org/drawingml/2006/main">
             <a:pPr algn="l">
-              <a:defRPr sz="1200" b="1">
-                <a:solidFill>
-                  <a:srgbClr val="1E1B18"/>
+              <a:defRPr sz="975" b="1">
+                <a:solidFill>
+                  <a:srgbClr val="C65D2E"/>
                 </a:solidFill>
                 <a:latin typeface="Aptos"/>
                 <a:ea typeface="Aptos"/>
@@ -1663,37 +1769,37 @@
               </a:defRPr>
             </a:pPr>
             <a:r>
-              <a:rPr sz="1200" b="1">
-                <a:solidFill>
-                  <a:srgbClr val="1E1B18"/>
+              <a:rPr sz="975" b="1">
+                <a:solidFill>
+                  <a:srgbClr val="C65D2E"/>
                 </a:solidFill>
                 <a:latin typeface="Aptos"/>
                 <a:ea typeface="Aptos"/>
                 <a:cs typeface="Aptos"/>
               </a:rPr>
-              <a:t>Editable output</a:t>
+              <a:t>Input brief -&gt; Node script -&gt; editable .pptx</a:t>
             </a:r>
           </a:p>
         </p:txBody>
       </p:sp>
       <p:sp>
         <p:nvSpPr>
-          <p:cNvPr id="10" name="">
-            <a:extLst xmlns:a="http://schemas.openxmlformats.org/drawingml/2006/main">
-              <a:ext uri="{FF2B5EF4-FFF2-40B4-BE49-F238E27FC236}">
-                <a16:creationId xmlns:a16="http://schemas.microsoft.com/office/drawing/2014/main" id="{B5DC88DB-400E-417D-A9C1-79E37600F003}"/>
-              </a:ext>
-            </a:extLst>
-          </p:cNvPr>
-          <p:cNvSpPr>
-            <a:spLocks xmlns:a="http://schemas.openxmlformats.org/drawingml/2006/main" noGrp="1"/>
-          </p:cNvSpPr>
-          <p:nvPr/>
-        </p:nvSpPr>
-        <p:spPr>
-          <a:xfrm xmlns:a="http://schemas.openxmlformats.org/drawingml/2006/main">
-            <a:off x="8801100" y="3867150"/>
-            <a:ext cx="2171700" cy="457200"/>
+          <p:cNvPr id="13" name="">
+            <a:extLst xmlns:a="http://schemas.openxmlformats.org/drawingml/2006/main">
+              <a:ext uri="{FF2B5EF4-FFF2-40B4-BE49-F238E27FC236}">
+                <a16:creationId xmlns:a16="http://schemas.microsoft.com/office/drawing/2014/main" id="{A64E43F3-5654-4C9A-BD27-EDE7B6F3FA2C}"/>
+              </a:ext>
+            </a:extLst>
+          </p:cNvPr>
+          <p:cNvSpPr>
+            <a:spLocks xmlns:a="http://schemas.openxmlformats.org/drawingml/2006/main" noGrp="1"/>
+          </p:cNvSpPr>
+          <p:nvPr/>
+        </p:nvSpPr>
+        <p:spPr>
+          <a:xfrm xmlns:a="http://schemas.openxmlformats.org/drawingml/2006/main">
+            <a:off x="8496300" y="5981700"/>
+            <a:ext cx="2476500" cy="266700"/>
           </a:xfrm>
           <a:prstGeom xmlns:a="http://schemas.openxmlformats.org/drawingml/2006/main" prst="rect">
             <a:avLst/>
@@ -1717,47 +1823,47 @@
           <a:lstStyle xmlns:a="http://schemas.openxmlformats.org/drawingml/2006/main"/>
           <a:p xmlns:a="http://schemas.openxmlformats.org/drawingml/2006/main">
             <a:pPr algn="l">
-              <a:defRPr sz="975" b="0">
-                <a:solidFill>
-                  <a:srgbClr val="6B6258"/>
-                </a:solidFill>
-                <a:latin typeface="Aptos"/>
-                <a:ea typeface="Aptos"/>
-                <a:cs typeface="Aptos"/>
+              <a:defRPr sz="1500" b="1">
+                <a:solidFill>
+                  <a:srgbClr val="FFF8F0"/>
+                </a:solidFill>
+                <a:latin typeface="Times New Roman"/>
+                <a:ea typeface="Times New Roman"/>
+                <a:cs typeface="Times New Roman"/>
               </a:defRPr>
             </a:pPr>
             <a:r>
-              <a:rPr sz="975" b="0">
-                <a:solidFill>
-                  <a:srgbClr val="6B6258"/>
-                </a:solidFill>
-                <a:latin typeface="Aptos"/>
-                <a:ea typeface="Aptos"/>
-                <a:cs typeface="Aptos"/>
+              <a:rPr sz="1500" b="1">
+                <a:solidFill>
+                  <a:srgbClr val="FFF8F0"/>
+                </a:solidFill>
+                <a:latin typeface="Times New Roman"/>
+                <a:ea typeface="Times New Roman"/>
+                <a:cs typeface="Times New Roman"/>
               </a:rPr>
-              <a:t>Built locally with the Codex Presentations runtime.</a:t>
+              <a:t>Hello World</a:t>
             </a:r>
           </a:p>
         </p:txBody>
       </p:sp>
       <p:sp>
         <p:nvSpPr>
-          <p:cNvPr id="11" name="">
-            <a:extLst xmlns:a="http://schemas.openxmlformats.org/drawingml/2006/main">
-              <a:ext uri="{FF2B5EF4-FFF2-40B4-BE49-F238E27FC236}">
-                <a16:creationId xmlns:a16="http://schemas.microsoft.com/office/drawing/2014/main" id="{5A907B52-529E-469A-9D4A-4F0D3B2A1D4B}"/>
-              </a:ext>
-            </a:extLst>
-          </p:cNvPr>
-          <p:cNvSpPr>
-            <a:spLocks xmlns:a="http://schemas.openxmlformats.org/drawingml/2006/main" noGrp="1"/>
-          </p:cNvSpPr>
-          <p:nvPr/>
-        </p:nvSpPr>
-        <p:spPr>
-          <a:xfrm xmlns:a="http://schemas.openxmlformats.org/drawingml/2006/main">
-            <a:off x="609600" y="5334000"/>
-            <a:ext cx="6191250" cy="285750"/>
+          <p:cNvPr id="14" name="">
+            <a:extLst xmlns:a="http://schemas.openxmlformats.org/drawingml/2006/main">
+              <a:ext uri="{FF2B5EF4-FFF2-40B4-BE49-F238E27FC236}">
+                <a16:creationId xmlns:a16="http://schemas.microsoft.com/office/drawing/2014/main" id="{39515E5A-2686-4FE6-818B-B6B9338EC786}"/>
+              </a:ext>
+            </a:extLst>
+          </p:cNvPr>
+          <p:cNvSpPr>
+            <a:spLocks xmlns:a="http://schemas.openxmlformats.org/drawingml/2006/main" noGrp="1"/>
+          </p:cNvSpPr>
+          <p:nvPr/>
+        </p:nvSpPr>
+        <p:spPr>
+          <a:xfrm xmlns:a="http://schemas.openxmlformats.org/drawingml/2006/main">
+            <a:off x="8496300" y="6229350"/>
+            <a:ext cx="2476500" cy="228600"/>
           </a:xfrm>
           <a:prstGeom xmlns:a="http://schemas.openxmlformats.org/drawingml/2006/main" prst="rect">
             <a:avLst/>
@@ -1781,9 +1887,9 @@
           <a:lstStyle xmlns:a="http://schemas.openxmlformats.org/drawingml/2006/main"/>
           <a:p xmlns:a="http://schemas.openxmlformats.org/drawingml/2006/main">
             <a:pPr algn="l">
-              <a:defRPr sz="1050" b="1">
-                <a:solidFill>
-                  <a:srgbClr val="C65D2E"/>
+              <a:defRPr sz="900" b="0">
+                <a:solidFill>
+                  <a:srgbClr val="DCCFBF"/>
                 </a:solidFill>
                 <a:latin typeface="Aptos"/>
                 <a:ea typeface="Aptos"/>
@@ -1791,37 +1897,37 @@
               </a:defRPr>
             </a:pPr>
             <a:r>
-              <a:rPr sz="1050" b="1">
-                <a:solidFill>
-                  <a:srgbClr val="C65D2E"/>
+              <a:rPr sz="900" b="0">
+                <a:solidFill>
+                  <a:srgbClr val="DCCFBF"/>
                 </a:solidFill>
                 <a:latin typeface="Aptos"/>
                 <a:ea typeface="Aptos"/>
                 <a:cs typeface="Aptos"/>
               </a:rPr>
-              <a:t>Input brief -&gt; Node script -&gt; editable .pptx</a:t>
+              <a:t>A minimal editable PPTX generated by Codex</a:t>
             </a:r>
           </a:p>
         </p:txBody>
       </p:sp>
       <p:sp>
         <p:nvSpPr>
-          <p:cNvPr id="12" name="">
-            <a:extLst xmlns:a="http://schemas.openxmlformats.org/drawingml/2006/main">
-              <a:ext uri="{FF2B5EF4-FFF2-40B4-BE49-F238E27FC236}">
-                <a16:creationId xmlns:a16="http://schemas.microsoft.com/office/drawing/2014/main" id="{E62F6CC5-8339-4D12-8AD5-F169352FE57C}"/>
-              </a:ext>
-            </a:extLst>
-          </p:cNvPr>
-          <p:cNvSpPr>
-            <a:spLocks xmlns:a="http://schemas.openxmlformats.org/drawingml/2006/main" noGrp="1"/>
-          </p:cNvSpPr>
-          <p:nvPr/>
-        </p:nvSpPr>
-        <p:spPr>
-          <a:xfrm xmlns:a="http://schemas.openxmlformats.org/drawingml/2006/main">
-            <a:off x="609600" y="6477000"/>
-            <a:ext cx="10972800" cy="9525"/>
+          <p:cNvPr id="15" name="">
+            <a:extLst xmlns:a="http://schemas.openxmlformats.org/drawingml/2006/main">
+              <a:ext uri="{FF2B5EF4-FFF2-40B4-BE49-F238E27FC236}">
+                <a16:creationId xmlns:a16="http://schemas.microsoft.com/office/drawing/2014/main" id="{3745F6D6-6256-4DDB-B186-976E022C081A}"/>
+              </a:ext>
+            </a:extLst>
+          </p:cNvPr>
+          <p:cNvSpPr>
+            <a:spLocks xmlns:a="http://schemas.openxmlformats.org/drawingml/2006/main" noGrp="1"/>
+          </p:cNvSpPr>
+          <p:nvPr/>
+        </p:nvSpPr>
+        <p:spPr>
+          <a:xfrm xmlns:a="http://schemas.openxmlformats.org/drawingml/2006/main">
+            <a:off x="685800" y="6438900"/>
+            <a:ext cx="10820400" cy="9525"/>
           </a:xfrm>
           <a:prstGeom xmlns:a="http://schemas.openxmlformats.org/drawingml/2006/main" prst="rect">
             <a:avLst/>
@@ -1831,30 +1937,32 @@
           </a:solidFill>
           <a:ln xmlns:a="http://schemas.openxmlformats.org/drawingml/2006/main" w="0">
             <a:solidFill>
-              <a:srgbClr val="D6C8B8"/>
-            </a:solidFill>
-            <a:prstDash val="solid"/>
-          </a:ln>
-        </p:spPr>
-      </p:sp>
-      <p:sp>
-        <p:nvSpPr>
-          <p:cNvPr id="13" name="">
-            <a:extLst xmlns:a="http://schemas.openxmlformats.org/drawingml/2006/main">
-              <a:ext uri="{FF2B5EF4-FFF2-40B4-BE49-F238E27FC236}">
-                <a16:creationId xmlns:a16="http://schemas.microsoft.com/office/drawing/2014/main" id="{A2E68C47-E2D2-4E98-9C7D-E7C2FD002A97}"/>
-              </a:ext>
-            </a:extLst>
-          </p:cNvPr>
-          <p:cNvSpPr>
-            <a:spLocks xmlns:a="http://schemas.openxmlformats.org/drawingml/2006/main" noGrp="1"/>
-          </p:cNvSpPr>
-          <p:nvPr/>
-        </p:nvSpPr>
-        <p:spPr>
-          <a:xfrm xmlns:a="http://schemas.openxmlformats.org/drawingml/2006/main">
-            <a:off x="609600" y="6572250"/>
-            <a:ext cx="3048000" cy="171450"/>
+              <a:srgbClr val="000000">
+                <a:alpha val="0"/>
+              </a:srgbClr>
+            </a:solidFill>
+            <a:prstDash val="solid"/>
+          </a:ln>
+        </p:spPr>
+      </p:sp>
+      <p:sp>
+        <p:nvSpPr>
+          <p:cNvPr id="16" name="">
+            <a:extLst xmlns:a="http://schemas.openxmlformats.org/drawingml/2006/main">
+              <a:ext uri="{FF2B5EF4-FFF2-40B4-BE49-F238E27FC236}">
+                <a16:creationId xmlns:a16="http://schemas.microsoft.com/office/drawing/2014/main" id="{8F9B90EF-150D-4B4F-8127-B8FEB89926B6}"/>
+              </a:ext>
+            </a:extLst>
+          </p:cNvPr>
+          <p:cNvSpPr>
+            <a:spLocks xmlns:a="http://schemas.openxmlformats.org/drawingml/2006/main" noGrp="1"/>
+          </p:cNvSpPr>
+          <p:nvPr/>
+        </p:nvSpPr>
+        <p:spPr>
+          <a:xfrm xmlns:a="http://schemas.openxmlformats.org/drawingml/2006/main">
+            <a:off x="685800" y="6543675"/>
+            <a:ext cx="3048000" cy="152400"/>
           </a:xfrm>
           <a:prstGeom xmlns:a="http://schemas.openxmlformats.org/drawingml/2006/main" prst="rect">
             <a:avLst/>
@@ -1878,7 +1986,7 @@
           <a:lstStyle xmlns:a="http://schemas.openxmlformats.org/drawingml/2006/main"/>
           <a:p xmlns:a="http://schemas.openxmlformats.org/drawingml/2006/main">
             <a:pPr algn="l">
-              <a:defRPr sz="750" b="0">
+              <a:defRPr sz="675" b="0">
                 <a:solidFill>
                   <a:srgbClr val="6B6258"/>
                 </a:solidFill>
@@ -1888,7 +1996,7 @@
               </a:defRPr>
             </a:pPr>
             <a:r>
-              <a:rPr sz="750" b="0">
+              <a:rPr sz="675" b="0">
                 <a:solidFill>
                   <a:srgbClr val="6B6258"/>
                 </a:solidFill>
@@ -1903,22 +2011,22 @@
       </p:sp>
       <p:sp>
         <p:nvSpPr>
-          <p:cNvPr id="14" name="">
-            <a:extLst xmlns:a="http://schemas.openxmlformats.org/drawingml/2006/main">
-              <a:ext uri="{FF2B5EF4-FFF2-40B4-BE49-F238E27FC236}">
-                <a16:creationId xmlns:a16="http://schemas.microsoft.com/office/drawing/2014/main" id="{C0ECB7F2-1069-486F-AED1-36E354D9AA3C}"/>
-              </a:ext>
-            </a:extLst>
-          </p:cNvPr>
-          <p:cNvSpPr>
-            <a:spLocks xmlns:a="http://schemas.openxmlformats.org/drawingml/2006/main" noGrp="1"/>
-          </p:cNvSpPr>
-          <p:nvPr/>
-        </p:nvSpPr>
-        <p:spPr>
-          <a:xfrm xmlns:a="http://schemas.openxmlformats.org/drawingml/2006/main">
-            <a:off x="10858500" y="6572250"/>
-            <a:ext cx="723900" cy="171450"/>
+          <p:cNvPr id="17" name="">
+            <a:extLst xmlns:a="http://schemas.openxmlformats.org/drawingml/2006/main">
+              <a:ext uri="{FF2B5EF4-FFF2-40B4-BE49-F238E27FC236}">
+                <a16:creationId xmlns:a16="http://schemas.microsoft.com/office/drawing/2014/main" id="{B9185A40-038B-4075-A151-12891D12EDB0}"/>
+              </a:ext>
+            </a:extLst>
+          </p:cNvPr>
+          <p:cNvSpPr>
+            <a:spLocks xmlns:a="http://schemas.openxmlformats.org/drawingml/2006/main" noGrp="1"/>
+          </p:cNvSpPr>
+          <p:nvPr/>
+        </p:nvSpPr>
+        <p:spPr>
+          <a:xfrm xmlns:a="http://schemas.openxmlformats.org/drawingml/2006/main">
+            <a:off x="10953750" y="6543675"/>
+            <a:ext cx="571500" cy="152400"/>
           </a:xfrm>
           <a:prstGeom xmlns:a="http://schemas.openxmlformats.org/drawingml/2006/main" prst="rect">
             <a:avLst/>
@@ -1942,7 +2050,7 @@
           <a:lstStyle xmlns:a="http://schemas.openxmlformats.org/drawingml/2006/main"/>
           <a:p xmlns:a="http://schemas.openxmlformats.org/drawingml/2006/main">
             <a:pPr algn="r">
-              <a:defRPr sz="750" b="0">
+              <a:defRPr sz="675" b="0">
                 <a:solidFill>
                   <a:srgbClr val="6B6258"/>
                 </a:solidFill>
@@ -1952,7 +2060,7 @@
               </a:defRPr>
             </a:pPr>
             <a:r>
-              <a:rPr sz="750" b="0">
+              <a:rPr sz="675" b="0">
                 <a:solidFill>
                   <a:srgbClr val="6B6258"/>
                 </a:solidFill>
@@ -1968,7 +2076,7 @@
     </p:spTree>
     <p:extLst>
       <p:ext uri="{BB962C8B-B14F-4D97-AF65-F5344CB8AC3E}">
-        <p14:creationId xmlns:p14="http://schemas.microsoft.com/office/powerpoint/2010/main" val="2068786370"/>
+        <p14:creationId xmlns:p14="http://schemas.microsoft.com/office/powerpoint/2010/main" val="2135052501"/>
       </p:ext>
     </p:extLst>
   </p:cSld>
@@ -1989,10 +2097,10 @@
       </p:grpSpPr>
       <p:sp>
         <p:nvSpPr>
-          <p:cNvPr id="1" name="">
-            <a:extLst xmlns:a="http://schemas.openxmlformats.org/drawingml/2006/main">
-              <a:ext uri="{FF2B5EF4-FFF2-40B4-BE49-F238E27FC236}">
-                <a16:creationId xmlns:a16="http://schemas.microsoft.com/office/drawing/2014/main" id="{D33B7F44-C55D-4AE5-981F-9AAD5E7A9016}"/>
+          <p:cNvPr id="15" name="">
+            <a:extLst xmlns:a="http://schemas.openxmlformats.org/drawingml/2006/main">
+              <a:ext uri="{FF2B5EF4-FFF2-40B4-BE49-F238E27FC236}">
+                <a16:creationId xmlns:a16="http://schemas.microsoft.com/office/drawing/2014/main" id="{DEAFDDCF-B0F1-4AFF-A55D-7B07D28B3B2C}"/>
               </a:ext>
             </a:extLst>
           </p:cNvPr>
@@ -2027,19 +2135,153 @@
           <p:cNvPr id="2" name="">
             <a:extLst xmlns:a="http://schemas.openxmlformats.org/drawingml/2006/main">
               <a:ext uri="{FF2B5EF4-FFF2-40B4-BE49-F238E27FC236}">
-                <a16:creationId xmlns:a16="http://schemas.microsoft.com/office/drawing/2014/main" id="{F26A339F-4205-413D-A551-0B360CC93F98}"/>
-              </a:ext>
-            </a:extLst>
-          </p:cNvPr>
-          <p:cNvSpPr>
-            <a:spLocks xmlns:a="http://schemas.openxmlformats.org/drawingml/2006/main" noGrp="1"/>
-          </p:cNvSpPr>
-          <p:nvPr/>
-        </p:nvSpPr>
-        <p:spPr>
-          <a:xfrm xmlns:a="http://schemas.openxmlformats.org/drawingml/2006/main">
-            <a:off x="609600" y="476250"/>
-            <a:ext cx="2286000" cy="266700"/>
+                <a16:creationId xmlns:a16="http://schemas.microsoft.com/office/drawing/2014/main" id="{CEBECC86-15A7-4250-9173-4B02519BF0CE}"/>
+              </a:ext>
+            </a:extLst>
+          </p:cNvPr>
+          <p:cNvSpPr>
+            <a:spLocks xmlns:a="http://schemas.openxmlformats.org/drawingml/2006/main" noGrp="1"/>
+          </p:cNvSpPr>
+          <p:nvPr/>
+        </p:nvSpPr>
+        <p:spPr>
+          <a:xfrm xmlns:a="http://schemas.openxmlformats.org/drawingml/2006/main">
+            <a:off x="0" y="0"/>
+            <a:ext cx="12192000" cy="266700"/>
+          </a:xfrm>
+          <a:prstGeom xmlns:a="http://schemas.openxmlformats.org/drawingml/2006/main" prst="rect">
+            <a:avLst/>
+          </a:prstGeom>
+          <a:solidFill xmlns:a="http://schemas.openxmlformats.org/drawingml/2006/main">
+            <a:srgbClr val="1F2738"/>
+          </a:solidFill>
+          <a:ln xmlns:a="http://schemas.openxmlformats.org/drawingml/2006/main" w="0">
+            <a:solidFill>
+              <a:srgbClr val="000000">
+                <a:alpha val="0"/>
+              </a:srgbClr>
+            </a:solidFill>
+            <a:prstDash val="solid"/>
+          </a:ln>
+        </p:spPr>
+      </p:sp>
+      <p:sp>
+        <p:nvSpPr>
+          <p:cNvPr id="3" name="">
+            <a:extLst xmlns:a="http://schemas.openxmlformats.org/drawingml/2006/main">
+              <a:ext uri="{FF2B5EF4-FFF2-40B4-BE49-F238E27FC236}">
+                <a16:creationId xmlns:a16="http://schemas.microsoft.com/office/drawing/2014/main" id="{D5AD45C3-7A97-48FD-B722-1F79CCC3F634}"/>
+              </a:ext>
+            </a:extLst>
+          </p:cNvPr>
+          <p:cNvSpPr>
+            <a:spLocks xmlns:a="http://schemas.openxmlformats.org/drawingml/2006/main" noGrp="1"/>
+          </p:cNvSpPr>
+          <p:nvPr/>
+        </p:nvSpPr>
+        <p:spPr>
+          <a:xfrm xmlns:a="http://schemas.openxmlformats.org/drawingml/2006/main">
+            <a:off x="685800" y="590550"/>
+            <a:ext cx="1314450" cy="228600"/>
+          </a:xfrm>
+          <a:prstGeom xmlns:a="http://schemas.openxmlformats.org/drawingml/2006/main" prst="rect">
+            <a:avLst/>
+          </a:prstGeom>
+          <a:solidFill xmlns:a="http://schemas.openxmlformats.org/drawingml/2006/main">
+            <a:srgbClr val="C65D2E"/>
+          </a:solidFill>
+          <a:ln xmlns:a="http://schemas.openxmlformats.org/drawingml/2006/main" w="0">
+            <a:solidFill>
+              <a:srgbClr val="000000">
+                <a:alpha val="0"/>
+              </a:srgbClr>
+            </a:solidFill>
+            <a:prstDash val="solid"/>
+          </a:ln>
+        </p:spPr>
+      </p:sp>
+      <p:sp>
+        <p:nvSpPr>
+          <p:cNvPr id="4" name="">
+            <a:extLst xmlns:a="http://schemas.openxmlformats.org/drawingml/2006/main">
+              <a:ext uri="{FF2B5EF4-FFF2-40B4-BE49-F238E27FC236}">
+                <a16:creationId xmlns:a16="http://schemas.microsoft.com/office/drawing/2014/main" id="{098C2A41-E800-4937-B919-D306D792F8BE}"/>
+              </a:ext>
+            </a:extLst>
+          </p:cNvPr>
+          <p:cNvSpPr>
+            <a:spLocks xmlns:a="http://schemas.openxmlformats.org/drawingml/2006/main" noGrp="1"/>
+          </p:cNvSpPr>
+          <p:nvPr/>
+        </p:nvSpPr>
+        <p:spPr>
+          <a:xfrm xmlns:a="http://schemas.openxmlformats.org/drawingml/2006/main">
+            <a:off x="781050" y="628650"/>
+            <a:ext cx="1123950" cy="152400"/>
+          </a:xfrm>
+          <a:prstGeom xmlns:a="http://schemas.openxmlformats.org/drawingml/2006/main" prst="rect">
+            <a:avLst/>
+          </a:prstGeom>
+          <a:solidFill xmlns:a="http://schemas.openxmlformats.org/drawingml/2006/main">
+            <a:srgbClr val="000000">
+              <a:alpha val="0"/>
+            </a:srgbClr>
+          </a:solidFill>
+          <a:ln xmlns:a="http://schemas.openxmlformats.org/drawingml/2006/main" w="0">
+            <a:solidFill>
+              <a:srgbClr val="000000">
+                <a:alpha val="0"/>
+              </a:srgbClr>
+            </a:solidFill>
+            <a:prstDash val="solid"/>
+          </a:ln>
+        </p:spPr>
+        <p:txBody>
+          <a:bodyPr xmlns:a="http://schemas.openxmlformats.org/drawingml/2006/main" lIns="0" tIns="0" rIns="0" bIns="0" anchor="t"/>
+          <a:lstStyle xmlns:a="http://schemas.openxmlformats.org/drawingml/2006/main"/>
+          <a:p xmlns:a="http://schemas.openxmlformats.org/drawingml/2006/main">
+            <a:pPr algn="ctr">
+              <a:defRPr sz="750" b="1">
+                <a:solidFill>
+                  <a:srgbClr val="FFF8F0"/>
+                </a:solidFill>
+                <a:latin typeface="Aptos"/>
+                <a:ea typeface="Aptos"/>
+                <a:cs typeface="Aptos"/>
+              </a:defRPr>
+            </a:pPr>
+            <a:r>
+              <a:rPr sz="750" b="1">
+                <a:solidFill>
+                  <a:srgbClr val="FFF8F0"/>
+                </a:solidFill>
+                <a:latin typeface="Aptos"/>
+                <a:ea typeface="Aptos"/>
+                <a:cs typeface="Aptos"/>
+              </a:rPr>
+              <a:t>WORKFLOW</a:t>
+            </a:r>
+          </a:p>
+        </p:txBody>
+      </p:sp>
+      <p:sp>
+        <p:nvSpPr>
+          <p:cNvPr id="5" name="">
+            <a:extLst xmlns:a="http://schemas.openxmlformats.org/drawingml/2006/main">
+              <a:ext uri="{FF2B5EF4-FFF2-40B4-BE49-F238E27FC236}">
+                <a16:creationId xmlns:a16="http://schemas.microsoft.com/office/drawing/2014/main" id="{C36B2336-81D9-4491-A122-FDD5596B0E7A}"/>
+              </a:ext>
+            </a:extLst>
+          </p:cNvPr>
+          <p:cNvSpPr>
+            <a:spLocks xmlns:a="http://schemas.openxmlformats.org/drawingml/2006/main" noGrp="1"/>
+          </p:cNvSpPr>
+          <p:nvPr/>
+        </p:nvSpPr>
+        <p:spPr>
+          <a:xfrm xmlns:a="http://schemas.openxmlformats.org/drawingml/2006/main">
+            <a:off x="685800" y="1066800"/>
+            <a:ext cx="8001000" cy="1143000"/>
           </a:xfrm>
           <a:prstGeom xmlns:a="http://schemas.openxmlformats.org/drawingml/2006/main" prst="rect">
             <a:avLst/>
@@ -2063,47 +2305,80 @@
           <a:lstStyle xmlns:a="http://schemas.openxmlformats.org/drawingml/2006/main"/>
           <a:p xmlns:a="http://schemas.openxmlformats.org/drawingml/2006/main">
             <a:pPr algn="l">
-              <a:defRPr sz="975" b="1">
-                <a:solidFill>
-                  <a:srgbClr val="C65D2E"/>
-                </a:solidFill>
-                <a:latin typeface="Aptos"/>
-                <a:ea typeface="Aptos"/>
-                <a:cs typeface="Aptos"/>
+              <a:defRPr sz="2250" b="1">
+                <a:solidFill>
+                  <a:srgbClr val="1E1B18"/>
+                </a:solidFill>
+                <a:latin typeface="Times New Roman"/>
+                <a:ea typeface="Times New Roman"/>
+                <a:cs typeface="Times New Roman"/>
               </a:defRPr>
             </a:pPr>
             <a:r>
-              <a:rPr sz="975" b="1">
-                <a:solidFill>
-                  <a:srgbClr val="C65D2E"/>
-                </a:solidFill>
-                <a:latin typeface="Aptos"/>
-                <a:ea typeface="Aptos"/>
-                <a:cs typeface="Aptos"/>
+              <a:rPr sz="2250" b="1">
+                <a:solidFill>
+                  <a:srgbClr val="1E1B18"/>
+                </a:solidFill>
+                <a:latin typeface="Times New Roman"/>
+                <a:ea typeface="Times New Roman"/>
+                <a:cs typeface="Times New Roman"/>
               </a:rPr>
-              <a:t>WORKFLOW</a:t>
+              <a:t>The automation loop is short enough to use every day.</a:t>
             </a:r>
           </a:p>
         </p:txBody>
       </p:sp>
       <p:sp>
         <p:nvSpPr>
-          <p:cNvPr id="3" name="">
-            <a:extLst xmlns:a="http://schemas.openxmlformats.org/drawingml/2006/main">
-              <a:ext uri="{FF2B5EF4-FFF2-40B4-BE49-F238E27FC236}">
-                <a16:creationId xmlns:a16="http://schemas.microsoft.com/office/drawing/2014/main" id="{103307B5-4A52-4FB0-A653-53E125419901}"/>
-              </a:ext>
-            </a:extLst>
-          </p:cNvPr>
-          <p:cNvSpPr>
-            <a:spLocks xmlns:a="http://schemas.openxmlformats.org/drawingml/2006/main" noGrp="1"/>
-          </p:cNvSpPr>
-          <p:nvPr/>
-        </p:nvSpPr>
-        <p:spPr>
-          <a:xfrm xmlns:a="http://schemas.openxmlformats.org/drawingml/2006/main">
-            <a:off x="609600" y="876300"/>
-            <a:ext cx="8382000" cy="914400"/>
+          <p:cNvPr id="6" name="">
+            <a:extLst xmlns:a="http://schemas.openxmlformats.org/drawingml/2006/main">
+              <a:ext uri="{FF2B5EF4-FFF2-40B4-BE49-F238E27FC236}">
+                <a16:creationId xmlns:a16="http://schemas.microsoft.com/office/drawing/2014/main" id="{B1A89E11-C20E-4171-A510-C594F0255BA4}"/>
+              </a:ext>
+            </a:extLst>
+          </p:cNvPr>
+          <p:cNvSpPr>
+            <a:spLocks xmlns:a="http://schemas.openxmlformats.org/drawingml/2006/main" noGrp="1"/>
+          </p:cNvSpPr>
+          <p:nvPr/>
+        </p:nvSpPr>
+        <p:spPr>
+          <a:xfrm xmlns:a="http://schemas.openxmlformats.org/drawingml/2006/main">
+            <a:off x="685800" y="2133600"/>
+            <a:ext cx="5524500" cy="3314700"/>
+          </a:xfrm>
+          <a:prstGeom xmlns:a="http://schemas.openxmlformats.org/drawingml/2006/main" prst="rect">
+            <a:avLst/>
+          </a:prstGeom>
+          <a:solidFill xmlns:a="http://schemas.openxmlformats.org/drawingml/2006/main">
+            <a:srgbClr val="FFF9F2"/>
+          </a:solidFill>
+          <a:ln xmlns:a="http://schemas.openxmlformats.org/drawingml/2006/main" w="9525">
+            <a:solidFill>
+              <a:srgbClr val="D6C8B8"/>
+            </a:solidFill>
+            <a:prstDash val="solid"/>
+          </a:ln>
+        </p:spPr>
+      </p:sp>
+      <p:sp>
+        <p:nvSpPr>
+          <p:cNvPr id="7" name="">
+            <a:extLst xmlns:a="http://schemas.openxmlformats.org/drawingml/2006/main">
+              <a:ext uri="{FF2B5EF4-FFF2-40B4-BE49-F238E27FC236}">
+                <a16:creationId xmlns:a16="http://schemas.microsoft.com/office/drawing/2014/main" id="{6422741E-6F2F-4027-99B5-7B33D54EC62B}"/>
+              </a:ext>
+            </a:extLst>
+          </p:cNvPr>
+          <p:cNvSpPr>
+            <a:spLocks xmlns:a="http://schemas.openxmlformats.org/drawingml/2006/main" noGrp="1"/>
+          </p:cNvSpPr>
+          <p:nvPr/>
+        </p:nvSpPr>
+        <p:spPr>
+          <a:xfrm xmlns:a="http://schemas.openxmlformats.org/drawingml/2006/main">
+            <a:off x="971550" y="2533650"/>
+            <a:ext cx="4857750" cy="2286000"/>
           </a:xfrm>
           <a:prstGeom xmlns:a="http://schemas.openxmlformats.org/drawingml/2006/main" prst="rect">
             <a:avLst/>
@@ -2127,127 +2402,30 @@
           <a:lstStyle xmlns:a="http://schemas.openxmlformats.org/drawingml/2006/main"/>
           <a:p xmlns:a="http://schemas.openxmlformats.org/drawingml/2006/main">
             <a:pPr algn="l">
-              <a:defRPr sz="2100" b="1">
+              <a:defRPr sz="1500" b="0">
                 <a:solidFill>
                   <a:srgbClr val="1E1B18"/>
                 </a:solidFill>
-                <a:latin typeface="Aptos Display"/>
-                <a:ea typeface="Aptos Display"/>
-                <a:cs typeface="Aptos Display"/>
+                <a:latin typeface="Aptos"/>
+                <a:ea typeface="Aptos"/>
+                <a:cs typeface="Aptos"/>
               </a:defRPr>
             </a:pPr>
             <a:r>
-              <a:rPr sz="2100" b="1">
+              <a:rPr sz="1500" b="0">
                 <a:solidFill>
                   <a:srgbClr val="1E1B18"/>
                 </a:solidFill>
-                <a:latin typeface="Aptos Display"/>
-                <a:ea typeface="Aptos Display"/>
-                <a:cs typeface="Aptos Display"/>
+                <a:latin typeface="Aptos"/>
+                <a:ea typeface="Aptos"/>
+                <a:cs typeface="Aptos"/>
               </a:rPr>
-              <a:t>The automation loop is short enough to use every day.</a:t>
-            </a:r>
-          </a:p>
-        </p:txBody>
-      </p:sp>
-      <p:sp>
-        <p:nvSpPr>
-          <p:cNvPr id="4" name="">
-            <a:extLst xmlns:a="http://schemas.openxmlformats.org/drawingml/2006/main">
-              <a:ext uri="{FF2B5EF4-FFF2-40B4-BE49-F238E27FC236}">
-                <a16:creationId xmlns:a16="http://schemas.microsoft.com/office/drawing/2014/main" id="{11F951B5-BF27-47E5-9FFF-69F34502028A}"/>
-              </a:ext>
-            </a:extLst>
-          </p:cNvPr>
-          <p:cNvSpPr>
-            <a:spLocks xmlns:a="http://schemas.openxmlformats.org/drawingml/2006/main" noGrp="1"/>
-          </p:cNvSpPr>
-          <p:nvPr/>
-        </p:nvSpPr>
-        <p:spPr>
-          <a:xfrm xmlns:a="http://schemas.openxmlformats.org/drawingml/2006/main">
-            <a:off x="609600" y="2057400"/>
-            <a:ext cx="6534150" cy="3581400"/>
-          </a:xfrm>
-          <a:prstGeom xmlns:a="http://schemas.openxmlformats.org/drawingml/2006/main" prst="rect">
-            <a:avLst/>
-          </a:prstGeom>
-          <a:solidFill xmlns:a="http://schemas.openxmlformats.org/drawingml/2006/main">
-            <a:srgbClr val="FFF9F2"/>
-          </a:solidFill>
-          <a:ln xmlns:a="http://schemas.openxmlformats.org/drawingml/2006/main" w="9525">
-            <a:solidFill>
-              <a:srgbClr val="D6C8B8"/>
-            </a:solidFill>
-            <a:prstDash val="solid"/>
-          </a:ln>
-        </p:spPr>
-      </p:sp>
-      <p:sp>
-        <p:nvSpPr>
-          <p:cNvPr id="5" name="">
-            <a:extLst xmlns:a="http://schemas.openxmlformats.org/drawingml/2006/main">
-              <a:ext uri="{FF2B5EF4-FFF2-40B4-BE49-F238E27FC236}">
-                <a16:creationId xmlns:a16="http://schemas.microsoft.com/office/drawing/2014/main" id="{49D1CA9C-40E4-48FA-B261-AA657B081959}"/>
-              </a:ext>
-            </a:extLst>
-          </p:cNvPr>
-          <p:cNvSpPr>
-            <a:spLocks xmlns:a="http://schemas.openxmlformats.org/drawingml/2006/main" noGrp="1"/>
-          </p:cNvSpPr>
-          <p:nvPr/>
-        </p:nvSpPr>
-        <p:spPr>
-          <a:xfrm xmlns:a="http://schemas.openxmlformats.org/drawingml/2006/main">
-            <a:off x="914400" y="2400300"/>
-            <a:ext cx="5734050" cy="2762250"/>
-          </a:xfrm>
-          <a:prstGeom xmlns:a="http://schemas.openxmlformats.org/drawingml/2006/main" prst="rect">
-            <a:avLst/>
-          </a:prstGeom>
-          <a:solidFill xmlns:a="http://schemas.openxmlformats.org/drawingml/2006/main">
-            <a:srgbClr val="000000">
-              <a:alpha val="0"/>
-            </a:srgbClr>
-          </a:solidFill>
-          <a:ln xmlns:a="http://schemas.openxmlformats.org/drawingml/2006/main" w="0">
-            <a:solidFill>
-              <a:srgbClr val="000000">
-                <a:alpha val="0"/>
-              </a:srgbClr>
-            </a:solidFill>
-            <a:prstDash val="solid"/>
-          </a:ln>
-        </p:spPr>
-        <p:txBody>
-          <a:bodyPr xmlns:a="http://schemas.openxmlformats.org/drawingml/2006/main" lIns="38100" tIns="38100" rIns="38100" bIns="38100" anchor="t"/>
-          <a:lstStyle xmlns:a="http://schemas.openxmlformats.org/drawingml/2006/main"/>
-          <a:p xmlns:a="http://schemas.openxmlformats.org/drawingml/2006/main">
-            <a:pPr algn="l">
-              <a:defRPr sz="1650" b="0">
-                <a:solidFill>
-                  <a:srgbClr val="1E1B18"/>
-                </a:solidFill>
-                <a:latin typeface="Aptos"/>
-                <a:ea typeface="Aptos"/>
-                <a:cs typeface="Aptos"/>
-              </a:defRPr>
-            </a:pPr>
-            <a:r>
-              <a:rPr sz="1650" b="0">
-                <a:solidFill>
-                  <a:srgbClr val="1E1B18"/>
-                </a:solidFill>
-                <a:latin typeface="Aptos"/>
-                <a:ea typeface="Aptos"/>
-                <a:cs typeface="Aptos"/>
-              </a:rPr>
-              <a:t>- Keep the deck request in a small JSON brief.</a:t>
+              <a:t>• Keep the deck request in a small JSON brief.</a:t>
             </a:r>
           </a:p>
           <a:p xmlns:a="http://schemas.openxmlformats.org/drawingml/2006/main">
             <a:pPr algn="l">
-              <a:defRPr sz="1650" b="0">
+              <a:defRPr sz="1500" b="0">
                 <a:solidFill>
                   <a:srgbClr val="1E1B18"/>
                 </a:solidFill>
@@ -2257,7 +2435,7 @@
               </a:defRPr>
             </a:pPr>
             <a:r>
-              <a:rPr sz="1650" b="0">
+              <a:rPr sz="1500" b="0">
                 <a:solidFill>
                   <a:srgbClr val="1E1B18"/>
                 </a:solidFill>
@@ -2265,12 +2443,12 @@
                 <a:ea typeface="Aptos"/>
                 <a:cs typeface="Aptos"/>
               </a:rPr>
-              <a:t>- Ask Codex to update that brief or generate a new one.</a:t>
+              <a:t>• Ask Codex to update that brief or generate a new one.</a:t>
             </a:r>
           </a:p>
           <a:p xmlns:a="http://schemas.openxmlformats.org/drawingml/2006/main">
             <a:pPr algn="l">
-              <a:defRPr sz="1650" b="0">
+              <a:defRPr sz="1500" b="0">
                 <a:solidFill>
                   <a:srgbClr val="1E1B18"/>
                 </a:solidFill>
@@ -2280,7 +2458,7 @@
               </a:defRPr>
             </a:pPr>
             <a:r>
-              <a:rPr sz="1650" b="0">
+              <a:rPr sz="1500" b="0">
                 <a:solidFill>
                   <a:srgbClr val="1E1B18"/>
                 </a:solidFill>
@@ -2288,12 +2466,12 @@
                 <a:ea typeface="Aptos"/>
                 <a:cs typeface="Aptos"/>
               </a:rPr>
-              <a:t>- Run one build command from VSCode or the terminal.</a:t>
+              <a:t>• Run one build command from VSCode or the terminal.</a:t>
             </a:r>
           </a:p>
           <a:p xmlns:a="http://schemas.openxmlformats.org/drawingml/2006/main">
             <a:pPr algn="l">
-              <a:defRPr sz="1650" b="0">
+              <a:defRPr sz="1500" b="0">
                 <a:solidFill>
                   <a:srgbClr val="1E1B18"/>
                 </a:solidFill>
@@ -2303,7 +2481,7 @@
               </a:defRPr>
             </a:pPr>
             <a:r>
-              <a:rPr sz="1650" b="0">
+              <a:rPr sz="1500" b="0">
                 <a:solidFill>
                   <a:srgbClr val="1E1B18"/>
                 </a:solidFill>
@@ -2311,62 +2489,64 @@
                 <a:ea typeface="Aptos"/>
                 <a:cs typeface="Aptos"/>
               </a:rPr>
-              <a:t>- Open the exported .pptx and make final edits in PowerPoint.</a:t>
+              <a:t>• Open the exported .pptx and make final edits in PowerPoint.</a:t>
             </a:r>
           </a:p>
         </p:txBody>
       </p:sp>
       <p:sp>
         <p:nvSpPr>
-          <p:cNvPr id="6" name="">
-            <a:extLst xmlns:a="http://schemas.openxmlformats.org/drawingml/2006/main">
-              <a:ext uri="{FF2B5EF4-FFF2-40B4-BE49-F238E27FC236}">
-                <a16:creationId xmlns:a16="http://schemas.microsoft.com/office/drawing/2014/main" id="{122449A0-C9FE-4A26-92C7-90803B9A4C33}"/>
-              </a:ext>
-            </a:extLst>
-          </p:cNvPr>
-          <p:cNvSpPr>
-            <a:spLocks xmlns:a="http://schemas.openxmlformats.org/drawingml/2006/main" noGrp="1"/>
-          </p:cNvSpPr>
-          <p:nvPr/>
-        </p:nvSpPr>
-        <p:spPr>
-          <a:xfrm xmlns:a="http://schemas.openxmlformats.org/drawingml/2006/main">
-            <a:off x="7524750" y="2057400"/>
-            <a:ext cx="4057650" cy="3581400"/>
-          </a:xfrm>
-          <a:prstGeom xmlns:a="http://schemas.openxmlformats.org/drawingml/2006/main" prst="rect">
-            <a:avLst/>
-          </a:prstGeom>
-          <a:solidFill xmlns:a="http://schemas.openxmlformats.org/drawingml/2006/main">
-            <a:srgbClr val="C65D2E"/>
-          </a:solidFill>
-          <a:ln xmlns:a="http://schemas.openxmlformats.org/drawingml/2006/main" w="9525">
-            <a:solidFill>
-              <a:srgbClr val="C65D2E"/>
-            </a:solidFill>
-            <a:prstDash val="solid"/>
-          </a:ln>
-        </p:spPr>
-      </p:sp>
-      <p:sp>
-        <p:nvSpPr>
-          <p:cNvPr id="7" name="">
-            <a:extLst xmlns:a="http://schemas.openxmlformats.org/drawingml/2006/main">
-              <a:ext uri="{FF2B5EF4-FFF2-40B4-BE49-F238E27FC236}">
-                <a16:creationId xmlns:a16="http://schemas.microsoft.com/office/drawing/2014/main" id="{E4F6B4A2-CCA3-459E-899B-1B52A9AED303}"/>
-              </a:ext>
-            </a:extLst>
-          </p:cNvPr>
-          <p:cNvSpPr>
-            <a:spLocks xmlns:a="http://schemas.openxmlformats.org/drawingml/2006/main" noGrp="1"/>
-          </p:cNvSpPr>
-          <p:nvPr/>
-        </p:nvSpPr>
-        <p:spPr>
-          <a:xfrm xmlns:a="http://schemas.openxmlformats.org/drawingml/2006/main">
-            <a:off x="7848600" y="2381250"/>
-            <a:ext cx="1143000" cy="190500"/>
+          <p:cNvPr id="8" name="">
+            <a:extLst xmlns:a="http://schemas.openxmlformats.org/drawingml/2006/main">
+              <a:ext uri="{FF2B5EF4-FFF2-40B4-BE49-F238E27FC236}">
+                <a16:creationId xmlns:a16="http://schemas.microsoft.com/office/drawing/2014/main" id="{99EECF45-517B-40C1-8C17-799B387C3A4C}"/>
+              </a:ext>
+            </a:extLst>
+          </p:cNvPr>
+          <p:cNvSpPr>
+            <a:spLocks xmlns:a="http://schemas.openxmlformats.org/drawingml/2006/main" noGrp="1"/>
+          </p:cNvSpPr>
+          <p:nvPr/>
+        </p:nvSpPr>
+        <p:spPr>
+          <a:xfrm xmlns:a="http://schemas.openxmlformats.org/drawingml/2006/main">
+            <a:off x="6534150" y="2133600"/>
+            <a:ext cx="4972050" cy="2171700"/>
+          </a:xfrm>
+          <a:prstGeom xmlns:a="http://schemas.openxmlformats.org/drawingml/2006/main" prst="rect">
+            <a:avLst/>
+          </a:prstGeom>
+          <a:solidFill xmlns:a="http://schemas.openxmlformats.org/drawingml/2006/main">
+            <a:srgbClr val="1F2738"/>
+          </a:solidFill>
+          <a:ln xmlns:a="http://schemas.openxmlformats.org/drawingml/2006/main" w="0">
+            <a:solidFill>
+              <a:srgbClr val="000000">
+                <a:alpha val="0"/>
+              </a:srgbClr>
+            </a:solidFill>
+            <a:prstDash val="solid"/>
+          </a:ln>
+        </p:spPr>
+      </p:sp>
+      <p:sp>
+        <p:nvSpPr>
+          <p:cNvPr id="9" name="">
+            <a:extLst xmlns:a="http://schemas.openxmlformats.org/drawingml/2006/main">
+              <a:ext uri="{FF2B5EF4-FFF2-40B4-BE49-F238E27FC236}">
+                <a16:creationId xmlns:a16="http://schemas.microsoft.com/office/drawing/2014/main" id="{E8947F91-BE7F-4F33-A9EE-394E49A64F8B}"/>
+              </a:ext>
+            </a:extLst>
+          </p:cNvPr>
+          <p:cNvSpPr>
+            <a:spLocks xmlns:a="http://schemas.openxmlformats.org/drawingml/2006/main" noGrp="1"/>
+          </p:cNvSpPr>
+          <p:nvPr/>
+        </p:nvSpPr>
+        <p:spPr>
+          <a:xfrm xmlns:a="http://schemas.openxmlformats.org/drawingml/2006/main">
+            <a:off x="6877050" y="2457450"/>
+            <a:ext cx="1143000" cy="152400"/>
           </a:xfrm>
           <a:prstGeom xmlns:a="http://schemas.openxmlformats.org/drawingml/2006/main" prst="rect">
             <a:avLst/>
@@ -2390,9 +2570,9 @@
           <a:lstStyle xmlns:a="http://schemas.openxmlformats.org/drawingml/2006/main"/>
           <a:p xmlns:a="http://schemas.openxmlformats.org/drawingml/2006/main">
             <a:pPr algn="l">
-              <a:defRPr sz="900" b="1">
-                <a:solidFill>
-                  <a:srgbClr val="FFF8F0"/>
+              <a:defRPr sz="750" b="1">
+                <a:solidFill>
+                  <a:srgbClr val="E7B08B"/>
                 </a:solidFill>
                 <a:latin typeface="Aptos"/>
                 <a:ea typeface="Aptos"/>
@@ -2400,9 +2580,9 @@
               </a:defRPr>
             </a:pPr>
             <a:r>
-              <a:rPr sz="900" b="1">
-                <a:solidFill>
-                  <a:srgbClr val="FFF8F0"/>
+              <a:rPr sz="750" b="1">
+                <a:solidFill>
+                  <a:srgbClr val="E7B08B"/>
                 </a:solidFill>
                 <a:latin typeface="Aptos"/>
                 <a:ea typeface="Aptos"/>
@@ -2415,22 +2595,22 @@
       </p:sp>
       <p:sp>
         <p:nvSpPr>
-          <p:cNvPr id="8" name="">
-            <a:extLst xmlns:a="http://schemas.openxmlformats.org/drawingml/2006/main">
-              <a:ext uri="{FF2B5EF4-FFF2-40B4-BE49-F238E27FC236}">
-                <a16:creationId xmlns:a16="http://schemas.microsoft.com/office/drawing/2014/main" id="{45527FC6-0C0A-4F70-BCF0-B95A85686923}"/>
-              </a:ext>
-            </a:extLst>
-          </p:cNvPr>
-          <p:cNvSpPr>
-            <a:spLocks xmlns:a="http://schemas.openxmlformats.org/drawingml/2006/main" noGrp="1"/>
-          </p:cNvSpPr>
-          <p:nvPr/>
-        </p:nvSpPr>
-        <p:spPr>
-          <a:xfrm xmlns:a="http://schemas.openxmlformats.org/drawingml/2006/main">
-            <a:off x="7848600" y="2781300"/>
-            <a:ext cx="3143250" cy="2095500"/>
+          <p:cNvPr id="10" name="">
+            <a:extLst xmlns:a="http://schemas.openxmlformats.org/drawingml/2006/main">
+              <a:ext uri="{FF2B5EF4-FFF2-40B4-BE49-F238E27FC236}">
+                <a16:creationId xmlns:a16="http://schemas.microsoft.com/office/drawing/2014/main" id="{05DE316C-7B1E-4A98-A8B5-4CD999A961A1}"/>
+              </a:ext>
+            </a:extLst>
+          </p:cNvPr>
+          <p:cNvSpPr>
+            <a:spLocks xmlns:a="http://schemas.openxmlformats.org/drawingml/2006/main" noGrp="1"/>
+          </p:cNvSpPr>
+          <p:nvPr/>
+        </p:nvSpPr>
+        <p:spPr>
+          <a:xfrm xmlns:a="http://schemas.openxmlformats.org/drawingml/2006/main">
+            <a:off x="6877050" y="2857500"/>
+            <a:ext cx="4000500" cy="1047750"/>
           </a:xfrm>
           <a:prstGeom xmlns:a="http://schemas.openxmlformats.org/drawingml/2006/main" prst="rect">
             <a:avLst/>
@@ -2450,27 +2630,27 @@
           </a:ln>
         </p:spPr>
         <p:txBody>
-          <a:bodyPr xmlns:a="http://schemas.openxmlformats.org/drawingml/2006/main" lIns="19050" tIns="19050" rIns="19050" bIns="19050" anchor="t"/>
+          <a:bodyPr xmlns:a="http://schemas.openxmlformats.org/drawingml/2006/main" lIns="0" tIns="0" rIns="0" bIns="0" anchor="t"/>
           <a:lstStyle xmlns:a="http://schemas.openxmlformats.org/drawingml/2006/main"/>
           <a:p xmlns:a="http://schemas.openxmlformats.org/drawingml/2006/main">
             <a:pPr algn="l">
-              <a:defRPr sz="1500" b="0">
+              <a:defRPr sz="1650" b="0">
                 <a:solidFill>
                   <a:srgbClr val="FFF8F0"/>
                 </a:solidFill>
-                <a:latin typeface="Aptos"/>
-                <a:ea typeface="Aptos"/>
-                <a:cs typeface="Aptos"/>
+                <a:latin typeface="Times New Roman"/>
+                <a:ea typeface="Times New Roman"/>
+                <a:cs typeface="Times New Roman"/>
               </a:defRPr>
             </a:pPr>
             <a:r>
-              <a:rPr sz="1500" b="0">
+              <a:rPr sz="1650" b="0">
                 <a:solidFill>
                   <a:srgbClr val="FFF8F0"/>
                 </a:solidFill>
-                <a:latin typeface="Aptos"/>
-                <a:ea typeface="Aptos"/>
-                <a:cs typeface="Aptos"/>
+                <a:latin typeface="Times New Roman"/>
+                <a:ea typeface="Times New Roman"/>
+                <a:cs typeface="Times New Roman"/>
               </a:rPr>
               <a:t>The deck is created with the built-in Codex Presentations runtime, so the result stays editable.</a:t>
             </a:r>
@@ -2479,22 +2659,57 @@
       </p:sp>
       <p:sp>
         <p:nvSpPr>
-          <p:cNvPr id="9" name="">
-            <a:extLst xmlns:a="http://schemas.openxmlformats.org/drawingml/2006/main">
-              <a:ext uri="{FF2B5EF4-FFF2-40B4-BE49-F238E27FC236}">
-                <a16:creationId xmlns:a16="http://schemas.microsoft.com/office/drawing/2014/main" id="{11F82B47-ECEB-47E4-86F2-1516645512A1}"/>
-              </a:ext>
-            </a:extLst>
-          </p:cNvPr>
-          <p:cNvSpPr>
-            <a:spLocks xmlns:a="http://schemas.openxmlformats.org/drawingml/2006/main" noGrp="1"/>
-          </p:cNvSpPr>
-          <p:nvPr/>
-        </p:nvSpPr>
-        <p:spPr>
-          <a:xfrm xmlns:a="http://schemas.openxmlformats.org/drawingml/2006/main">
-            <a:off x="609600" y="6477000"/>
-            <a:ext cx="10972800" cy="9525"/>
+          <p:cNvPr id="11" name="">
+            <a:extLst xmlns:a="http://schemas.openxmlformats.org/drawingml/2006/main">
+              <a:ext uri="{FF2B5EF4-FFF2-40B4-BE49-F238E27FC236}">
+                <a16:creationId xmlns:a16="http://schemas.microsoft.com/office/drawing/2014/main" id="{C5C19A4D-D5F9-428A-8C7D-E232BCD44B20}"/>
+              </a:ext>
+            </a:extLst>
+          </p:cNvPr>
+          <p:cNvSpPr>
+            <a:spLocks xmlns:a="http://schemas.openxmlformats.org/drawingml/2006/main" noGrp="1"/>
+          </p:cNvSpPr>
+          <p:nvPr/>
+        </p:nvSpPr>
+        <p:spPr>
+          <a:xfrm xmlns:a="http://schemas.openxmlformats.org/drawingml/2006/main">
+            <a:off x="6534150" y="4476750"/>
+            <a:ext cx="4972050" cy="1257300"/>
+          </a:xfrm>
+          <a:prstGeom xmlns:a="http://schemas.openxmlformats.org/drawingml/2006/main" prst="rect">
+            <a:avLst/>
+          </a:prstGeom>
+          <a:solidFill xmlns:a="http://schemas.openxmlformats.org/drawingml/2006/main">
+            <a:srgbClr val="000000">
+              <a:alpha val="0"/>
+            </a:srgbClr>
+          </a:solidFill>
+          <a:ln xmlns:a="http://schemas.openxmlformats.org/drawingml/2006/main" w="9525">
+            <a:solidFill>
+              <a:srgbClr val="D6C8B8"/>
+            </a:solidFill>
+            <a:prstDash val="solid"/>
+          </a:ln>
+        </p:spPr>
+      </p:sp>
+      <p:sp>
+        <p:nvSpPr>
+          <p:cNvPr id="12" name="">
+            <a:extLst xmlns:a="http://schemas.openxmlformats.org/drawingml/2006/main">
+              <a:ext uri="{FF2B5EF4-FFF2-40B4-BE49-F238E27FC236}">
+                <a16:creationId xmlns:a16="http://schemas.microsoft.com/office/drawing/2014/main" id="{DCA542F4-2736-4CA6-B207-944C136B3F28}"/>
+              </a:ext>
+            </a:extLst>
+          </p:cNvPr>
+          <p:cNvSpPr>
+            <a:spLocks xmlns:a="http://schemas.openxmlformats.org/drawingml/2006/main" noGrp="1"/>
+          </p:cNvSpPr>
+          <p:nvPr/>
+        </p:nvSpPr>
+        <p:spPr>
+          <a:xfrm xmlns:a="http://schemas.openxmlformats.org/drawingml/2006/main">
+            <a:off x="685800" y="6438900"/>
+            <a:ext cx="10820400" cy="9525"/>
           </a:xfrm>
           <a:prstGeom xmlns:a="http://schemas.openxmlformats.org/drawingml/2006/main" prst="rect">
             <a:avLst/>
@@ -2504,30 +2719,32 @@
           </a:solidFill>
           <a:ln xmlns:a="http://schemas.openxmlformats.org/drawingml/2006/main" w="0">
             <a:solidFill>
-              <a:srgbClr val="D6C8B8"/>
-            </a:solidFill>
-            <a:prstDash val="solid"/>
-          </a:ln>
-        </p:spPr>
-      </p:sp>
-      <p:sp>
-        <p:nvSpPr>
-          <p:cNvPr id="10" name="">
-            <a:extLst xmlns:a="http://schemas.openxmlformats.org/drawingml/2006/main">
-              <a:ext uri="{FF2B5EF4-FFF2-40B4-BE49-F238E27FC236}">
-                <a16:creationId xmlns:a16="http://schemas.microsoft.com/office/drawing/2014/main" id="{AB690BAA-71ED-4710-8F3D-5E44BFE4A2DD}"/>
-              </a:ext>
-            </a:extLst>
-          </p:cNvPr>
-          <p:cNvSpPr>
-            <a:spLocks xmlns:a="http://schemas.openxmlformats.org/drawingml/2006/main" noGrp="1"/>
-          </p:cNvSpPr>
-          <p:nvPr/>
-        </p:nvSpPr>
-        <p:spPr>
-          <a:xfrm xmlns:a="http://schemas.openxmlformats.org/drawingml/2006/main">
-            <a:off x="609600" y="6572250"/>
-            <a:ext cx="3048000" cy="171450"/>
+              <a:srgbClr val="000000">
+                <a:alpha val="0"/>
+              </a:srgbClr>
+            </a:solidFill>
+            <a:prstDash val="solid"/>
+          </a:ln>
+        </p:spPr>
+      </p:sp>
+      <p:sp>
+        <p:nvSpPr>
+          <p:cNvPr id="13" name="">
+            <a:extLst xmlns:a="http://schemas.openxmlformats.org/drawingml/2006/main">
+              <a:ext uri="{FF2B5EF4-FFF2-40B4-BE49-F238E27FC236}">
+                <a16:creationId xmlns:a16="http://schemas.microsoft.com/office/drawing/2014/main" id="{98FFA1C2-D54F-4DDB-A15E-C3C3B5E94830}"/>
+              </a:ext>
+            </a:extLst>
+          </p:cNvPr>
+          <p:cNvSpPr>
+            <a:spLocks xmlns:a="http://schemas.openxmlformats.org/drawingml/2006/main" noGrp="1"/>
+          </p:cNvSpPr>
+          <p:nvPr/>
+        </p:nvSpPr>
+        <p:spPr>
+          <a:xfrm xmlns:a="http://schemas.openxmlformats.org/drawingml/2006/main">
+            <a:off x="685800" y="6543675"/>
+            <a:ext cx="3048000" cy="152400"/>
           </a:xfrm>
           <a:prstGeom xmlns:a="http://schemas.openxmlformats.org/drawingml/2006/main" prst="rect">
             <a:avLst/>
@@ -2551,7 +2768,7 @@
           <a:lstStyle xmlns:a="http://schemas.openxmlformats.org/drawingml/2006/main"/>
           <a:p xmlns:a="http://schemas.openxmlformats.org/drawingml/2006/main">
             <a:pPr algn="l">
-              <a:defRPr sz="750" b="0">
+              <a:defRPr sz="675" b="0">
                 <a:solidFill>
                   <a:srgbClr val="6B6258"/>
                 </a:solidFill>
@@ -2561,7 +2778,7 @@
               </a:defRPr>
             </a:pPr>
             <a:r>
-              <a:rPr sz="750" b="0">
+              <a:rPr sz="675" b="0">
                 <a:solidFill>
                   <a:srgbClr val="6B6258"/>
                 </a:solidFill>
@@ -2576,22 +2793,22 @@
       </p:sp>
       <p:sp>
         <p:nvSpPr>
-          <p:cNvPr id="11" name="">
-            <a:extLst xmlns:a="http://schemas.openxmlformats.org/drawingml/2006/main">
-              <a:ext uri="{FF2B5EF4-FFF2-40B4-BE49-F238E27FC236}">
-                <a16:creationId xmlns:a16="http://schemas.microsoft.com/office/drawing/2014/main" id="{BA69368B-DA13-49ED-8366-0E938B08E739}"/>
-              </a:ext>
-            </a:extLst>
-          </p:cNvPr>
-          <p:cNvSpPr>
-            <a:spLocks xmlns:a="http://schemas.openxmlformats.org/drawingml/2006/main" noGrp="1"/>
-          </p:cNvSpPr>
-          <p:nvPr/>
-        </p:nvSpPr>
-        <p:spPr>
-          <a:xfrm xmlns:a="http://schemas.openxmlformats.org/drawingml/2006/main">
-            <a:off x="10858500" y="6572250"/>
-            <a:ext cx="723900" cy="171450"/>
+          <p:cNvPr id="14" name="">
+            <a:extLst xmlns:a="http://schemas.openxmlformats.org/drawingml/2006/main">
+              <a:ext uri="{FF2B5EF4-FFF2-40B4-BE49-F238E27FC236}">
+                <a16:creationId xmlns:a16="http://schemas.microsoft.com/office/drawing/2014/main" id="{0983896B-2CC1-46C0-B794-7484BCA00649}"/>
+              </a:ext>
+            </a:extLst>
+          </p:cNvPr>
+          <p:cNvSpPr>
+            <a:spLocks xmlns:a="http://schemas.openxmlformats.org/drawingml/2006/main" noGrp="1"/>
+          </p:cNvSpPr>
+          <p:nvPr/>
+        </p:nvSpPr>
+        <p:spPr>
+          <a:xfrm xmlns:a="http://schemas.openxmlformats.org/drawingml/2006/main">
+            <a:off x="10953750" y="6543675"/>
+            <a:ext cx="571500" cy="152400"/>
           </a:xfrm>
           <a:prstGeom xmlns:a="http://schemas.openxmlformats.org/drawingml/2006/main" prst="rect">
             <a:avLst/>
@@ -2615,7 +2832,7 @@
           <a:lstStyle xmlns:a="http://schemas.openxmlformats.org/drawingml/2006/main"/>
           <a:p xmlns:a="http://schemas.openxmlformats.org/drawingml/2006/main">
             <a:pPr algn="r">
-              <a:defRPr sz="750" b="0">
+              <a:defRPr sz="675" b="0">
                 <a:solidFill>
                   <a:srgbClr val="6B6258"/>
                 </a:solidFill>
@@ -2625,7 +2842,7 @@
               </a:defRPr>
             </a:pPr>
             <a:r>
-              <a:rPr sz="750" b="0">
+              <a:rPr sz="675" b="0">
                 <a:solidFill>
                   <a:srgbClr val="6B6258"/>
                 </a:solidFill>
@@ -2641,7 +2858,7 @@
     </p:spTree>
     <p:extLst>
       <p:ext uri="{BB962C8B-B14F-4D97-AF65-F5344CB8AC3E}">
-        <p14:creationId xmlns:p14="http://schemas.microsoft.com/office/powerpoint/2010/main" val="1641231653"/>
+        <p14:creationId xmlns:p14="http://schemas.microsoft.com/office/powerpoint/2010/main" val="225118556"/>
       </p:ext>
     </p:extLst>
   </p:cSld>
@@ -2662,10 +2879,10 @@
       </p:grpSpPr>
       <p:sp>
         <p:nvSpPr>
-          <p:cNvPr id="1" name="">
-            <a:extLst xmlns:a="http://schemas.openxmlformats.org/drawingml/2006/main">
-              <a:ext uri="{FF2B5EF4-FFF2-40B4-BE49-F238E27FC236}">
-                <a16:creationId xmlns:a16="http://schemas.microsoft.com/office/drawing/2014/main" id="{AB214EE3-1C23-4EE9-87A9-34F8CA983729}"/>
+          <p:cNvPr id="26" name="">
+            <a:extLst xmlns:a="http://schemas.openxmlformats.org/drawingml/2006/main">
+              <a:ext uri="{FF2B5EF4-FFF2-40B4-BE49-F238E27FC236}">
+                <a16:creationId xmlns:a16="http://schemas.microsoft.com/office/drawing/2014/main" id="{73415FBE-93E8-4888-A76B-AC7427F03068}"/>
               </a:ext>
             </a:extLst>
           </p:cNvPr>
@@ -2683,7 +2900,7 @@
             <a:avLst/>
           </a:prstGeom>
           <a:solidFill xmlns:a="http://schemas.openxmlformats.org/drawingml/2006/main">
-            <a:srgbClr val="F6F1E8"/>
+            <a:srgbClr val="1F2738"/>
           </a:solidFill>
           <a:ln xmlns:a="http://schemas.openxmlformats.org/drawingml/2006/main" w="0">
             <a:solidFill>
@@ -2700,19 +2917,153 @@
           <p:cNvPr id="2" name="">
             <a:extLst xmlns:a="http://schemas.openxmlformats.org/drawingml/2006/main">
               <a:ext uri="{FF2B5EF4-FFF2-40B4-BE49-F238E27FC236}">
-                <a16:creationId xmlns:a16="http://schemas.microsoft.com/office/drawing/2014/main" id="{4447C281-8C35-40E7-B36F-7D16D553ECC0}"/>
-              </a:ext>
-            </a:extLst>
-          </p:cNvPr>
-          <p:cNvSpPr>
-            <a:spLocks xmlns:a="http://schemas.openxmlformats.org/drawingml/2006/main" noGrp="1"/>
-          </p:cNvSpPr>
-          <p:nvPr/>
-        </p:nvSpPr>
-        <p:spPr>
-          <a:xfrm xmlns:a="http://schemas.openxmlformats.org/drawingml/2006/main">
-            <a:off x="609600" y="476250"/>
-            <a:ext cx="2286000" cy="266700"/>
+                <a16:creationId xmlns:a16="http://schemas.microsoft.com/office/drawing/2014/main" id="{CF12E149-03EA-4BD2-A31D-38E4C00E6CB0}"/>
+              </a:ext>
+            </a:extLst>
+          </p:cNvPr>
+          <p:cNvSpPr>
+            <a:spLocks xmlns:a="http://schemas.openxmlformats.org/drawingml/2006/main" noGrp="1"/>
+          </p:cNvSpPr>
+          <p:nvPr/>
+        </p:nvSpPr>
+        <p:spPr>
+          <a:xfrm xmlns:a="http://schemas.openxmlformats.org/drawingml/2006/main">
+            <a:off x="0" y="0"/>
+            <a:ext cx="12192000" cy="266700"/>
+          </a:xfrm>
+          <a:prstGeom xmlns:a="http://schemas.openxmlformats.org/drawingml/2006/main" prst="rect">
+            <a:avLst/>
+          </a:prstGeom>
+          <a:solidFill xmlns:a="http://schemas.openxmlformats.org/drawingml/2006/main">
+            <a:srgbClr val="C65D2E"/>
+          </a:solidFill>
+          <a:ln xmlns:a="http://schemas.openxmlformats.org/drawingml/2006/main" w="0">
+            <a:solidFill>
+              <a:srgbClr val="000000">
+                <a:alpha val="0"/>
+              </a:srgbClr>
+            </a:solidFill>
+            <a:prstDash val="solid"/>
+          </a:ln>
+        </p:spPr>
+      </p:sp>
+      <p:sp>
+        <p:nvSpPr>
+          <p:cNvPr id="3" name="">
+            <a:extLst xmlns:a="http://schemas.openxmlformats.org/drawingml/2006/main">
+              <a:ext uri="{FF2B5EF4-FFF2-40B4-BE49-F238E27FC236}">
+                <a16:creationId xmlns:a16="http://schemas.microsoft.com/office/drawing/2014/main" id="{D8E29843-23E2-4AEB-88B2-8090E9481EDE}"/>
+              </a:ext>
+            </a:extLst>
+          </p:cNvPr>
+          <p:cNvSpPr>
+            <a:spLocks xmlns:a="http://schemas.openxmlformats.org/drawingml/2006/main" noGrp="1"/>
+          </p:cNvSpPr>
+          <p:nvPr/>
+        </p:nvSpPr>
+        <p:spPr>
+          <a:xfrm xmlns:a="http://schemas.openxmlformats.org/drawingml/2006/main">
+            <a:off x="685800" y="647700"/>
+            <a:ext cx="1790700" cy="228600"/>
+          </a:xfrm>
+          <a:prstGeom xmlns:a="http://schemas.openxmlformats.org/drawingml/2006/main" prst="rect">
+            <a:avLst/>
+          </a:prstGeom>
+          <a:solidFill xmlns:a="http://schemas.openxmlformats.org/drawingml/2006/main">
+            <a:srgbClr val="C65D2E"/>
+          </a:solidFill>
+          <a:ln xmlns:a="http://schemas.openxmlformats.org/drawingml/2006/main" w="0">
+            <a:solidFill>
+              <a:srgbClr val="000000">
+                <a:alpha val="0"/>
+              </a:srgbClr>
+            </a:solidFill>
+            <a:prstDash val="solid"/>
+          </a:ln>
+        </p:spPr>
+      </p:sp>
+      <p:sp>
+        <p:nvSpPr>
+          <p:cNvPr id="4" name="">
+            <a:extLst xmlns:a="http://schemas.openxmlformats.org/drawingml/2006/main">
+              <a:ext uri="{FF2B5EF4-FFF2-40B4-BE49-F238E27FC236}">
+                <a16:creationId xmlns:a16="http://schemas.microsoft.com/office/drawing/2014/main" id="{8802A5D8-8E44-4615-A592-53B50319B438}"/>
+              </a:ext>
+            </a:extLst>
+          </p:cNvPr>
+          <p:cNvSpPr>
+            <a:spLocks xmlns:a="http://schemas.openxmlformats.org/drawingml/2006/main" noGrp="1"/>
+          </p:cNvSpPr>
+          <p:nvPr/>
+        </p:nvSpPr>
+        <p:spPr>
+          <a:xfrm xmlns:a="http://schemas.openxmlformats.org/drawingml/2006/main">
+            <a:off x="781050" y="685800"/>
+            <a:ext cx="1600200" cy="152400"/>
+          </a:xfrm>
+          <a:prstGeom xmlns:a="http://schemas.openxmlformats.org/drawingml/2006/main" prst="rect">
+            <a:avLst/>
+          </a:prstGeom>
+          <a:solidFill xmlns:a="http://schemas.openxmlformats.org/drawingml/2006/main">
+            <a:srgbClr val="000000">
+              <a:alpha val="0"/>
+            </a:srgbClr>
+          </a:solidFill>
+          <a:ln xmlns:a="http://schemas.openxmlformats.org/drawingml/2006/main" w="0">
+            <a:solidFill>
+              <a:srgbClr val="000000">
+                <a:alpha val="0"/>
+              </a:srgbClr>
+            </a:solidFill>
+            <a:prstDash val="solid"/>
+          </a:ln>
+        </p:spPr>
+        <p:txBody>
+          <a:bodyPr xmlns:a="http://schemas.openxmlformats.org/drawingml/2006/main" lIns="0" tIns="0" rIns="0" bIns="0" anchor="t"/>
+          <a:lstStyle xmlns:a="http://schemas.openxmlformats.org/drawingml/2006/main"/>
+          <a:p xmlns:a="http://schemas.openxmlformats.org/drawingml/2006/main">
+            <a:pPr algn="ctr">
+              <a:defRPr sz="750" b="1">
+                <a:solidFill>
+                  <a:srgbClr val="FFF8F0"/>
+                </a:solidFill>
+                <a:latin typeface="Aptos"/>
+                <a:ea typeface="Aptos"/>
+                <a:cs typeface="Aptos"/>
+              </a:defRPr>
+            </a:pPr>
+            <a:r>
+              <a:rPr sz="750" b="1">
+                <a:solidFill>
+                  <a:srgbClr val="FFF8F0"/>
+                </a:solidFill>
+                <a:latin typeface="Aptos"/>
+                <a:ea typeface="Aptos"/>
+                <a:cs typeface="Aptos"/>
+              </a:rPr>
+              <a:t>PROOF</a:t>
+            </a:r>
+          </a:p>
+        </p:txBody>
+      </p:sp>
+      <p:sp>
+        <p:nvSpPr>
+          <p:cNvPr id="5" name="">
+            <a:extLst xmlns:a="http://schemas.openxmlformats.org/drawingml/2006/main">
+              <a:ext uri="{FF2B5EF4-FFF2-40B4-BE49-F238E27FC236}">
+                <a16:creationId xmlns:a16="http://schemas.microsoft.com/office/drawing/2014/main" id="{F67DAA61-3A8F-4AD1-BA20-615D6E995F18}"/>
+              </a:ext>
+            </a:extLst>
+          </p:cNvPr>
+          <p:cNvSpPr>
+            <a:spLocks xmlns:a="http://schemas.openxmlformats.org/drawingml/2006/main" noGrp="1"/>
+          </p:cNvSpPr>
+          <p:nvPr/>
+        </p:nvSpPr>
+        <p:spPr>
+          <a:xfrm xmlns:a="http://schemas.openxmlformats.org/drawingml/2006/main">
+            <a:off x="685800" y="1143000"/>
+            <a:ext cx="7810500" cy="857250"/>
           </a:xfrm>
           <a:prstGeom xmlns:a="http://schemas.openxmlformats.org/drawingml/2006/main" prst="rect">
             <a:avLst/>
@@ -2736,47 +3087,115 @@
           <a:lstStyle xmlns:a="http://schemas.openxmlformats.org/drawingml/2006/main"/>
           <a:p xmlns:a="http://schemas.openxmlformats.org/drawingml/2006/main">
             <a:pPr algn="l">
-              <a:defRPr sz="975" b="1">
-                <a:solidFill>
-                  <a:srgbClr val="C65D2E"/>
-                </a:solidFill>
-                <a:latin typeface="Aptos"/>
-                <a:ea typeface="Aptos"/>
-                <a:cs typeface="Aptos"/>
+              <a:defRPr sz="2325" b="1">
+                <a:solidFill>
+                  <a:srgbClr val="FFF8F0"/>
+                </a:solidFill>
+                <a:latin typeface="Times New Roman"/>
+                <a:ea typeface="Times New Roman"/>
+                <a:cs typeface="Times New Roman"/>
               </a:defRPr>
             </a:pPr>
             <a:r>
-              <a:rPr sz="975" b="1">
-                <a:solidFill>
-                  <a:srgbClr val="C65D2E"/>
-                </a:solidFill>
-                <a:latin typeface="Aptos"/>
-                <a:ea typeface="Aptos"/>
-                <a:cs typeface="Aptos"/>
+              <a:rPr sz="2325" b="1">
+                <a:solidFill>
+                  <a:srgbClr val="FFF8F0"/>
+                </a:solidFill>
+                <a:latin typeface="Times New Roman"/>
+                <a:ea typeface="Times New Roman"/>
+                <a:cs typeface="Times New Roman"/>
               </a:rPr>
-              <a:t>PROOF</a:t>
+              <a:t>A small schema is enough to drive consistent deck output.</a:t>
             </a:r>
           </a:p>
         </p:txBody>
       </p:sp>
       <p:sp>
         <p:nvSpPr>
-          <p:cNvPr id="3" name="">
-            <a:extLst xmlns:a="http://schemas.openxmlformats.org/drawingml/2006/main">
-              <a:ext uri="{FF2B5EF4-FFF2-40B4-BE49-F238E27FC236}">
-                <a16:creationId xmlns:a16="http://schemas.microsoft.com/office/drawing/2014/main" id="{9748ACFC-EE15-4C2D-8B84-3254BA67990F}"/>
-              </a:ext>
-            </a:extLst>
-          </p:cNvPr>
-          <p:cNvSpPr>
-            <a:spLocks xmlns:a="http://schemas.openxmlformats.org/drawingml/2006/main" noGrp="1"/>
-          </p:cNvSpPr>
-          <p:nvPr/>
-        </p:nvSpPr>
-        <p:spPr>
-          <a:xfrm xmlns:a="http://schemas.openxmlformats.org/drawingml/2006/main">
-            <a:off x="609600" y="876300"/>
-            <a:ext cx="8382000" cy="914400"/>
+          <p:cNvPr id="6" name="">
+            <a:extLst xmlns:a="http://schemas.openxmlformats.org/drawingml/2006/main">
+              <a:ext uri="{FF2B5EF4-FFF2-40B4-BE49-F238E27FC236}">
+                <a16:creationId xmlns:a16="http://schemas.microsoft.com/office/drawing/2014/main" id="{BB179D87-41A0-4729-AA52-2D4EFFF115BC}"/>
+              </a:ext>
+            </a:extLst>
+          </p:cNvPr>
+          <p:cNvSpPr>
+            <a:spLocks xmlns:a="http://schemas.openxmlformats.org/drawingml/2006/main" noGrp="1"/>
+          </p:cNvSpPr>
+          <p:nvPr/>
+        </p:nvSpPr>
+        <p:spPr>
+          <a:xfrm xmlns:a="http://schemas.openxmlformats.org/drawingml/2006/main">
+            <a:off x="685800" y="2476500"/>
+            <a:ext cx="3429000" cy="2362200"/>
+          </a:xfrm>
+          <a:prstGeom xmlns:a="http://schemas.openxmlformats.org/drawingml/2006/main" prst="rect">
+            <a:avLst/>
+          </a:prstGeom>
+          <a:solidFill xmlns:a="http://schemas.openxmlformats.org/drawingml/2006/main">
+            <a:srgbClr val="FFF9F2"/>
+          </a:solidFill>
+          <a:ln xmlns:a="http://schemas.openxmlformats.org/drawingml/2006/main" w="19050">
+            <a:solidFill>
+              <a:srgbClr val="E7B08B"/>
+            </a:solidFill>
+            <a:prstDash val="solid"/>
+          </a:ln>
+        </p:spPr>
+      </p:sp>
+      <p:sp>
+        <p:nvSpPr>
+          <p:cNvPr id="7" name="">
+            <a:extLst xmlns:a="http://schemas.openxmlformats.org/drawingml/2006/main">
+              <a:ext uri="{FF2B5EF4-FFF2-40B4-BE49-F238E27FC236}">
+                <a16:creationId xmlns:a16="http://schemas.microsoft.com/office/drawing/2014/main" id="{F753E7D7-4B6C-495E-9965-337F5BF8CF7E}"/>
+              </a:ext>
+            </a:extLst>
+          </p:cNvPr>
+          <p:cNvSpPr>
+            <a:spLocks xmlns:a="http://schemas.openxmlformats.org/drawingml/2006/main" noGrp="1"/>
+          </p:cNvSpPr>
+          <p:nvPr/>
+        </p:nvSpPr>
+        <p:spPr>
+          <a:xfrm xmlns:a="http://schemas.openxmlformats.org/drawingml/2006/main">
+            <a:off x="685800" y="2476500"/>
+            <a:ext cx="3429000" cy="152400"/>
+          </a:xfrm>
+          <a:prstGeom xmlns:a="http://schemas.openxmlformats.org/drawingml/2006/main" prst="rect">
+            <a:avLst/>
+          </a:prstGeom>
+          <a:solidFill xmlns:a="http://schemas.openxmlformats.org/drawingml/2006/main">
+            <a:srgbClr val="C65D2E"/>
+          </a:solidFill>
+          <a:ln xmlns:a="http://schemas.openxmlformats.org/drawingml/2006/main" w="0">
+            <a:solidFill>
+              <a:srgbClr val="000000">
+                <a:alpha val="0"/>
+              </a:srgbClr>
+            </a:solidFill>
+            <a:prstDash val="solid"/>
+          </a:ln>
+        </p:spPr>
+      </p:sp>
+      <p:sp>
+        <p:nvSpPr>
+          <p:cNvPr id="8" name="">
+            <a:extLst xmlns:a="http://schemas.openxmlformats.org/drawingml/2006/main">
+              <a:ext uri="{FF2B5EF4-FFF2-40B4-BE49-F238E27FC236}">
+                <a16:creationId xmlns:a16="http://schemas.microsoft.com/office/drawing/2014/main" id="{31D78F0E-6AD4-482B-A067-210F3EE2056E}"/>
+              </a:ext>
+            </a:extLst>
+          </p:cNvPr>
+          <p:cNvSpPr>
+            <a:spLocks xmlns:a="http://schemas.openxmlformats.org/drawingml/2006/main" noGrp="1"/>
+          </p:cNvSpPr>
+          <p:nvPr/>
+        </p:nvSpPr>
+        <p:spPr>
+          <a:xfrm xmlns:a="http://schemas.openxmlformats.org/drawingml/2006/main">
+            <a:off x="914400" y="2876550"/>
+            <a:ext cx="2971800" cy="495300"/>
           </a:xfrm>
           <a:prstGeom xmlns:a="http://schemas.openxmlformats.org/drawingml/2006/main" prst="rect">
             <a:avLst/>
@@ -2802,78 +3221,45 @@
             <a:pPr algn="l">
               <a:defRPr sz="2100" b="1">
                 <a:solidFill>
-                  <a:srgbClr val="1E1B18"/>
-                </a:solidFill>
-                <a:latin typeface="Aptos Display"/>
-                <a:ea typeface="Aptos Display"/>
-                <a:cs typeface="Aptos Display"/>
+                  <a:srgbClr val="C65D2E"/>
+                </a:solidFill>
+                <a:latin typeface="Times New Roman"/>
+                <a:ea typeface="Times New Roman"/>
+                <a:cs typeface="Times New Roman"/>
               </a:defRPr>
             </a:pPr>
             <a:r>
               <a:rPr sz="2100" b="1">
                 <a:solidFill>
-                  <a:srgbClr val="1E1B18"/>
-                </a:solidFill>
-                <a:latin typeface="Aptos Display"/>
-                <a:ea typeface="Aptos Display"/>
-                <a:cs typeface="Aptos Display"/>
+                  <a:srgbClr val="C65D2E"/>
+                </a:solidFill>
+                <a:latin typeface="Times New Roman"/>
+                <a:ea typeface="Times New Roman"/>
+                <a:cs typeface="Times New Roman"/>
               </a:rPr>
-              <a:t>A small schema is enough to drive consistent deck output.</a:t>
+              <a:t>4</a:t>
             </a:r>
           </a:p>
         </p:txBody>
       </p:sp>
       <p:sp>
         <p:nvSpPr>
-          <p:cNvPr id="4" name="">
-            <a:extLst xmlns:a="http://schemas.openxmlformats.org/drawingml/2006/main">
-              <a:ext uri="{FF2B5EF4-FFF2-40B4-BE49-F238E27FC236}">
-                <a16:creationId xmlns:a16="http://schemas.microsoft.com/office/drawing/2014/main" id="{A1C1215F-E47B-49C6-B637-C07AD158EE6F}"/>
-              </a:ext>
-            </a:extLst>
-          </p:cNvPr>
-          <p:cNvSpPr>
-            <a:spLocks xmlns:a="http://schemas.openxmlformats.org/drawingml/2006/main" noGrp="1"/>
-          </p:cNvSpPr>
-          <p:nvPr/>
-        </p:nvSpPr>
-        <p:spPr>
-          <a:xfrm xmlns:a="http://schemas.openxmlformats.org/drawingml/2006/main">
-            <a:off x="609600" y="2362200"/>
-            <a:ext cx="3505200" cy="2343150"/>
-          </a:xfrm>
-          <a:prstGeom xmlns:a="http://schemas.openxmlformats.org/drawingml/2006/main" prst="rect">
-            <a:avLst/>
-          </a:prstGeom>
-          <a:solidFill xmlns:a="http://schemas.openxmlformats.org/drawingml/2006/main">
-            <a:srgbClr val="FFF9F2"/>
-          </a:solidFill>
-          <a:ln xmlns:a="http://schemas.openxmlformats.org/drawingml/2006/main" w="9525">
-            <a:solidFill>
-              <a:srgbClr val="D6C8B8"/>
-            </a:solidFill>
-            <a:prstDash val="solid"/>
-          </a:ln>
-        </p:spPr>
-      </p:sp>
-      <p:sp>
-        <p:nvSpPr>
-          <p:cNvPr id="5" name="">
-            <a:extLst xmlns:a="http://schemas.openxmlformats.org/drawingml/2006/main">
-              <a:ext uri="{FF2B5EF4-FFF2-40B4-BE49-F238E27FC236}">
-                <a16:creationId xmlns:a16="http://schemas.microsoft.com/office/drawing/2014/main" id="{F77A13D6-4D64-46BB-88DD-77B7C5BC59AE}"/>
-              </a:ext>
-            </a:extLst>
-          </p:cNvPr>
-          <p:cNvSpPr>
-            <a:spLocks xmlns:a="http://schemas.openxmlformats.org/drawingml/2006/main" noGrp="1"/>
-          </p:cNvSpPr>
-          <p:nvPr/>
-        </p:nvSpPr>
-        <p:spPr>
-          <a:xfrm xmlns:a="http://schemas.openxmlformats.org/drawingml/2006/main">
-            <a:off x="876300" y="2705100"/>
-            <a:ext cx="2971800" cy="666750"/>
+          <p:cNvPr id="9" name="">
+            <a:extLst xmlns:a="http://schemas.openxmlformats.org/drawingml/2006/main">
+              <a:ext uri="{FF2B5EF4-FFF2-40B4-BE49-F238E27FC236}">
+                <a16:creationId xmlns:a16="http://schemas.microsoft.com/office/drawing/2014/main" id="{28043A2E-2F65-498C-B96F-35B68AABB324}"/>
+              </a:ext>
+            </a:extLst>
+          </p:cNvPr>
+          <p:cNvSpPr>
+            <a:spLocks xmlns:a="http://schemas.openxmlformats.org/drawingml/2006/main" noGrp="1"/>
+          </p:cNvSpPr>
+          <p:nvPr/>
+        </p:nvSpPr>
+        <p:spPr>
+          <a:xfrm xmlns:a="http://schemas.openxmlformats.org/drawingml/2006/main">
+            <a:off x="914400" y="3581400"/>
+            <a:ext cx="2971800" cy="228600"/>
           </a:xfrm>
           <a:prstGeom xmlns:a="http://schemas.openxmlformats.org/drawingml/2006/main" prst="rect">
             <a:avLst/>
@@ -2897,81 +3283,17 @@
           <a:lstStyle xmlns:a="http://schemas.openxmlformats.org/drawingml/2006/main"/>
           <a:p xmlns:a="http://schemas.openxmlformats.org/drawingml/2006/main">
             <a:pPr algn="l">
-              <a:defRPr sz="2550" b="1">
-                <a:solidFill>
-                  <a:srgbClr val="C65D2E"/>
-                </a:solidFill>
-                <a:latin typeface="Aptos Display"/>
-                <a:ea typeface="Aptos Display"/>
-                <a:cs typeface="Aptos Display"/>
+              <a:defRPr sz="1125" b="1">
+                <a:solidFill>
+                  <a:srgbClr val="1E1B18"/>
+                </a:solidFill>
+                <a:latin typeface="Aptos"/>
+                <a:ea typeface="Aptos"/>
+                <a:cs typeface="Aptos"/>
               </a:defRPr>
             </a:pPr>
             <a:r>
-              <a:rPr sz="2550" b="1">
-                <a:solidFill>
-                  <a:srgbClr val="C65D2E"/>
-                </a:solidFill>
-                <a:latin typeface="Aptos Display"/>
-                <a:ea typeface="Aptos Display"/>
-                <a:cs typeface="Aptos Display"/>
-              </a:rPr>
-              <a:t>4</a:t>
-            </a:r>
-          </a:p>
-        </p:txBody>
-      </p:sp>
-      <p:sp>
-        <p:nvSpPr>
-          <p:cNvPr id="6" name="">
-            <a:extLst xmlns:a="http://schemas.openxmlformats.org/drawingml/2006/main">
-              <a:ext uri="{FF2B5EF4-FFF2-40B4-BE49-F238E27FC236}">
-                <a16:creationId xmlns:a16="http://schemas.microsoft.com/office/drawing/2014/main" id="{AE33AA6D-761F-4212-B452-E19BC7A08B1D}"/>
-              </a:ext>
-            </a:extLst>
-          </p:cNvPr>
-          <p:cNvSpPr>
-            <a:spLocks xmlns:a="http://schemas.openxmlformats.org/drawingml/2006/main" noGrp="1"/>
-          </p:cNvSpPr>
-          <p:nvPr/>
-        </p:nvSpPr>
-        <p:spPr>
-          <a:xfrm xmlns:a="http://schemas.openxmlformats.org/drawingml/2006/main">
-            <a:off x="876300" y="3429000"/>
-            <a:ext cx="2971800" cy="285750"/>
-          </a:xfrm>
-          <a:prstGeom xmlns:a="http://schemas.openxmlformats.org/drawingml/2006/main" prst="rect">
-            <a:avLst/>
-          </a:prstGeom>
-          <a:solidFill xmlns:a="http://schemas.openxmlformats.org/drawingml/2006/main">
-            <a:srgbClr val="000000">
-              <a:alpha val="0"/>
-            </a:srgbClr>
-          </a:solidFill>
-          <a:ln xmlns:a="http://schemas.openxmlformats.org/drawingml/2006/main" w="0">
-            <a:solidFill>
-              <a:srgbClr val="000000">
-                <a:alpha val="0"/>
-              </a:srgbClr>
-            </a:solidFill>
-            <a:prstDash val="solid"/>
-          </a:ln>
-        </p:spPr>
-        <p:txBody>
-          <a:bodyPr xmlns:a="http://schemas.openxmlformats.org/drawingml/2006/main" lIns="0" tIns="0" rIns="0" bIns="0" anchor="t"/>
-          <a:lstStyle xmlns:a="http://schemas.openxmlformats.org/drawingml/2006/main"/>
-          <a:p xmlns:a="http://schemas.openxmlformats.org/drawingml/2006/main">
-            <a:pPr algn="l">
-              <a:defRPr sz="1200" b="1">
-                <a:solidFill>
-                  <a:srgbClr val="1E1B18"/>
-                </a:solidFill>
-                <a:latin typeface="Aptos"/>
-                <a:ea typeface="Aptos"/>
-                <a:cs typeface="Aptos"/>
-              </a:defRPr>
-            </a:pPr>
-            <a:r>
-              <a:rPr sz="1200" b="1">
+              <a:rPr sz="1125" b="1">
                 <a:solidFill>
                   <a:srgbClr val="1E1B18"/>
                 </a:solidFill>
@@ -2986,22 +3308,22 @@
       </p:sp>
       <p:sp>
         <p:nvSpPr>
-          <p:cNvPr id="7" name="">
-            <a:extLst xmlns:a="http://schemas.openxmlformats.org/drawingml/2006/main">
-              <a:ext uri="{FF2B5EF4-FFF2-40B4-BE49-F238E27FC236}">
-                <a16:creationId xmlns:a16="http://schemas.microsoft.com/office/drawing/2014/main" id="{C293AE5C-C5A1-4E51-919E-E7BCABC9ED53}"/>
-              </a:ext>
-            </a:extLst>
-          </p:cNvPr>
-          <p:cNvSpPr>
-            <a:spLocks xmlns:a="http://schemas.openxmlformats.org/drawingml/2006/main" noGrp="1"/>
-          </p:cNvSpPr>
-          <p:nvPr/>
-        </p:nvSpPr>
-        <p:spPr>
-          <a:xfrm xmlns:a="http://schemas.openxmlformats.org/drawingml/2006/main">
-            <a:off x="876300" y="3810000"/>
-            <a:ext cx="2971800" cy="590550"/>
+          <p:cNvPr id="10" name="">
+            <a:extLst xmlns:a="http://schemas.openxmlformats.org/drawingml/2006/main">
+              <a:ext uri="{FF2B5EF4-FFF2-40B4-BE49-F238E27FC236}">
+                <a16:creationId xmlns:a16="http://schemas.microsoft.com/office/drawing/2014/main" id="{61844D56-371D-4768-8165-487C982B8D14}"/>
+              </a:ext>
+            </a:extLst>
+          </p:cNvPr>
+          <p:cNvSpPr>
+            <a:spLocks xmlns:a="http://schemas.openxmlformats.org/drawingml/2006/main" noGrp="1"/>
+          </p:cNvSpPr>
+          <p:nvPr/>
+        </p:nvSpPr>
+        <p:spPr>
+          <a:xfrm xmlns:a="http://schemas.openxmlformats.org/drawingml/2006/main">
+            <a:off x="914400" y="3924300"/>
+            <a:ext cx="2971800" cy="552450"/>
           </a:xfrm>
           <a:prstGeom xmlns:a="http://schemas.openxmlformats.org/drawingml/2006/main" prst="rect">
             <a:avLst/>
@@ -3050,22 +3372,22 @@
       </p:sp>
       <p:sp>
         <p:nvSpPr>
-          <p:cNvPr id="8" name="">
-            <a:extLst xmlns:a="http://schemas.openxmlformats.org/drawingml/2006/main">
-              <a:ext uri="{FF2B5EF4-FFF2-40B4-BE49-F238E27FC236}">
-                <a16:creationId xmlns:a16="http://schemas.microsoft.com/office/drawing/2014/main" id="{315223D9-C94E-4EE8-9FDE-5AD5FAD9DE85}"/>
-              </a:ext>
-            </a:extLst>
-          </p:cNvPr>
-          <p:cNvSpPr>
-            <a:spLocks xmlns:a="http://schemas.openxmlformats.org/drawingml/2006/main" noGrp="1"/>
-          </p:cNvSpPr>
-          <p:nvPr/>
-        </p:nvSpPr>
-        <p:spPr>
-          <a:xfrm xmlns:a="http://schemas.openxmlformats.org/drawingml/2006/main">
-            <a:off x="4343400" y="2362200"/>
-            <a:ext cx="3505200" cy="2343150"/>
+          <p:cNvPr id="11" name="">
+            <a:extLst xmlns:a="http://schemas.openxmlformats.org/drawingml/2006/main">
+              <a:ext uri="{FF2B5EF4-FFF2-40B4-BE49-F238E27FC236}">
+                <a16:creationId xmlns:a16="http://schemas.microsoft.com/office/drawing/2014/main" id="{D2B39E5A-1983-49DB-8FEC-92D6C0ABE048}"/>
+              </a:ext>
+            </a:extLst>
+          </p:cNvPr>
+          <p:cNvSpPr>
+            <a:spLocks xmlns:a="http://schemas.openxmlformats.org/drawingml/2006/main" noGrp="1"/>
+          </p:cNvSpPr>
+          <p:nvPr/>
+        </p:nvSpPr>
+        <p:spPr>
+          <a:xfrm xmlns:a="http://schemas.openxmlformats.org/drawingml/2006/main">
+            <a:off x="4381500" y="2476500"/>
+            <a:ext cx="3429000" cy="2362200"/>
           </a:xfrm>
           <a:prstGeom xmlns:a="http://schemas.openxmlformats.org/drawingml/2006/main" prst="rect">
             <a:avLst/>
@@ -3073,32 +3395,67 @@
           <a:solidFill xmlns:a="http://schemas.openxmlformats.org/drawingml/2006/main">
             <a:srgbClr val="FFF9F2"/>
           </a:solidFill>
-          <a:ln xmlns:a="http://schemas.openxmlformats.org/drawingml/2006/main" w="9525">
-            <a:solidFill>
-              <a:srgbClr val="D6C8B8"/>
-            </a:solidFill>
-            <a:prstDash val="solid"/>
-          </a:ln>
-        </p:spPr>
-      </p:sp>
-      <p:sp>
-        <p:nvSpPr>
-          <p:cNvPr id="9" name="">
-            <a:extLst xmlns:a="http://schemas.openxmlformats.org/drawingml/2006/main">
-              <a:ext uri="{FF2B5EF4-FFF2-40B4-BE49-F238E27FC236}">
-                <a16:creationId xmlns:a16="http://schemas.microsoft.com/office/drawing/2014/main" id="{F5EA3E13-CFD5-44DE-9D2B-B78FEB2FC1E2}"/>
-              </a:ext>
-            </a:extLst>
-          </p:cNvPr>
-          <p:cNvSpPr>
-            <a:spLocks xmlns:a="http://schemas.openxmlformats.org/drawingml/2006/main" noGrp="1"/>
-          </p:cNvSpPr>
-          <p:nvPr/>
-        </p:nvSpPr>
-        <p:spPr>
-          <a:xfrm xmlns:a="http://schemas.openxmlformats.org/drawingml/2006/main">
-            <a:off x="4610100" y="2705100"/>
-            <a:ext cx="2971800" cy="666750"/>
+          <a:ln xmlns:a="http://schemas.openxmlformats.org/drawingml/2006/main" w="19050">
+            <a:solidFill>
+              <a:srgbClr val="E7B08B"/>
+            </a:solidFill>
+            <a:prstDash val="solid"/>
+          </a:ln>
+        </p:spPr>
+      </p:sp>
+      <p:sp>
+        <p:nvSpPr>
+          <p:cNvPr id="12" name="">
+            <a:extLst xmlns:a="http://schemas.openxmlformats.org/drawingml/2006/main">
+              <a:ext uri="{FF2B5EF4-FFF2-40B4-BE49-F238E27FC236}">
+                <a16:creationId xmlns:a16="http://schemas.microsoft.com/office/drawing/2014/main" id="{CC1F2C16-B756-4DE3-A18B-B1882E5090E0}"/>
+              </a:ext>
+            </a:extLst>
+          </p:cNvPr>
+          <p:cNvSpPr>
+            <a:spLocks xmlns:a="http://schemas.openxmlformats.org/drawingml/2006/main" noGrp="1"/>
+          </p:cNvSpPr>
+          <p:nvPr/>
+        </p:nvSpPr>
+        <p:spPr>
+          <a:xfrm xmlns:a="http://schemas.openxmlformats.org/drawingml/2006/main">
+            <a:off x="4381500" y="2476500"/>
+            <a:ext cx="3429000" cy="152400"/>
+          </a:xfrm>
+          <a:prstGeom xmlns:a="http://schemas.openxmlformats.org/drawingml/2006/main" prst="rect">
+            <a:avLst/>
+          </a:prstGeom>
+          <a:solidFill xmlns:a="http://schemas.openxmlformats.org/drawingml/2006/main">
+            <a:srgbClr val="C65D2E"/>
+          </a:solidFill>
+          <a:ln xmlns:a="http://schemas.openxmlformats.org/drawingml/2006/main" w="0">
+            <a:solidFill>
+              <a:srgbClr val="000000">
+                <a:alpha val="0"/>
+              </a:srgbClr>
+            </a:solidFill>
+            <a:prstDash val="solid"/>
+          </a:ln>
+        </p:spPr>
+      </p:sp>
+      <p:sp>
+        <p:nvSpPr>
+          <p:cNvPr id="13" name="">
+            <a:extLst xmlns:a="http://schemas.openxmlformats.org/drawingml/2006/main">
+              <a:ext uri="{FF2B5EF4-FFF2-40B4-BE49-F238E27FC236}">
+                <a16:creationId xmlns:a16="http://schemas.microsoft.com/office/drawing/2014/main" id="{39737D40-821B-4A83-A000-4C110E650CA9}"/>
+              </a:ext>
+            </a:extLst>
+          </p:cNvPr>
+          <p:cNvSpPr>
+            <a:spLocks xmlns:a="http://schemas.openxmlformats.org/drawingml/2006/main" noGrp="1"/>
+          </p:cNvSpPr>
+          <p:nvPr/>
+        </p:nvSpPr>
+        <p:spPr>
+          <a:xfrm xmlns:a="http://schemas.openxmlformats.org/drawingml/2006/main">
+            <a:off x="4610100" y="2876550"/>
+            <a:ext cx="2971800" cy="495300"/>
           </a:xfrm>
           <a:prstGeom xmlns:a="http://schemas.openxmlformats.org/drawingml/2006/main" prst="rect">
             <a:avLst/>
@@ -3122,23 +3479,23 @@
           <a:lstStyle xmlns:a="http://schemas.openxmlformats.org/drawingml/2006/main"/>
           <a:p xmlns:a="http://schemas.openxmlformats.org/drawingml/2006/main">
             <a:pPr algn="l">
-              <a:defRPr sz="2550" b="1">
+              <a:defRPr sz="2100" b="1">
                 <a:solidFill>
                   <a:srgbClr val="C65D2E"/>
                 </a:solidFill>
-                <a:latin typeface="Aptos Display"/>
-                <a:ea typeface="Aptos Display"/>
-                <a:cs typeface="Aptos Display"/>
+                <a:latin typeface="Times New Roman"/>
+                <a:ea typeface="Times New Roman"/>
+                <a:cs typeface="Times New Roman"/>
               </a:defRPr>
             </a:pPr>
             <a:r>
-              <a:rPr sz="2550" b="1">
+              <a:rPr sz="2100" b="1">
                 <a:solidFill>
                   <a:srgbClr val="C65D2E"/>
                 </a:solidFill>
-                <a:latin typeface="Aptos Display"/>
-                <a:ea typeface="Aptos Display"/>
-                <a:cs typeface="Aptos Display"/>
+                <a:latin typeface="Times New Roman"/>
+                <a:ea typeface="Times New Roman"/>
+                <a:cs typeface="Times New Roman"/>
               </a:rPr>
               <a:t>1</a:t>
             </a:r>
@@ -3147,22 +3504,22 @@
       </p:sp>
       <p:sp>
         <p:nvSpPr>
-          <p:cNvPr id="10" name="">
-            <a:extLst xmlns:a="http://schemas.openxmlformats.org/drawingml/2006/main">
-              <a:ext uri="{FF2B5EF4-FFF2-40B4-BE49-F238E27FC236}">
-                <a16:creationId xmlns:a16="http://schemas.microsoft.com/office/drawing/2014/main" id="{CC658D85-8E4D-4AF6-A857-EA0E86986F33}"/>
-              </a:ext>
-            </a:extLst>
-          </p:cNvPr>
-          <p:cNvSpPr>
-            <a:spLocks xmlns:a="http://schemas.openxmlformats.org/drawingml/2006/main" noGrp="1"/>
-          </p:cNvSpPr>
-          <p:nvPr/>
-        </p:nvSpPr>
-        <p:spPr>
-          <a:xfrm xmlns:a="http://schemas.openxmlformats.org/drawingml/2006/main">
-            <a:off x="4610100" y="3429000"/>
-            <a:ext cx="2971800" cy="285750"/>
+          <p:cNvPr id="14" name="">
+            <a:extLst xmlns:a="http://schemas.openxmlformats.org/drawingml/2006/main">
+              <a:ext uri="{FF2B5EF4-FFF2-40B4-BE49-F238E27FC236}">
+                <a16:creationId xmlns:a16="http://schemas.microsoft.com/office/drawing/2014/main" id="{C13EAEED-2612-4B49-BEC4-818DC1A12A99}"/>
+              </a:ext>
+            </a:extLst>
+          </p:cNvPr>
+          <p:cNvSpPr>
+            <a:spLocks xmlns:a="http://schemas.openxmlformats.org/drawingml/2006/main" noGrp="1"/>
+          </p:cNvSpPr>
+          <p:nvPr/>
+        </p:nvSpPr>
+        <p:spPr>
+          <a:xfrm xmlns:a="http://schemas.openxmlformats.org/drawingml/2006/main">
+            <a:off x="4610100" y="3581400"/>
+            <a:ext cx="2971800" cy="228600"/>
           </a:xfrm>
           <a:prstGeom xmlns:a="http://schemas.openxmlformats.org/drawingml/2006/main" prst="rect">
             <a:avLst/>
@@ -3186,7 +3543,7 @@
           <a:lstStyle xmlns:a="http://schemas.openxmlformats.org/drawingml/2006/main"/>
           <a:p xmlns:a="http://schemas.openxmlformats.org/drawingml/2006/main">
             <a:pPr algn="l">
-              <a:defRPr sz="1200" b="1">
+              <a:defRPr sz="1125" b="1">
                 <a:solidFill>
                   <a:srgbClr val="1E1B18"/>
                 </a:solidFill>
@@ -3196,7 +3553,7 @@
               </a:defRPr>
             </a:pPr>
             <a:r>
-              <a:rPr sz="1200" b="1">
+              <a:rPr sz="1125" b="1">
                 <a:solidFill>
                   <a:srgbClr val="1E1B18"/>
                 </a:solidFill>
@@ -3211,22 +3568,22 @@
       </p:sp>
       <p:sp>
         <p:nvSpPr>
-          <p:cNvPr id="11" name="">
-            <a:extLst xmlns:a="http://schemas.openxmlformats.org/drawingml/2006/main">
-              <a:ext uri="{FF2B5EF4-FFF2-40B4-BE49-F238E27FC236}">
-                <a16:creationId xmlns:a16="http://schemas.microsoft.com/office/drawing/2014/main" id="{B24C01D6-F708-4050-B4E4-6746A11251F0}"/>
-              </a:ext>
-            </a:extLst>
-          </p:cNvPr>
-          <p:cNvSpPr>
-            <a:spLocks xmlns:a="http://schemas.openxmlformats.org/drawingml/2006/main" noGrp="1"/>
-          </p:cNvSpPr>
-          <p:nvPr/>
-        </p:nvSpPr>
-        <p:spPr>
-          <a:xfrm xmlns:a="http://schemas.openxmlformats.org/drawingml/2006/main">
-            <a:off x="4610100" y="3810000"/>
-            <a:ext cx="2971800" cy="590550"/>
+          <p:cNvPr id="15" name="">
+            <a:extLst xmlns:a="http://schemas.openxmlformats.org/drawingml/2006/main">
+              <a:ext uri="{FF2B5EF4-FFF2-40B4-BE49-F238E27FC236}">
+                <a16:creationId xmlns:a16="http://schemas.microsoft.com/office/drawing/2014/main" id="{C7986A81-6042-4683-9E2F-735B941A6C52}"/>
+              </a:ext>
+            </a:extLst>
+          </p:cNvPr>
+          <p:cNvSpPr>
+            <a:spLocks xmlns:a="http://schemas.openxmlformats.org/drawingml/2006/main" noGrp="1"/>
+          </p:cNvSpPr>
+          <p:nvPr/>
+        </p:nvSpPr>
+        <p:spPr>
+          <a:xfrm xmlns:a="http://schemas.openxmlformats.org/drawingml/2006/main">
+            <a:off x="4610100" y="3924300"/>
+            <a:ext cx="2971800" cy="552450"/>
           </a:xfrm>
           <a:prstGeom xmlns:a="http://schemas.openxmlformats.org/drawingml/2006/main" prst="rect">
             <a:avLst/>
@@ -3275,22 +3632,22 @@
       </p:sp>
       <p:sp>
         <p:nvSpPr>
-          <p:cNvPr id="12" name="">
-            <a:extLst xmlns:a="http://schemas.openxmlformats.org/drawingml/2006/main">
-              <a:ext uri="{FF2B5EF4-FFF2-40B4-BE49-F238E27FC236}">
-                <a16:creationId xmlns:a16="http://schemas.microsoft.com/office/drawing/2014/main" id="{B6C87E20-936A-4C84-92CA-6C7BE22DE3DC}"/>
-              </a:ext>
-            </a:extLst>
-          </p:cNvPr>
-          <p:cNvSpPr>
-            <a:spLocks xmlns:a="http://schemas.openxmlformats.org/drawingml/2006/main" noGrp="1"/>
-          </p:cNvSpPr>
-          <p:nvPr/>
-        </p:nvSpPr>
-        <p:spPr>
-          <a:xfrm xmlns:a="http://schemas.openxmlformats.org/drawingml/2006/main">
-            <a:off x="8077200" y="2362200"/>
-            <a:ext cx="3505200" cy="2343150"/>
+          <p:cNvPr id="16" name="">
+            <a:extLst xmlns:a="http://schemas.openxmlformats.org/drawingml/2006/main">
+              <a:ext uri="{FF2B5EF4-FFF2-40B4-BE49-F238E27FC236}">
+                <a16:creationId xmlns:a16="http://schemas.microsoft.com/office/drawing/2014/main" id="{47ABBA29-352E-4244-8955-21CEFD48C039}"/>
+              </a:ext>
+            </a:extLst>
+          </p:cNvPr>
+          <p:cNvSpPr>
+            <a:spLocks xmlns:a="http://schemas.openxmlformats.org/drawingml/2006/main" noGrp="1"/>
+          </p:cNvSpPr>
+          <p:nvPr/>
+        </p:nvSpPr>
+        <p:spPr>
+          <a:xfrm xmlns:a="http://schemas.openxmlformats.org/drawingml/2006/main">
+            <a:off x="8077200" y="2476500"/>
+            <a:ext cx="3429000" cy="2362200"/>
           </a:xfrm>
           <a:prstGeom xmlns:a="http://schemas.openxmlformats.org/drawingml/2006/main" prst="rect">
             <a:avLst/>
@@ -3298,32 +3655,67 @@
           <a:solidFill xmlns:a="http://schemas.openxmlformats.org/drawingml/2006/main">
             <a:srgbClr val="FFF9F2"/>
           </a:solidFill>
-          <a:ln xmlns:a="http://schemas.openxmlformats.org/drawingml/2006/main" w="9525">
-            <a:solidFill>
-              <a:srgbClr val="D6C8B8"/>
-            </a:solidFill>
-            <a:prstDash val="solid"/>
-          </a:ln>
-        </p:spPr>
-      </p:sp>
-      <p:sp>
-        <p:nvSpPr>
-          <p:cNvPr id="13" name="">
-            <a:extLst xmlns:a="http://schemas.openxmlformats.org/drawingml/2006/main">
-              <a:ext uri="{FF2B5EF4-FFF2-40B4-BE49-F238E27FC236}">
-                <a16:creationId xmlns:a16="http://schemas.microsoft.com/office/drawing/2014/main" id="{ADFD68DA-D648-45B4-B303-8980D44836E4}"/>
-              </a:ext>
-            </a:extLst>
-          </p:cNvPr>
-          <p:cNvSpPr>
-            <a:spLocks xmlns:a="http://schemas.openxmlformats.org/drawingml/2006/main" noGrp="1"/>
-          </p:cNvSpPr>
-          <p:nvPr/>
-        </p:nvSpPr>
-        <p:spPr>
-          <a:xfrm xmlns:a="http://schemas.openxmlformats.org/drawingml/2006/main">
-            <a:off x="8343900" y="2705100"/>
-            <a:ext cx="2971800" cy="666750"/>
+          <a:ln xmlns:a="http://schemas.openxmlformats.org/drawingml/2006/main" w="19050">
+            <a:solidFill>
+              <a:srgbClr val="E7B08B"/>
+            </a:solidFill>
+            <a:prstDash val="solid"/>
+          </a:ln>
+        </p:spPr>
+      </p:sp>
+      <p:sp>
+        <p:nvSpPr>
+          <p:cNvPr id="17" name="">
+            <a:extLst xmlns:a="http://schemas.openxmlformats.org/drawingml/2006/main">
+              <a:ext uri="{FF2B5EF4-FFF2-40B4-BE49-F238E27FC236}">
+                <a16:creationId xmlns:a16="http://schemas.microsoft.com/office/drawing/2014/main" id="{71AD15AE-53EE-4373-BB30-B6EB468DA1C8}"/>
+              </a:ext>
+            </a:extLst>
+          </p:cNvPr>
+          <p:cNvSpPr>
+            <a:spLocks xmlns:a="http://schemas.openxmlformats.org/drawingml/2006/main" noGrp="1"/>
+          </p:cNvSpPr>
+          <p:nvPr/>
+        </p:nvSpPr>
+        <p:spPr>
+          <a:xfrm xmlns:a="http://schemas.openxmlformats.org/drawingml/2006/main">
+            <a:off x="8077200" y="2476500"/>
+            <a:ext cx="3429000" cy="152400"/>
+          </a:xfrm>
+          <a:prstGeom xmlns:a="http://schemas.openxmlformats.org/drawingml/2006/main" prst="rect">
+            <a:avLst/>
+          </a:prstGeom>
+          <a:solidFill xmlns:a="http://schemas.openxmlformats.org/drawingml/2006/main">
+            <a:srgbClr val="C65D2E"/>
+          </a:solidFill>
+          <a:ln xmlns:a="http://schemas.openxmlformats.org/drawingml/2006/main" w="0">
+            <a:solidFill>
+              <a:srgbClr val="000000">
+                <a:alpha val="0"/>
+              </a:srgbClr>
+            </a:solidFill>
+            <a:prstDash val="solid"/>
+          </a:ln>
+        </p:spPr>
+      </p:sp>
+      <p:sp>
+        <p:nvSpPr>
+          <p:cNvPr id="18" name="">
+            <a:extLst xmlns:a="http://schemas.openxmlformats.org/drawingml/2006/main">
+              <a:ext uri="{FF2B5EF4-FFF2-40B4-BE49-F238E27FC236}">
+                <a16:creationId xmlns:a16="http://schemas.microsoft.com/office/drawing/2014/main" id="{EBAB1549-EF8A-4690-863B-DE8172EA1505}"/>
+              </a:ext>
+            </a:extLst>
+          </p:cNvPr>
+          <p:cNvSpPr>
+            <a:spLocks xmlns:a="http://schemas.openxmlformats.org/drawingml/2006/main" noGrp="1"/>
+          </p:cNvSpPr>
+          <p:nvPr/>
+        </p:nvSpPr>
+        <p:spPr>
+          <a:xfrm xmlns:a="http://schemas.openxmlformats.org/drawingml/2006/main">
+            <a:off x="8305800" y="2876550"/>
+            <a:ext cx="2971800" cy="495300"/>
           </a:xfrm>
           <a:prstGeom xmlns:a="http://schemas.openxmlformats.org/drawingml/2006/main" prst="rect">
             <a:avLst/>
@@ -3347,23 +3739,23 @@
           <a:lstStyle xmlns:a="http://schemas.openxmlformats.org/drawingml/2006/main"/>
           <a:p xmlns:a="http://schemas.openxmlformats.org/drawingml/2006/main">
             <a:pPr algn="l">
-              <a:defRPr sz="2550" b="1">
+              <a:defRPr sz="2100" b="1">
                 <a:solidFill>
                   <a:srgbClr val="C65D2E"/>
                 </a:solidFill>
-                <a:latin typeface="Aptos Display"/>
-                <a:ea typeface="Aptos Display"/>
-                <a:cs typeface="Aptos Display"/>
+                <a:latin typeface="Times New Roman"/>
+                <a:ea typeface="Times New Roman"/>
+                <a:cs typeface="Times New Roman"/>
               </a:defRPr>
             </a:pPr>
             <a:r>
-              <a:rPr sz="2550" b="1">
+              <a:rPr sz="2100" b="1">
                 <a:solidFill>
                   <a:srgbClr val="C65D2E"/>
                 </a:solidFill>
-                <a:latin typeface="Aptos Display"/>
-                <a:ea typeface="Aptos Display"/>
-                <a:cs typeface="Aptos Display"/>
+                <a:latin typeface="Times New Roman"/>
+                <a:ea typeface="Times New Roman"/>
+                <a:cs typeface="Times New Roman"/>
               </a:rPr>
               <a:t>.pptx</a:t>
             </a:r>
@@ -3372,22 +3764,22 @@
       </p:sp>
       <p:sp>
         <p:nvSpPr>
-          <p:cNvPr id="14" name="">
-            <a:extLst xmlns:a="http://schemas.openxmlformats.org/drawingml/2006/main">
-              <a:ext uri="{FF2B5EF4-FFF2-40B4-BE49-F238E27FC236}">
-                <a16:creationId xmlns:a16="http://schemas.microsoft.com/office/drawing/2014/main" id="{775DEE43-63C9-4567-B56A-9D8C43025E43}"/>
-              </a:ext>
-            </a:extLst>
-          </p:cNvPr>
-          <p:cNvSpPr>
-            <a:spLocks xmlns:a="http://schemas.openxmlformats.org/drawingml/2006/main" noGrp="1"/>
-          </p:cNvSpPr>
-          <p:nvPr/>
-        </p:nvSpPr>
-        <p:spPr>
-          <a:xfrm xmlns:a="http://schemas.openxmlformats.org/drawingml/2006/main">
-            <a:off x="8343900" y="3429000"/>
-            <a:ext cx="2971800" cy="285750"/>
+          <p:cNvPr id="19" name="">
+            <a:extLst xmlns:a="http://schemas.openxmlformats.org/drawingml/2006/main">
+              <a:ext uri="{FF2B5EF4-FFF2-40B4-BE49-F238E27FC236}">
+                <a16:creationId xmlns:a16="http://schemas.microsoft.com/office/drawing/2014/main" id="{235341B7-7DA9-41E0-A781-11F94C1B7BCB}"/>
+              </a:ext>
+            </a:extLst>
+          </p:cNvPr>
+          <p:cNvSpPr>
+            <a:spLocks xmlns:a="http://schemas.openxmlformats.org/drawingml/2006/main" noGrp="1"/>
+          </p:cNvSpPr>
+          <p:nvPr/>
+        </p:nvSpPr>
+        <p:spPr>
+          <a:xfrm xmlns:a="http://schemas.openxmlformats.org/drawingml/2006/main">
+            <a:off x="8305800" y="3581400"/>
+            <a:ext cx="2971800" cy="228600"/>
           </a:xfrm>
           <a:prstGeom xmlns:a="http://schemas.openxmlformats.org/drawingml/2006/main" prst="rect">
             <a:avLst/>
@@ -3411,7 +3803,7 @@
           <a:lstStyle xmlns:a="http://schemas.openxmlformats.org/drawingml/2006/main"/>
           <a:p xmlns:a="http://schemas.openxmlformats.org/drawingml/2006/main">
             <a:pPr algn="l">
-              <a:defRPr sz="1200" b="1">
+              <a:defRPr sz="1125" b="1">
                 <a:solidFill>
                   <a:srgbClr val="1E1B18"/>
                 </a:solidFill>
@@ -3421,7 +3813,7 @@
               </a:defRPr>
             </a:pPr>
             <a:r>
-              <a:rPr sz="1200" b="1">
+              <a:rPr sz="1125" b="1">
                 <a:solidFill>
                   <a:srgbClr val="1E1B18"/>
                 </a:solidFill>
@@ -3436,22 +3828,22 @@
       </p:sp>
       <p:sp>
         <p:nvSpPr>
-          <p:cNvPr id="15" name="">
-            <a:extLst xmlns:a="http://schemas.openxmlformats.org/drawingml/2006/main">
-              <a:ext uri="{FF2B5EF4-FFF2-40B4-BE49-F238E27FC236}">
-                <a16:creationId xmlns:a16="http://schemas.microsoft.com/office/drawing/2014/main" id="{8EFCD867-C105-4456-AEF1-7FCB36468E98}"/>
-              </a:ext>
-            </a:extLst>
-          </p:cNvPr>
-          <p:cNvSpPr>
-            <a:spLocks xmlns:a="http://schemas.openxmlformats.org/drawingml/2006/main" noGrp="1"/>
-          </p:cNvSpPr>
-          <p:nvPr/>
-        </p:nvSpPr>
-        <p:spPr>
-          <a:xfrm xmlns:a="http://schemas.openxmlformats.org/drawingml/2006/main">
-            <a:off x="8343900" y="3810000"/>
-            <a:ext cx="2971800" cy="590550"/>
+          <p:cNvPr id="20" name="">
+            <a:extLst xmlns:a="http://schemas.openxmlformats.org/drawingml/2006/main">
+              <a:ext uri="{FF2B5EF4-FFF2-40B4-BE49-F238E27FC236}">
+                <a16:creationId xmlns:a16="http://schemas.microsoft.com/office/drawing/2014/main" id="{EE628F2D-A645-479E-9A51-3FEFA6168C89}"/>
+              </a:ext>
+            </a:extLst>
+          </p:cNvPr>
+          <p:cNvSpPr>
+            <a:spLocks xmlns:a="http://schemas.openxmlformats.org/drawingml/2006/main" noGrp="1"/>
+          </p:cNvSpPr>
+          <p:nvPr/>
+        </p:nvSpPr>
+        <p:spPr>
+          <a:xfrm xmlns:a="http://schemas.openxmlformats.org/drawingml/2006/main">
+            <a:off x="8305800" y="3924300"/>
+            <a:ext cx="2971800" cy="552450"/>
           </a:xfrm>
           <a:prstGeom xmlns:a="http://schemas.openxmlformats.org/drawingml/2006/main" prst="rect">
             <a:avLst/>
@@ -3500,22 +3892,57 @@
       </p:sp>
       <p:sp>
         <p:nvSpPr>
-          <p:cNvPr id="16" name="">
-            <a:extLst xmlns:a="http://schemas.openxmlformats.org/drawingml/2006/main">
-              <a:ext uri="{FF2B5EF4-FFF2-40B4-BE49-F238E27FC236}">
-                <a16:creationId xmlns:a16="http://schemas.microsoft.com/office/drawing/2014/main" id="{935A7E4F-BB00-456E-A070-AAAD15275CC9}"/>
-              </a:ext>
-            </a:extLst>
-          </p:cNvPr>
-          <p:cNvSpPr>
-            <a:spLocks xmlns:a="http://schemas.openxmlformats.org/drawingml/2006/main" noGrp="1"/>
-          </p:cNvSpPr>
-          <p:nvPr/>
-        </p:nvSpPr>
-        <p:spPr>
-          <a:xfrm xmlns:a="http://schemas.openxmlformats.org/drawingml/2006/main">
-            <a:off x="609600" y="5219700"/>
-            <a:ext cx="9334500" cy="323850"/>
+          <p:cNvPr id="21" name="">
+            <a:extLst xmlns:a="http://schemas.openxmlformats.org/drawingml/2006/main">
+              <a:ext uri="{FF2B5EF4-FFF2-40B4-BE49-F238E27FC236}">
+                <a16:creationId xmlns:a16="http://schemas.microsoft.com/office/drawing/2014/main" id="{6B3CE32A-2C07-4C64-99C0-4D0780DE50EB}"/>
+              </a:ext>
+            </a:extLst>
+          </p:cNvPr>
+          <p:cNvSpPr>
+            <a:spLocks xmlns:a="http://schemas.openxmlformats.org/drawingml/2006/main" noGrp="1"/>
+          </p:cNvSpPr>
+          <p:nvPr/>
+        </p:nvSpPr>
+        <p:spPr>
+          <a:xfrm xmlns:a="http://schemas.openxmlformats.org/drawingml/2006/main">
+            <a:off x="685800" y="5334000"/>
+            <a:ext cx="10820400" cy="19050"/>
+          </a:xfrm>
+          <a:prstGeom xmlns:a="http://schemas.openxmlformats.org/drawingml/2006/main" prst="rect">
+            <a:avLst/>
+          </a:prstGeom>
+          <a:solidFill xmlns:a="http://schemas.openxmlformats.org/drawingml/2006/main">
+            <a:srgbClr val="E7B08B"/>
+          </a:solidFill>
+          <a:ln xmlns:a="http://schemas.openxmlformats.org/drawingml/2006/main" w="0">
+            <a:solidFill>
+              <a:srgbClr val="000000">
+                <a:alpha val="0"/>
+              </a:srgbClr>
+            </a:solidFill>
+            <a:prstDash val="solid"/>
+          </a:ln>
+        </p:spPr>
+      </p:sp>
+      <p:sp>
+        <p:nvSpPr>
+          <p:cNvPr id="22" name="">
+            <a:extLst xmlns:a="http://schemas.openxmlformats.org/drawingml/2006/main">
+              <a:ext uri="{FF2B5EF4-FFF2-40B4-BE49-F238E27FC236}">
+                <a16:creationId xmlns:a16="http://schemas.microsoft.com/office/drawing/2014/main" id="{C2F63CF2-A199-4BC7-877E-EAB34B2B8ACC}"/>
+              </a:ext>
+            </a:extLst>
+          </p:cNvPr>
+          <p:cNvSpPr>
+            <a:spLocks xmlns:a="http://schemas.openxmlformats.org/drawingml/2006/main" noGrp="1"/>
+          </p:cNvSpPr>
+          <p:nvPr/>
+        </p:nvSpPr>
+        <p:spPr>
+          <a:xfrm xmlns:a="http://schemas.openxmlformats.org/drawingml/2006/main">
+            <a:off x="685800" y="5562600"/>
+            <a:ext cx="9334500" cy="457200"/>
           </a:xfrm>
           <a:prstGeom xmlns:a="http://schemas.openxmlformats.org/drawingml/2006/main" prst="rect">
             <a:avLst/>
@@ -3541,7 +3968,7 @@
             <a:pPr algn="l">
               <a:defRPr sz="1350" b="1">
                 <a:solidFill>
-                  <a:srgbClr val="1E1B18"/>
+                  <a:srgbClr val="FFF8F0"/>
                 </a:solidFill>
                 <a:latin typeface="Aptos"/>
                 <a:ea typeface="Aptos"/>
@@ -3551,7 +3978,7 @@
             <a:r>
               <a:rPr sz="1350" b="1">
                 <a:solidFill>
-                  <a:srgbClr val="1E1B18"/>
+                  <a:srgbClr val="FFF8F0"/>
                 </a:solidFill>
                 <a:latin typeface="Aptos"/>
                 <a:ea typeface="Aptos"/>
@@ -3564,55 +3991,57 @@
       </p:sp>
       <p:sp>
         <p:nvSpPr>
-          <p:cNvPr id="17" name="">
-            <a:extLst xmlns:a="http://schemas.openxmlformats.org/drawingml/2006/main">
-              <a:ext uri="{FF2B5EF4-FFF2-40B4-BE49-F238E27FC236}">
-                <a16:creationId xmlns:a16="http://schemas.microsoft.com/office/drawing/2014/main" id="{60F15A14-6BDC-4537-9B2F-BAA468E5E5A8}"/>
-              </a:ext>
-            </a:extLst>
-          </p:cNvPr>
-          <p:cNvSpPr>
-            <a:spLocks xmlns:a="http://schemas.openxmlformats.org/drawingml/2006/main" noGrp="1"/>
-          </p:cNvSpPr>
-          <p:nvPr/>
-        </p:nvSpPr>
-        <p:spPr>
-          <a:xfrm xmlns:a="http://schemas.openxmlformats.org/drawingml/2006/main">
-            <a:off x="609600" y="6477000"/>
-            <a:ext cx="10972800" cy="9525"/>
-          </a:xfrm>
-          <a:prstGeom xmlns:a="http://schemas.openxmlformats.org/drawingml/2006/main" prst="rect">
-            <a:avLst/>
-          </a:prstGeom>
-          <a:solidFill xmlns:a="http://schemas.openxmlformats.org/drawingml/2006/main">
-            <a:srgbClr val="D6C8B8"/>
-          </a:solidFill>
-          <a:ln xmlns:a="http://schemas.openxmlformats.org/drawingml/2006/main" w="0">
-            <a:solidFill>
-              <a:srgbClr val="D6C8B8"/>
-            </a:solidFill>
-            <a:prstDash val="solid"/>
-          </a:ln>
-        </p:spPr>
-      </p:sp>
-      <p:sp>
-        <p:nvSpPr>
-          <p:cNvPr id="18" name="">
-            <a:extLst xmlns:a="http://schemas.openxmlformats.org/drawingml/2006/main">
-              <a:ext uri="{FF2B5EF4-FFF2-40B4-BE49-F238E27FC236}">
-                <a16:creationId xmlns:a16="http://schemas.microsoft.com/office/drawing/2014/main" id="{C377130E-2B3F-4641-B875-568BB8E95FF0}"/>
-              </a:ext>
-            </a:extLst>
-          </p:cNvPr>
-          <p:cNvSpPr>
-            <a:spLocks xmlns:a="http://schemas.openxmlformats.org/drawingml/2006/main" noGrp="1"/>
-          </p:cNvSpPr>
-          <p:nvPr/>
-        </p:nvSpPr>
-        <p:spPr>
-          <a:xfrm xmlns:a="http://schemas.openxmlformats.org/drawingml/2006/main">
-            <a:off x="609600" y="6572250"/>
-            <a:ext cx="3048000" cy="171450"/>
+          <p:cNvPr id="23" name="">
+            <a:extLst xmlns:a="http://schemas.openxmlformats.org/drawingml/2006/main">
+              <a:ext uri="{FF2B5EF4-FFF2-40B4-BE49-F238E27FC236}">
+                <a16:creationId xmlns:a16="http://schemas.microsoft.com/office/drawing/2014/main" id="{15AB0928-09B1-4B54-8678-C90F86A76614}"/>
+              </a:ext>
+            </a:extLst>
+          </p:cNvPr>
+          <p:cNvSpPr>
+            <a:spLocks xmlns:a="http://schemas.openxmlformats.org/drawingml/2006/main" noGrp="1"/>
+          </p:cNvSpPr>
+          <p:nvPr/>
+        </p:nvSpPr>
+        <p:spPr>
+          <a:xfrm xmlns:a="http://schemas.openxmlformats.org/drawingml/2006/main">
+            <a:off x="685800" y="6438900"/>
+            <a:ext cx="10820400" cy="9525"/>
+          </a:xfrm>
+          <a:prstGeom xmlns:a="http://schemas.openxmlformats.org/drawingml/2006/main" prst="rect">
+            <a:avLst/>
+          </a:prstGeom>
+          <a:solidFill xmlns:a="http://schemas.openxmlformats.org/drawingml/2006/main">
+            <a:srgbClr val="E7B08B"/>
+          </a:solidFill>
+          <a:ln xmlns:a="http://schemas.openxmlformats.org/drawingml/2006/main" w="0">
+            <a:solidFill>
+              <a:srgbClr val="000000">
+                <a:alpha val="0"/>
+              </a:srgbClr>
+            </a:solidFill>
+            <a:prstDash val="solid"/>
+          </a:ln>
+        </p:spPr>
+      </p:sp>
+      <p:sp>
+        <p:nvSpPr>
+          <p:cNvPr id="24" name="">
+            <a:extLst xmlns:a="http://schemas.openxmlformats.org/drawingml/2006/main">
+              <a:ext uri="{FF2B5EF4-FFF2-40B4-BE49-F238E27FC236}">
+                <a16:creationId xmlns:a16="http://schemas.microsoft.com/office/drawing/2014/main" id="{EBB72976-0995-4E24-8A14-7CDD5CEF7804}"/>
+              </a:ext>
+            </a:extLst>
+          </p:cNvPr>
+          <p:cNvSpPr>
+            <a:spLocks xmlns:a="http://schemas.openxmlformats.org/drawingml/2006/main" noGrp="1"/>
+          </p:cNvSpPr>
+          <p:nvPr/>
+        </p:nvSpPr>
+        <p:spPr>
+          <a:xfrm xmlns:a="http://schemas.openxmlformats.org/drawingml/2006/main">
+            <a:off x="685800" y="6543675"/>
+            <a:ext cx="3048000" cy="152400"/>
           </a:xfrm>
           <a:prstGeom xmlns:a="http://schemas.openxmlformats.org/drawingml/2006/main" prst="rect">
             <a:avLst/>
@@ -3636,9 +4065,9 @@
           <a:lstStyle xmlns:a="http://schemas.openxmlformats.org/drawingml/2006/main"/>
           <a:p xmlns:a="http://schemas.openxmlformats.org/drawingml/2006/main">
             <a:pPr algn="l">
-              <a:defRPr sz="750" b="0">
-                <a:solidFill>
-                  <a:srgbClr val="6B6258"/>
+              <a:defRPr sz="675" b="0">
+                <a:solidFill>
+                  <a:srgbClr val="E7B08B"/>
                 </a:solidFill>
                 <a:latin typeface="Aptos"/>
                 <a:ea typeface="Aptos"/>
@@ -3646,9 +4075,9 @@
               </a:defRPr>
             </a:pPr>
             <a:r>
-              <a:rPr sz="750" b="0">
-                <a:solidFill>
-                  <a:srgbClr val="6B6258"/>
+              <a:rPr sz="675" b="0">
+                <a:solidFill>
+                  <a:srgbClr val="E7B08B"/>
                 </a:solidFill>
                 <a:latin typeface="Aptos"/>
                 <a:ea typeface="Aptos"/>
@@ -3661,22 +4090,22 @@
       </p:sp>
       <p:sp>
         <p:nvSpPr>
-          <p:cNvPr id="19" name="">
-            <a:extLst xmlns:a="http://schemas.openxmlformats.org/drawingml/2006/main">
-              <a:ext uri="{FF2B5EF4-FFF2-40B4-BE49-F238E27FC236}">
-                <a16:creationId xmlns:a16="http://schemas.microsoft.com/office/drawing/2014/main" id="{06222AD3-E33D-46F3-B5C2-E856F09427C9}"/>
-              </a:ext>
-            </a:extLst>
-          </p:cNvPr>
-          <p:cNvSpPr>
-            <a:spLocks xmlns:a="http://schemas.openxmlformats.org/drawingml/2006/main" noGrp="1"/>
-          </p:cNvSpPr>
-          <p:nvPr/>
-        </p:nvSpPr>
-        <p:spPr>
-          <a:xfrm xmlns:a="http://schemas.openxmlformats.org/drawingml/2006/main">
-            <a:off x="10858500" y="6572250"/>
-            <a:ext cx="723900" cy="171450"/>
+          <p:cNvPr id="25" name="">
+            <a:extLst xmlns:a="http://schemas.openxmlformats.org/drawingml/2006/main">
+              <a:ext uri="{FF2B5EF4-FFF2-40B4-BE49-F238E27FC236}">
+                <a16:creationId xmlns:a16="http://schemas.microsoft.com/office/drawing/2014/main" id="{813534CF-057C-4E6E-B1E8-B87194EB553A}"/>
+              </a:ext>
+            </a:extLst>
+          </p:cNvPr>
+          <p:cNvSpPr>
+            <a:spLocks xmlns:a="http://schemas.openxmlformats.org/drawingml/2006/main" noGrp="1"/>
+          </p:cNvSpPr>
+          <p:nvPr/>
+        </p:nvSpPr>
+        <p:spPr>
+          <a:xfrm xmlns:a="http://schemas.openxmlformats.org/drawingml/2006/main">
+            <a:off x="10953750" y="6543675"/>
+            <a:ext cx="571500" cy="152400"/>
           </a:xfrm>
           <a:prstGeom xmlns:a="http://schemas.openxmlformats.org/drawingml/2006/main" prst="rect">
             <a:avLst/>
@@ -3700,9 +4129,9 @@
           <a:lstStyle xmlns:a="http://schemas.openxmlformats.org/drawingml/2006/main"/>
           <a:p xmlns:a="http://schemas.openxmlformats.org/drawingml/2006/main">
             <a:pPr algn="r">
-              <a:defRPr sz="750" b="0">
-                <a:solidFill>
-                  <a:srgbClr val="6B6258"/>
+              <a:defRPr sz="675" b="0">
+                <a:solidFill>
+                  <a:srgbClr val="E7B08B"/>
                 </a:solidFill>
                 <a:latin typeface="Aptos"/>
                 <a:ea typeface="Aptos"/>
@@ -3710,9 +4139,9 @@
               </a:defRPr>
             </a:pPr>
             <a:r>
-              <a:rPr sz="750" b="0">
-                <a:solidFill>
-                  <a:srgbClr val="6B6258"/>
+              <a:rPr sz="675" b="0">
+                <a:solidFill>
+                  <a:srgbClr val="E7B08B"/>
                 </a:solidFill>
                 <a:latin typeface="Aptos"/>
                 <a:ea typeface="Aptos"/>
@@ -3726,7 +4155,7 @@
     </p:spTree>
     <p:extLst>
       <p:ext uri="{BB962C8B-B14F-4D97-AF65-F5344CB8AC3E}">
-        <p14:creationId xmlns:p14="http://schemas.microsoft.com/office/powerpoint/2010/main" val="1754777330"/>
+        <p14:creationId xmlns:p14="http://schemas.microsoft.com/office/powerpoint/2010/main" val="1861903167"/>
       </p:ext>
     </p:extLst>
   </p:cSld>
@@ -3747,10 +4176,10 @@
       </p:grpSpPr>
       <p:sp>
         <p:nvSpPr>
-          <p:cNvPr id="1" name="">
-            <a:extLst xmlns:a="http://schemas.openxmlformats.org/drawingml/2006/main">
-              <a:ext uri="{FF2B5EF4-FFF2-40B4-BE49-F238E27FC236}">
-                <a16:creationId xmlns:a16="http://schemas.microsoft.com/office/drawing/2014/main" id="{9AB6CB9C-54F2-43F1-A7F7-2CF2AE8E25BC}"/>
+          <p:cNvPr id="13" name="">
+            <a:extLst xmlns:a="http://schemas.openxmlformats.org/drawingml/2006/main">
+              <a:ext uri="{FF2B5EF4-FFF2-40B4-BE49-F238E27FC236}">
+                <a16:creationId xmlns:a16="http://schemas.microsoft.com/office/drawing/2014/main" id="{88B10123-B8EC-480C-8FB7-F41006C4F3B8}"/>
               </a:ext>
             </a:extLst>
           </p:cNvPr>
@@ -3785,19 +4214,124 @@
           <p:cNvPr id="2" name="">
             <a:extLst xmlns:a="http://schemas.openxmlformats.org/drawingml/2006/main">
               <a:ext uri="{FF2B5EF4-FFF2-40B4-BE49-F238E27FC236}">
-                <a16:creationId xmlns:a16="http://schemas.microsoft.com/office/drawing/2014/main" id="{FD84BBA8-4C13-4950-8648-C2546A18C7F6}"/>
-              </a:ext>
-            </a:extLst>
-          </p:cNvPr>
-          <p:cNvSpPr>
-            <a:spLocks xmlns:a="http://schemas.openxmlformats.org/drawingml/2006/main" noGrp="1"/>
-          </p:cNvSpPr>
-          <p:nvPr/>
-        </p:nvSpPr>
-        <p:spPr>
-          <a:xfrm xmlns:a="http://schemas.openxmlformats.org/drawingml/2006/main">
-            <a:off x="609600" y="476250"/>
-            <a:ext cx="2286000" cy="266700"/>
+                <a16:creationId xmlns:a16="http://schemas.microsoft.com/office/drawing/2014/main" id="{43C8BE40-8800-49BF-A483-A3848C8BA698}"/>
+              </a:ext>
+            </a:extLst>
+          </p:cNvPr>
+          <p:cNvSpPr>
+            <a:spLocks xmlns:a="http://schemas.openxmlformats.org/drawingml/2006/main" noGrp="1"/>
+          </p:cNvSpPr>
+          <p:nvPr/>
+        </p:nvSpPr>
+        <p:spPr>
+          <a:xfrm xmlns:a="http://schemas.openxmlformats.org/drawingml/2006/main">
+            <a:off x="0" y="0"/>
+            <a:ext cx="12192000" cy="266700"/>
+          </a:xfrm>
+          <a:prstGeom xmlns:a="http://schemas.openxmlformats.org/drawingml/2006/main" prst="rect">
+            <a:avLst/>
+          </a:prstGeom>
+          <a:solidFill xmlns:a="http://schemas.openxmlformats.org/drawingml/2006/main">
+            <a:srgbClr val="1F2738"/>
+          </a:solidFill>
+          <a:ln xmlns:a="http://schemas.openxmlformats.org/drawingml/2006/main" w="0">
+            <a:solidFill>
+              <a:srgbClr val="000000">
+                <a:alpha val="0"/>
+              </a:srgbClr>
+            </a:solidFill>
+            <a:prstDash val="solid"/>
+          </a:ln>
+        </p:spPr>
+      </p:sp>
+      <p:sp>
+        <p:nvSpPr>
+          <p:cNvPr id="3" name="">
+            <a:extLst xmlns:a="http://schemas.openxmlformats.org/drawingml/2006/main">
+              <a:ext uri="{FF2B5EF4-FFF2-40B4-BE49-F238E27FC236}">
+                <a16:creationId xmlns:a16="http://schemas.microsoft.com/office/drawing/2014/main" id="{7EAF3235-82FB-4F5B-9259-8D5C27F75A74}"/>
+              </a:ext>
+            </a:extLst>
+          </p:cNvPr>
+          <p:cNvSpPr>
+            <a:spLocks xmlns:a="http://schemas.openxmlformats.org/drawingml/2006/main" noGrp="1"/>
+          </p:cNvSpPr>
+          <p:nvPr/>
+        </p:nvSpPr>
+        <p:spPr>
+          <a:xfrm xmlns:a="http://schemas.openxmlformats.org/drawingml/2006/main">
+            <a:off x="685800" y="1371600"/>
+            <a:ext cx="10820400" cy="3733800"/>
+          </a:xfrm>
+          <a:prstGeom xmlns:a="http://schemas.openxmlformats.org/drawingml/2006/main" prst="rect">
+            <a:avLst/>
+          </a:prstGeom>
+          <a:solidFill xmlns:a="http://schemas.openxmlformats.org/drawingml/2006/main">
+            <a:srgbClr val="1F2738"/>
+          </a:solidFill>
+          <a:ln xmlns:a="http://schemas.openxmlformats.org/drawingml/2006/main" w="0">
+            <a:solidFill>
+              <a:srgbClr val="000000">
+                <a:alpha val="0"/>
+              </a:srgbClr>
+            </a:solidFill>
+            <a:prstDash val="solid"/>
+          </a:ln>
+        </p:spPr>
+      </p:sp>
+      <p:sp>
+        <p:nvSpPr>
+          <p:cNvPr id="4" name="">
+            <a:extLst xmlns:a="http://schemas.openxmlformats.org/drawingml/2006/main">
+              <a:ext uri="{FF2B5EF4-FFF2-40B4-BE49-F238E27FC236}">
+                <a16:creationId xmlns:a16="http://schemas.microsoft.com/office/drawing/2014/main" id="{C903EFA3-4B61-46E6-9661-A0C9A8964311}"/>
+              </a:ext>
+            </a:extLst>
+          </p:cNvPr>
+          <p:cNvSpPr>
+            <a:spLocks xmlns:a="http://schemas.openxmlformats.org/drawingml/2006/main" noGrp="1"/>
+          </p:cNvSpPr>
+          <p:nvPr/>
+        </p:nvSpPr>
+        <p:spPr>
+          <a:xfrm xmlns:a="http://schemas.openxmlformats.org/drawingml/2006/main">
+            <a:off x="685800" y="1371600"/>
+            <a:ext cx="190500" cy="3733800"/>
+          </a:xfrm>
+          <a:prstGeom xmlns:a="http://schemas.openxmlformats.org/drawingml/2006/main" prst="rect">
+            <a:avLst/>
+          </a:prstGeom>
+          <a:solidFill xmlns:a="http://schemas.openxmlformats.org/drawingml/2006/main">
+            <a:srgbClr val="C65D2E"/>
+          </a:solidFill>
+          <a:ln xmlns:a="http://schemas.openxmlformats.org/drawingml/2006/main" w="0">
+            <a:solidFill>
+              <a:srgbClr val="000000">
+                <a:alpha val="0"/>
+              </a:srgbClr>
+            </a:solidFill>
+            <a:prstDash val="solid"/>
+          </a:ln>
+        </p:spPr>
+      </p:sp>
+      <p:sp>
+        <p:nvSpPr>
+          <p:cNvPr id="5" name="">
+            <a:extLst xmlns:a="http://schemas.openxmlformats.org/drawingml/2006/main">
+              <a:ext uri="{FF2B5EF4-FFF2-40B4-BE49-F238E27FC236}">
+                <a16:creationId xmlns:a16="http://schemas.microsoft.com/office/drawing/2014/main" id="{879DDE1C-BD9B-4017-82A4-8053A9E877F5}"/>
+              </a:ext>
+            </a:extLst>
+          </p:cNvPr>
+          <p:cNvSpPr>
+            <a:spLocks xmlns:a="http://schemas.openxmlformats.org/drawingml/2006/main" noGrp="1"/>
+          </p:cNvSpPr>
+          <p:nvPr/>
+        </p:nvSpPr>
+        <p:spPr>
+          <a:xfrm xmlns:a="http://schemas.openxmlformats.org/drawingml/2006/main">
+            <a:off x="1181100" y="1847850"/>
+            <a:ext cx="1714500" cy="171450"/>
           </a:xfrm>
           <a:prstGeom xmlns:a="http://schemas.openxmlformats.org/drawingml/2006/main" prst="rect">
             <a:avLst/>
@@ -3821,9 +4355,9 @@
           <a:lstStyle xmlns:a="http://schemas.openxmlformats.org/drawingml/2006/main"/>
           <a:p xmlns:a="http://schemas.openxmlformats.org/drawingml/2006/main">
             <a:pPr algn="l">
-              <a:defRPr sz="975" b="1">
-                <a:solidFill>
-                  <a:srgbClr val="C65D2E"/>
+              <a:defRPr sz="825" b="1">
+                <a:solidFill>
+                  <a:srgbClr val="E7B08B"/>
                 </a:solidFill>
                 <a:latin typeface="Aptos"/>
                 <a:ea typeface="Aptos"/>
@@ -3831,9 +4365,9 @@
               </a:defRPr>
             </a:pPr>
             <a:r>
-              <a:rPr sz="975" b="1">
-                <a:solidFill>
-                  <a:srgbClr val="C65D2E"/>
+              <a:rPr sz="825" b="1">
+                <a:solidFill>
+                  <a:srgbClr val="E7B08B"/>
                 </a:solidFill>
                 <a:latin typeface="Aptos"/>
                 <a:ea typeface="Aptos"/>
@@ -3846,22 +4380,22 @@
       </p:sp>
       <p:sp>
         <p:nvSpPr>
-          <p:cNvPr id="3" name="">
-            <a:extLst xmlns:a="http://schemas.openxmlformats.org/drawingml/2006/main">
-              <a:ext uri="{FF2B5EF4-FFF2-40B4-BE49-F238E27FC236}">
-                <a16:creationId xmlns:a16="http://schemas.microsoft.com/office/drawing/2014/main" id="{26012F0A-4585-440D-A869-52E5DE52CB7D}"/>
-              </a:ext>
-            </a:extLst>
-          </p:cNvPr>
-          <p:cNvSpPr>
-            <a:spLocks xmlns:a="http://schemas.openxmlformats.org/drawingml/2006/main" noGrp="1"/>
-          </p:cNvSpPr>
-          <p:nvPr/>
-        </p:nvSpPr>
-        <p:spPr>
-          <a:xfrm xmlns:a="http://schemas.openxmlformats.org/drawingml/2006/main">
-            <a:off x="609600" y="876300"/>
-            <a:ext cx="8382000" cy="914400"/>
+          <p:cNvPr id="6" name="">
+            <a:extLst xmlns:a="http://schemas.openxmlformats.org/drawingml/2006/main">
+              <a:ext uri="{FF2B5EF4-FFF2-40B4-BE49-F238E27FC236}">
+                <a16:creationId xmlns:a16="http://schemas.microsoft.com/office/drawing/2014/main" id="{DD031E3A-2348-410F-B0DD-90ED1F5812C6}"/>
+              </a:ext>
+            </a:extLst>
+          </p:cNvPr>
+          <p:cNvSpPr>
+            <a:spLocks xmlns:a="http://schemas.openxmlformats.org/drawingml/2006/main" noGrp="1"/>
+          </p:cNvSpPr>
+          <p:nvPr/>
+        </p:nvSpPr>
+        <p:spPr>
+          <a:xfrm xmlns:a="http://schemas.openxmlformats.org/drawingml/2006/main">
+            <a:off x="1181100" y="2209800"/>
+            <a:ext cx="8610600" cy="857250"/>
           </a:xfrm>
           <a:prstGeom xmlns:a="http://schemas.openxmlformats.org/drawingml/2006/main" prst="rect">
             <a:avLst/>
@@ -3885,23 +4419,23 @@
           <a:lstStyle xmlns:a="http://schemas.openxmlformats.org/drawingml/2006/main"/>
           <a:p xmlns:a="http://schemas.openxmlformats.org/drawingml/2006/main">
             <a:pPr algn="l">
-              <a:defRPr sz="2100" b="1">
-                <a:solidFill>
-                  <a:srgbClr val="1E1B18"/>
-                </a:solidFill>
-                <a:latin typeface="Aptos Display"/>
-                <a:ea typeface="Aptos Display"/>
-                <a:cs typeface="Aptos Display"/>
+              <a:defRPr sz="2550" b="1">
+                <a:solidFill>
+                  <a:srgbClr val="FFF8F0"/>
+                </a:solidFill>
+                <a:latin typeface="Times New Roman"/>
+                <a:ea typeface="Times New Roman"/>
+                <a:cs typeface="Times New Roman"/>
               </a:defRPr>
             </a:pPr>
             <a:r>
-              <a:rPr sz="2100" b="1">
-                <a:solidFill>
-                  <a:srgbClr val="1E1B18"/>
-                </a:solidFill>
-                <a:latin typeface="Aptos Display"/>
-                <a:ea typeface="Aptos Display"/>
-                <a:cs typeface="Aptos Display"/>
+              <a:rPr sz="2550" b="1">
+                <a:solidFill>
+                  <a:srgbClr val="FFF8F0"/>
+                </a:solidFill>
+                <a:latin typeface="Times New Roman"/>
+                <a:ea typeface="Times New Roman"/>
+                <a:cs typeface="Times New Roman"/>
               </a:rPr>
               <a:t>Replace the sample brief with your own presentation request.</a:t>
             </a:r>
@@ -3910,55 +4444,22 @@
       </p:sp>
       <p:sp>
         <p:nvSpPr>
-          <p:cNvPr id="4" name="">
-            <a:extLst xmlns:a="http://schemas.openxmlformats.org/drawingml/2006/main">
-              <a:ext uri="{FF2B5EF4-FFF2-40B4-BE49-F238E27FC236}">
-                <a16:creationId xmlns:a16="http://schemas.microsoft.com/office/drawing/2014/main" id="{09EE3607-2A8A-4D8D-9313-668E5FCB04AC}"/>
-              </a:ext>
-            </a:extLst>
-          </p:cNvPr>
-          <p:cNvSpPr>
-            <a:spLocks xmlns:a="http://schemas.openxmlformats.org/drawingml/2006/main" noGrp="1"/>
-          </p:cNvSpPr>
-          <p:nvPr/>
-        </p:nvSpPr>
-        <p:spPr>
-          <a:xfrm xmlns:a="http://schemas.openxmlformats.org/drawingml/2006/main">
-            <a:off x="609600" y="2095500"/>
-            <a:ext cx="10972800" cy="2724150"/>
-          </a:xfrm>
-          <a:prstGeom xmlns:a="http://schemas.openxmlformats.org/drawingml/2006/main" prst="rect">
-            <a:avLst/>
-          </a:prstGeom>
-          <a:solidFill xmlns:a="http://schemas.openxmlformats.org/drawingml/2006/main">
-            <a:srgbClr val="C65D2E"/>
-          </a:solidFill>
-          <a:ln xmlns:a="http://schemas.openxmlformats.org/drawingml/2006/main" w="9525">
-            <a:solidFill>
-              <a:srgbClr val="C65D2E"/>
-            </a:solidFill>
-            <a:prstDash val="solid"/>
-          </a:ln>
-        </p:spPr>
-      </p:sp>
-      <p:sp>
-        <p:nvSpPr>
-          <p:cNvPr id="5" name="">
-            <a:extLst xmlns:a="http://schemas.openxmlformats.org/drawingml/2006/main">
-              <a:ext uri="{FF2B5EF4-FFF2-40B4-BE49-F238E27FC236}">
-                <a16:creationId xmlns:a16="http://schemas.microsoft.com/office/drawing/2014/main" id="{64B88177-FE87-4A25-9364-32A8F127C481}"/>
-              </a:ext>
-            </a:extLst>
-          </p:cNvPr>
-          <p:cNvSpPr>
-            <a:spLocks xmlns:a="http://schemas.openxmlformats.org/drawingml/2006/main" noGrp="1"/>
-          </p:cNvSpPr>
-          <p:nvPr/>
-        </p:nvSpPr>
-        <p:spPr>
-          <a:xfrm xmlns:a="http://schemas.openxmlformats.org/drawingml/2006/main">
-            <a:off x="1047750" y="2647950"/>
-            <a:ext cx="8572500" cy="762000"/>
+          <p:cNvPr id="7" name="">
+            <a:extLst xmlns:a="http://schemas.openxmlformats.org/drawingml/2006/main">
+              <a:ext uri="{FF2B5EF4-FFF2-40B4-BE49-F238E27FC236}">
+                <a16:creationId xmlns:a16="http://schemas.microsoft.com/office/drawing/2014/main" id="{7729148F-B989-4F9A-AEB6-37B18827B698}"/>
+              </a:ext>
+            </a:extLst>
+          </p:cNvPr>
+          <p:cNvSpPr>
+            <a:spLocks xmlns:a="http://schemas.openxmlformats.org/drawingml/2006/main" noGrp="1"/>
+          </p:cNvSpPr>
+          <p:nvPr/>
+        </p:nvSpPr>
+        <p:spPr>
+          <a:xfrm xmlns:a="http://schemas.openxmlformats.org/drawingml/2006/main">
+            <a:off x="1181100" y="3390900"/>
+            <a:ext cx="8667750" cy="857250"/>
           </a:xfrm>
           <a:prstGeom xmlns:a="http://schemas.openxmlformats.org/drawingml/2006/main" prst="rect">
             <a:avLst/>
@@ -3982,23 +4483,23 @@
           <a:lstStyle xmlns:a="http://schemas.openxmlformats.org/drawingml/2006/main"/>
           <a:p xmlns:a="http://schemas.openxmlformats.org/drawingml/2006/main">
             <a:pPr algn="l">
-              <a:defRPr sz="2100" b="1">
-                <a:solidFill>
-                  <a:srgbClr val="FFF8F0"/>
-                </a:solidFill>
-                <a:latin typeface="Aptos Display"/>
-                <a:ea typeface="Aptos Display"/>
-                <a:cs typeface="Aptos Display"/>
+              <a:defRPr sz="1575" b="0">
+                <a:solidFill>
+                  <a:srgbClr val="ECE2D3"/>
+                </a:solidFill>
+                <a:latin typeface="Aptos"/>
+                <a:ea typeface="Aptos"/>
+                <a:cs typeface="Aptos"/>
               </a:defRPr>
             </a:pPr>
             <a:r>
-              <a:rPr sz="2100" b="1">
-                <a:solidFill>
-                  <a:srgbClr val="FFF8F0"/>
-                </a:solidFill>
-                <a:latin typeface="Aptos Display"/>
-                <a:ea typeface="Aptos Display"/>
-                <a:cs typeface="Aptos Display"/>
+              <a:rPr sz="1575" b="0">
+                <a:solidFill>
+                  <a:srgbClr val="ECE2D3"/>
+                </a:solidFill>
+                <a:latin typeface="Aptos"/>
+                <a:ea typeface="Aptos"/>
+                <a:cs typeface="Aptos"/>
               </a:rPr>
               <a:t>Use the template brief for product pitches, course slides, reports, or internal reviews.</a:t>
             </a:r>
@@ -4007,22 +4508,156 @@
       </p:sp>
       <p:sp>
         <p:nvSpPr>
-          <p:cNvPr id="6" name="">
-            <a:extLst xmlns:a="http://schemas.openxmlformats.org/drawingml/2006/main">
-              <a:ext uri="{FF2B5EF4-FFF2-40B4-BE49-F238E27FC236}">
-                <a16:creationId xmlns:a16="http://schemas.microsoft.com/office/drawing/2014/main" id="{E0ED1DB6-76FB-43B9-8F65-606142492CDE}"/>
-              </a:ext>
-            </a:extLst>
-          </p:cNvPr>
-          <p:cNvSpPr>
-            <a:spLocks xmlns:a="http://schemas.openxmlformats.org/drawingml/2006/main" noGrp="1"/>
-          </p:cNvSpPr>
-          <p:nvPr/>
-        </p:nvSpPr>
-        <p:spPr>
-          <a:xfrm xmlns:a="http://schemas.openxmlformats.org/drawingml/2006/main">
-            <a:off x="1047750" y="3733800"/>
-            <a:ext cx="4953000" cy="285750"/>
+          <p:cNvPr id="8" name="">
+            <a:extLst xmlns:a="http://schemas.openxmlformats.org/drawingml/2006/main">
+              <a:ext uri="{FF2B5EF4-FFF2-40B4-BE49-F238E27FC236}">
+                <a16:creationId xmlns:a16="http://schemas.microsoft.com/office/drawing/2014/main" id="{ACBC838B-0EAC-4F00-AE23-250E5001E7A2}"/>
+              </a:ext>
+            </a:extLst>
+          </p:cNvPr>
+          <p:cNvSpPr>
+            <a:spLocks xmlns:a="http://schemas.openxmlformats.org/drawingml/2006/main" noGrp="1"/>
+          </p:cNvSpPr>
+          <p:nvPr/>
+        </p:nvSpPr>
+        <p:spPr>
+          <a:xfrm xmlns:a="http://schemas.openxmlformats.org/drawingml/2006/main">
+            <a:off x="1181100" y="4438650"/>
+            <a:ext cx="1409700" cy="323850"/>
+          </a:xfrm>
+          <a:prstGeom xmlns:a="http://schemas.openxmlformats.org/drawingml/2006/main" prst="rect">
+            <a:avLst/>
+          </a:prstGeom>
+          <a:solidFill xmlns:a="http://schemas.openxmlformats.org/drawingml/2006/main">
+            <a:srgbClr val="C65D2E"/>
+          </a:solidFill>
+          <a:ln xmlns:a="http://schemas.openxmlformats.org/drawingml/2006/main" w="0">
+            <a:solidFill>
+              <a:srgbClr val="000000">
+                <a:alpha val="0"/>
+              </a:srgbClr>
+            </a:solidFill>
+            <a:prstDash val="solid"/>
+          </a:ln>
+        </p:spPr>
+      </p:sp>
+      <p:sp>
+        <p:nvSpPr>
+          <p:cNvPr id="9" name="">
+            <a:extLst xmlns:a="http://schemas.openxmlformats.org/drawingml/2006/main">
+              <a:ext uri="{FF2B5EF4-FFF2-40B4-BE49-F238E27FC236}">
+                <a16:creationId xmlns:a16="http://schemas.microsoft.com/office/drawing/2014/main" id="{741471C9-6CC8-4676-86C4-BB652DBFD246}"/>
+              </a:ext>
+            </a:extLst>
+          </p:cNvPr>
+          <p:cNvSpPr>
+            <a:spLocks xmlns:a="http://schemas.openxmlformats.org/drawingml/2006/main" noGrp="1"/>
+          </p:cNvSpPr>
+          <p:nvPr/>
+        </p:nvSpPr>
+        <p:spPr>
+          <a:xfrm xmlns:a="http://schemas.openxmlformats.org/drawingml/2006/main">
+            <a:off x="1314450" y="4514850"/>
+            <a:ext cx="1143000" cy="171450"/>
+          </a:xfrm>
+          <a:prstGeom xmlns:a="http://schemas.openxmlformats.org/drawingml/2006/main" prst="rect">
+            <a:avLst/>
+          </a:prstGeom>
+          <a:solidFill xmlns:a="http://schemas.openxmlformats.org/drawingml/2006/main">
+            <a:srgbClr val="000000">
+              <a:alpha val="0"/>
+            </a:srgbClr>
+          </a:solidFill>
+          <a:ln xmlns:a="http://schemas.openxmlformats.org/drawingml/2006/main" w="0">
+            <a:solidFill>
+              <a:srgbClr val="000000">
+                <a:alpha val="0"/>
+              </a:srgbClr>
+            </a:solidFill>
+            <a:prstDash val="solid"/>
+          </a:ln>
+        </p:spPr>
+        <p:txBody>
+          <a:bodyPr xmlns:a="http://schemas.openxmlformats.org/drawingml/2006/main" lIns="0" tIns="0" rIns="0" bIns="0" anchor="t"/>
+          <a:lstStyle xmlns:a="http://schemas.openxmlformats.org/drawingml/2006/main"/>
+          <a:p xmlns:a="http://schemas.openxmlformats.org/drawingml/2006/main">
+            <a:pPr algn="ctr">
+              <a:defRPr sz="1050" b="1">
+                <a:solidFill>
+                  <a:srgbClr val="FFF8F0"/>
+                </a:solidFill>
+                <a:latin typeface="Aptos"/>
+                <a:ea typeface="Aptos"/>
+                <a:cs typeface="Aptos"/>
+              </a:defRPr>
+            </a:pPr>
+            <a:r>
+              <a:rPr sz="1050" b="1">
+                <a:solidFill>
+                  <a:srgbClr val="FFF8F0"/>
+                </a:solidFill>
+                <a:latin typeface="Aptos"/>
+                <a:ea typeface="Aptos"/>
+                <a:cs typeface="Aptos"/>
+              </a:rPr>
+              <a:t>Ask Codex to draft the next brief.</a:t>
+            </a:r>
+          </a:p>
+        </p:txBody>
+      </p:sp>
+      <p:sp>
+        <p:nvSpPr>
+          <p:cNvPr id="10" name="">
+            <a:extLst xmlns:a="http://schemas.openxmlformats.org/drawingml/2006/main">
+              <a:ext uri="{FF2B5EF4-FFF2-40B4-BE49-F238E27FC236}">
+                <a16:creationId xmlns:a16="http://schemas.microsoft.com/office/drawing/2014/main" id="{1CEF441F-85E5-4094-B6E4-F192253F04C9}"/>
+              </a:ext>
+            </a:extLst>
+          </p:cNvPr>
+          <p:cNvSpPr>
+            <a:spLocks xmlns:a="http://schemas.openxmlformats.org/drawingml/2006/main" noGrp="1"/>
+          </p:cNvSpPr>
+          <p:nvPr/>
+        </p:nvSpPr>
+        <p:spPr>
+          <a:xfrm xmlns:a="http://schemas.openxmlformats.org/drawingml/2006/main">
+            <a:off x="685800" y="6438900"/>
+            <a:ext cx="10820400" cy="9525"/>
+          </a:xfrm>
+          <a:prstGeom xmlns:a="http://schemas.openxmlformats.org/drawingml/2006/main" prst="rect">
+            <a:avLst/>
+          </a:prstGeom>
+          <a:solidFill xmlns:a="http://schemas.openxmlformats.org/drawingml/2006/main">
+            <a:srgbClr val="D6C8B8"/>
+          </a:solidFill>
+          <a:ln xmlns:a="http://schemas.openxmlformats.org/drawingml/2006/main" w="0">
+            <a:solidFill>
+              <a:srgbClr val="000000">
+                <a:alpha val="0"/>
+              </a:srgbClr>
+            </a:solidFill>
+            <a:prstDash val="solid"/>
+          </a:ln>
+        </p:spPr>
+      </p:sp>
+      <p:sp>
+        <p:nvSpPr>
+          <p:cNvPr id="11" name="">
+            <a:extLst xmlns:a="http://schemas.openxmlformats.org/drawingml/2006/main">
+              <a:ext uri="{FF2B5EF4-FFF2-40B4-BE49-F238E27FC236}">
+                <a16:creationId xmlns:a16="http://schemas.microsoft.com/office/drawing/2014/main" id="{A24EBD81-3C2C-4781-9129-21F50A7CD53A}"/>
+              </a:ext>
+            </a:extLst>
+          </p:cNvPr>
+          <p:cNvSpPr>
+            <a:spLocks xmlns:a="http://schemas.openxmlformats.org/drawingml/2006/main" noGrp="1"/>
+          </p:cNvSpPr>
+          <p:nvPr/>
+        </p:nvSpPr>
+        <p:spPr>
+          <a:xfrm xmlns:a="http://schemas.openxmlformats.org/drawingml/2006/main">
+            <a:off x="685800" y="6543675"/>
+            <a:ext cx="3048000" cy="152400"/>
           </a:xfrm>
           <a:prstGeom xmlns:a="http://schemas.openxmlformats.org/drawingml/2006/main" prst="rect">
             <a:avLst/>
@@ -4046,9 +4681,9 @@
           <a:lstStyle xmlns:a="http://schemas.openxmlformats.org/drawingml/2006/main"/>
           <a:p xmlns:a="http://schemas.openxmlformats.org/drawingml/2006/main">
             <a:pPr algn="l">
-              <a:defRPr sz="1350" b="0">
-                <a:solidFill>
-                  <a:srgbClr val="FFF8F0"/>
+              <a:defRPr sz="675" b="0">
+                <a:solidFill>
+                  <a:srgbClr val="6B6258"/>
                 </a:solidFill>
                 <a:latin typeface="Aptos"/>
                 <a:ea typeface="Aptos"/>
@@ -4056,104 +4691,7 @@
               </a:defRPr>
             </a:pPr>
             <a:r>
-              <a:rPr sz="1350" b="0">
-                <a:solidFill>
-                  <a:srgbClr val="FFF8F0"/>
-                </a:solidFill>
-                <a:latin typeface="Aptos"/>
-                <a:ea typeface="Aptos"/>
-                <a:cs typeface="Aptos"/>
-              </a:rPr>
-              <a:t>Ask Codex to draft the next brief.</a:t>
-            </a:r>
-          </a:p>
-        </p:txBody>
-      </p:sp>
-      <p:sp>
-        <p:nvSpPr>
-          <p:cNvPr id="7" name="">
-            <a:extLst xmlns:a="http://schemas.openxmlformats.org/drawingml/2006/main">
-              <a:ext uri="{FF2B5EF4-FFF2-40B4-BE49-F238E27FC236}">
-                <a16:creationId xmlns:a16="http://schemas.microsoft.com/office/drawing/2014/main" id="{B8A1BC37-3360-4DD2-A0F4-C3F8F4532EEC}"/>
-              </a:ext>
-            </a:extLst>
-          </p:cNvPr>
-          <p:cNvSpPr>
-            <a:spLocks xmlns:a="http://schemas.openxmlformats.org/drawingml/2006/main" noGrp="1"/>
-          </p:cNvSpPr>
-          <p:nvPr/>
-        </p:nvSpPr>
-        <p:spPr>
-          <a:xfrm xmlns:a="http://schemas.openxmlformats.org/drawingml/2006/main">
-            <a:off x="609600" y="6477000"/>
-            <a:ext cx="10972800" cy="9525"/>
-          </a:xfrm>
-          <a:prstGeom xmlns:a="http://schemas.openxmlformats.org/drawingml/2006/main" prst="rect">
-            <a:avLst/>
-          </a:prstGeom>
-          <a:solidFill xmlns:a="http://schemas.openxmlformats.org/drawingml/2006/main">
-            <a:srgbClr val="D6C8B8"/>
-          </a:solidFill>
-          <a:ln xmlns:a="http://schemas.openxmlformats.org/drawingml/2006/main" w="0">
-            <a:solidFill>
-              <a:srgbClr val="D6C8B8"/>
-            </a:solidFill>
-            <a:prstDash val="solid"/>
-          </a:ln>
-        </p:spPr>
-      </p:sp>
-      <p:sp>
-        <p:nvSpPr>
-          <p:cNvPr id="8" name="">
-            <a:extLst xmlns:a="http://schemas.openxmlformats.org/drawingml/2006/main">
-              <a:ext uri="{FF2B5EF4-FFF2-40B4-BE49-F238E27FC236}">
-                <a16:creationId xmlns:a16="http://schemas.microsoft.com/office/drawing/2014/main" id="{87546F99-CD9B-4436-99B5-7440FDD8F75B}"/>
-              </a:ext>
-            </a:extLst>
-          </p:cNvPr>
-          <p:cNvSpPr>
-            <a:spLocks xmlns:a="http://schemas.openxmlformats.org/drawingml/2006/main" noGrp="1"/>
-          </p:cNvSpPr>
-          <p:nvPr/>
-        </p:nvSpPr>
-        <p:spPr>
-          <a:xfrm xmlns:a="http://schemas.openxmlformats.org/drawingml/2006/main">
-            <a:off x="609600" y="6572250"/>
-            <a:ext cx="3048000" cy="171450"/>
-          </a:xfrm>
-          <a:prstGeom xmlns:a="http://schemas.openxmlformats.org/drawingml/2006/main" prst="rect">
-            <a:avLst/>
-          </a:prstGeom>
-          <a:solidFill xmlns:a="http://schemas.openxmlformats.org/drawingml/2006/main">
-            <a:srgbClr val="000000">
-              <a:alpha val="0"/>
-            </a:srgbClr>
-          </a:solidFill>
-          <a:ln xmlns:a="http://schemas.openxmlformats.org/drawingml/2006/main" w="0">
-            <a:solidFill>
-              <a:srgbClr val="000000">
-                <a:alpha val="0"/>
-              </a:srgbClr>
-            </a:solidFill>
-            <a:prstDash val="solid"/>
-          </a:ln>
-        </p:spPr>
-        <p:txBody>
-          <a:bodyPr xmlns:a="http://schemas.openxmlformats.org/drawingml/2006/main" lIns="0" tIns="0" rIns="0" bIns="0" anchor="t"/>
-          <a:lstStyle xmlns:a="http://schemas.openxmlformats.org/drawingml/2006/main"/>
-          <a:p xmlns:a="http://schemas.openxmlformats.org/drawingml/2006/main">
-            <a:pPr algn="l">
-              <a:defRPr sz="750" b="0">
-                <a:solidFill>
-                  <a:srgbClr val="6B6258"/>
-                </a:solidFill>
-                <a:latin typeface="Aptos"/>
-                <a:ea typeface="Aptos"/>
-                <a:cs typeface="Aptos"/>
-              </a:defRPr>
-            </a:pPr>
-            <a:r>
-              <a:rPr sz="750" b="0">
+              <a:rPr sz="675" b="0">
                 <a:solidFill>
                   <a:srgbClr val="6B6258"/>
                 </a:solidFill>
@@ -4168,22 +4706,22 @@
       </p:sp>
       <p:sp>
         <p:nvSpPr>
-          <p:cNvPr id="9" name="">
-            <a:extLst xmlns:a="http://schemas.openxmlformats.org/drawingml/2006/main">
-              <a:ext uri="{FF2B5EF4-FFF2-40B4-BE49-F238E27FC236}">
-                <a16:creationId xmlns:a16="http://schemas.microsoft.com/office/drawing/2014/main" id="{997472B2-6193-4606-9083-69169554BE6D}"/>
-              </a:ext>
-            </a:extLst>
-          </p:cNvPr>
-          <p:cNvSpPr>
-            <a:spLocks xmlns:a="http://schemas.openxmlformats.org/drawingml/2006/main" noGrp="1"/>
-          </p:cNvSpPr>
-          <p:nvPr/>
-        </p:nvSpPr>
-        <p:spPr>
-          <a:xfrm xmlns:a="http://schemas.openxmlformats.org/drawingml/2006/main">
-            <a:off x="10858500" y="6572250"/>
-            <a:ext cx="723900" cy="171450"/>
+          <p:cNvPr id="12" name="">
+            <a:extLst xmlns:a="http://schemas.openxmlformats.org/drawingml/2006/main">
+              <a:ext uri="{FF2B5EF4-FFF2-40B4-BE49-F238E27FC236}">
+                <a16:creationId xmlns:a16="http://schemas.microsoft.com/office/drawing/2014/main" id="{501B6748-8688-487E-A765-BF7E16636774}"/>
+              </a:ext>
+            </a:extLst>
+          </p:cNvPr>
+          <p:cNvSpPr>
+            <a:spLocks xmlns:a="http://schemas.openxmlformats.org/drawingml/2006/main" noGrp="1"/>
+          </p:cNvSpPr>
+          <p:nvPr/>
+        </p:nvSpPr>
+        <p:spPr>
+          <a:xfrm xmlns:a="http://schemas.openxmlformats.org/drawingml/2006/main">
+            <a:off x="10953750" y="6543675"/>
+            <a:ext cx="571500" cy="152400"/>
           </a:xfrm>
           <a:prstGeom xmlns:a="http://schemas.openxmlformats.org/drawingml/2006/main" prst="rect">
             <a:avLst/>
@@ -4207,7 +4745,7 @@
           <a:lstStyle xmlns:a="http://schemas.openxmlformats.org/drawingml/2006/main"/>
           <a:p xmlns:a="http://schemas.openxmlformats.org/drawingml/2006/main">
             <a:pPr algn="r">
-              <a:defRPr sz="750" b="0">
+              <a:defRPr sz="675" b="0">
                 <a:solidFill>
                   <a:srgbClr val="6B6258"/>
                 </a:solidFill>
@@ -4217,7 +4755,7 @@
               </a:defRPr>
             </a:pPr>
             <a:r>
-              <a:rPr sz="750" b="0">
+              <a:rPr sz="675" b="0">
                 <a:solidFill>
                   <a:srgbClr val="6B6258"/>
                 </a:solidFill>
@@ -4233,7 +4771,7 @@
     </p:spTree>
     <p:extLst>
       <p:ext uri="{BB962C8B-B14F-4D97-AF65-F5344CB8AC3E}">
-        <p14:creationId xmlns:p14="http://schemas.microsoft.com/office/powerpoint/2010/main" val="856678084"/>
+        <p14:creationId xmlns:p14="http://schemas.microsoft.com/office/powerpoint/2010/main" val="1439308246"/>
       </p:ext>
     </p:extLst>
   </p:cSld>
@@ -4298,12 +4836,58 @@
         <a:solidFill>
           <a:schemeClr val="phClr"/>
         </a:solidFill>
-        <a:solidFill>
-          <a:schemeClr val="dk1"/>
-        </a:solidFill>
-        <a:solidFill>
-          <a:schemeClr val="accent1"/>
-        </a:solidFill>
+        <a:gradFill>
+          <a:gsLst>
+            <a:gs pos="0">
+              <a:schemeClr val="phClr">
+                <a:tint val="67000"/>
+                <a:lumMod val="110000"/>
+                <a:satMod val="105000"/>
+              </a:schemeClr>
+            </a:gs>
+            <a:gs pos="50000">
+              <a:schemeClr val="phClr">
+                <a:tint val="73000"/>
+                <a:lumMod val="105000"/>
+                <a:satMod val="103000"/>
+              </a:schemeClr>
+            </a:gs>
+            <a:gs pos="100000">
+              <a:schemeClr val="phClr">
+                <a:tint val="81000"/>
+                <a:lumMod val="105000"/>
+                <a:satMod val="109000"/>
+              </a:schemeClr>
+            </a:gs>
+          </a:gsLst>
+          <a:lin ang="5400000" scaled="0"/>
+        </a:gradFill>
+        <a:gradFill>
+          <a:gsLst>
+            <a:gs pos="0">
+              <a:schemeClr val="phClr">
+                <a:tint val="94000"/>
+                <a:lumMod val="102000"/>
+                <a:satMod val="103000"/>
+              </a:schemeClr>
+            </a:gs>
+            <a:gs pos="50000">
+              <a:schemeClr val="phClr">
+                <a:shade val="100000"/>
+                <a:lumMod val="100000"/>
+                <a:satMod val="110000"/>
+              </a:schemeClr>
+            </a:gs>
+            <a:gs pos="100000">
+              <a:schemeClr val="phClr">
+                <a:shade val="78000"/>
+                <a:lumMod val="99000"/>
+                <a:satMod val="120000"/>
+              </a:schemeClr>
+            </a:gs>
+          </a:gsLst>
+          <a:lin ang="5400000" scaled="0"/>
+        </a:gradFill>
       </a:fillStyleLst>
       <a:lnStyleLst>
         <a:ln w="12700">

</xml_diff>